<commit_message>
fix(docs): fix slide 3 pipeline diagram overflowing off the slide
The 11-box pipeline diagram was laid out in a single row needing
~22.5in on a 13.33in-wide slide. Rebuilt as a two-row flowchart
(same box sizes/fonts, no shrinking) with a connector routing the
flow from the end of row 1 into the start of row 2, and moved the
test-string input box under its new Matcher position.
</commit_message>
<xml_diff>
--- a/docs/presentation.pptx
+++ b/docs/presentation.pptx
@@ -5270,13 +5270,13 @@
       </p:cxnSp>
       <p:sp>
         <p:nvSpPr>
-          <p:cNvPr id="5" name="Rectangle 4"/>
+          <p:cNvPr id="5" name="Rectangle 5"/>
           <p:cNvSpPr/>
           <p:nvPr/>
         </p:nvSpPr>
         <p:spPr>
           <a:xfrm>
-            <a:off x="457200" y="2011680"/>
+            <a:off x="457200" y="1188720"/>
             <a:ext cx="1691640" cy="731520"/>
           </a:xfrm>
           <a:prstGeom prst="rect">
@@ -5318,21 +5318,32 @@
                 </a:solidFill>
                 <a:latin typeface="Arial"/>
               </a:rPr>
-              <a:t>Pattern
-(text)</a:t>
-            </a:r>
-          </a:p>
-        </p:txBody>
-      </p:sp>
-      <p:sp>
-        <p:nvSpPr>
-          <p:cNvPr id="6" name="Rectangle 5"/>
+              <a:t>Pattern</a:t>
+            </a:r>
+          </a:p>
+          <a:p>
+            <a:pPr algn="ctr"/>
+            <a:r>
+              <a:rPr sz="1300">
+                <a:solidFill>
+                  <a:srgbClr val="000000"/>
+                </a:solidFill>
+                <a:latin typeface="Arial"/>
+              </a:rPr>
+              <a:t>(text)</a:t>
+            </a:r>
+          </a:p>
+        </p:txBody>
+      </p:sp>
+      <p:sp>
+        <p:nvSpPr>
+          <p:cNvPr id="6" name="Rectangle 6"/>
           <p:cNvSpPr/>
           <p:nvPr/>
         </p:nvSpPr>
         <p:spPr>
           <a:xfrm>
-            <a:off x="2468880" y="2011680"/>
+            <a:off x="2468880" y="1188720"/>
             <a:ext cx="1417320" cy="731520"/>
           </a:xfrm>
           <a:prstGeom prst="rect">
@@ -5381,13 +5392,13 @@
       </p:sp>
       <p:sp>
         <p:nvSpPr>
-          <p:cNvPr id="7" name="Rectangle 6"/>
+          <p:cNvPr id="7" name="Rectangle 7"/>
           <p:cNvSpPr/>
           <p:nvPr/>
         </p:nvSpPr>
         <p:spPr>
           <a:xfrm>
-            <a:off x="4206240" y="2011680"/>
+            <a:off x="4206240" y="1188720"/>
             <a:ext cx="1417320" cy="731520"/>
           </a:xfrm>
           <a:prstGeom prst="rect">
@@ -5436,13 +5447,13 @@
       </p:sp>
       <p:sp>
         <p:nvSpPr>
-          <p:cNvPr id="8" name="Rectangle 7"/>
+          <p:cNvPr id="8" name="Rectangle 8"/>
           <p:cNvSpPr/>
           <p:nvPr/>
         </p:nvSpPr>
         <p:spPr>
           <a:xfrm>
-            <a:off x="5943600" y="2011680"/>
+            <a:off x="5943600" y="1188720"/>
             <a:ext cx="1691640" cy="731520"/>
           </a:xfrm>
           <a:prstGeom prst="rect">
@@ -5484,21 +5495,32 @@
                 </a:solidFill>
                 <a:latin typeface="Arial"/>
               </a:rPr>
-              <a:t>Thompson's
-Construction</a:t>
-            </a:r>
-          </a:p>
-        </p:txBody>
-      </p:sp>
-      <p:sp>
-        <p:nvSpPr>
-          <p:cNvPr id="9" name="Rectangle 8"/>
+              <a:t>Thompson's</a:t>
+            </a:r>
+          </a:p>
+          <a:p>
+            <a:pPr algn="ctr"/>
+            <a:r>
+              <a:rPr sz="1300">
+                <a:solidFill>
+                  <a:srgbClr val="000000"/>
+                </a:solidFill>
+                <a:latin typeface="Arial"/>
+              </a:rPr>
+              <a:t>Construction</a:t>
+            </a:r>
+          </a:p>
+        </p:txBody>
+      </p:sp>
+      <p:sp>
+        <p:nvSpPr>
+          <p:cNvPr id="9" name="Rectangle 9"/>
           <p:cNvSpPr/>
           <p:nvPr/>
         </p:nvSpPr>
         <p:spPr>
           <a:xfrm>
-            <a:off x="7955279" y="2011680"/>
+            <a:off x="7955280" y="1188720"/>
             <a:ext cx="1417320" cy="731520"/>
           </a:xfrm>
           <a:prstGeom prst="rect">
@@ -5547,13 +5569,13 @@
       </p:sp>
       <p:sp>
         <p:nvSpPr>
-          <p:cNvPr id="10" name="Rectangle 9"/>
+          <p:cNvPr id="10" name="Rectangle 10"/>
           <p:cNvSpPr/>
           <p:nvPr/>
         </p:nvSpPr>
         <p:spPr>
           <a:xfrm>
-            <a:off x="9692640" y="2011680"/>
+            <a:off x="9692640" y="1188720"/>
             <a:ext cx="1691640" cy="731520"/>
           </a:xfrm>
           <a:prstGeom prst="rect">
@@ -5595,21 +5617,212 @@
                 </a:solidFill>
                 <a:latin typeface="Arial"/>
               </a:rPr>
-              <a:t>Subset
-Construction</a:t>
-            </a:r>
-          </a:p>
-        </p:txBody>
-      </p:sp>
-      <p:sp>
-        <p:nvSpPr>
-          <p:cNvPr id="11" name="Rectangle 10"/>
+              <a:t>Subset</a:t>
+            </a:r>
+          </a:p>
+          <a:p>
+            <a:pPr algn="ctr"/>
+            <a:r>
+              <a:rPr sz="1300">
+                <a:solidFill>
+                  <a:srgbClr val="000000"/>
+                </a:solidFill>
+                <a:latin typeface="Arial"/>
+              </a:rPr>
+              <a:t>Construction</a:t>
+            </a:r>
+          </a:p>
+        </p:txBody>
+      </p:sp>
+      <p:cxnSp>
+        <p:nvCxnSpPr>
+          <p:cNvPr id="11" name="Connector 11"/>
+          <p:cNvCxnSpPr/>
+          <p:nvPr/>
+        </p:nvCxnSpPr>
+        <p:spPr>
+          <a:xfrm>
+            <a:off x="2148840" y="1554480"/>
+            <a:ext cx="320040" cy="0"/>
+          </a:xfrm>
+          <a:prstGeom prst="line">
+            <a:avLst/>
+          </a:prstGeom>
+          <a:ln w="15875">
+            <a:solidFill>
+              <a:srgbClr val="000000"/>
+            </a:solidFill>
+            <a:tailEnd type="triangle" w="med" len="med"/>
+          </a:ln>
+        </p:spPr>
+        <p:style>
+          <a:lnRef idx="2">
+            <a:schemeClr val="accent1"/>
+          </a:lnRef>
+          <a:fillRef idx="0">
+            <a:schemeClr val="accent1"/>
+          </a:fillRef>
+          <a:effectRef idx="1">
+            <a:schemeClr val="accent1"/>
+          </a:effectRef>
+          <a:fontRef idx="minor">
+            <a:schemeClr val="tx1"/>
+          </a:fontRef>
+        </p:style>
+      </p:cxnSp>
+      <p:cxnSp>
+        <p:nvCxnSpPr>
+          <p:cNvPr id="12" name="Connector 12"/>
+          <p:cNvCxnSpPr/>
+          <p:nvPr/>
+        </p:nvCxnSpPr>
+        <p:spPr>
+          <a:xfrm>
+            <a:off x="3886200" y="1554480"/>
+            <a:ext cx="320040" cy="0"/>
+          </a:xfrm>
+          <a:prstGeom prst="line">
+            <a:avLst/>
+          </a:prstGeom>
+          <a:ln w="15875">
+            <a:solidFill>
+              <a:srgbClr val="000000"/>
+            </a:solidFill>
+            <a:tailEnd type="triangle" w="med" len="med"/>
+          </a:ln>
+        </p:spPr>
+        <p:style>
+          <a:lnRef idx="2">
+            <a:schemeClr val="accent1"/>
+          </a:lnRef>
+          <a:fillRef idx="0">
+            <a:schemeClr val="accent1"/>
+          </a:fillRef>
+          <a:effectRef idx="1">
+            <a:schemeClr val="accent1"/>
+          </a:effectRef>
+          <a:fontRef idx="minor">
+            <a:schemeClr val="tx1"/>
+          </a:fontRef>
+        </p:style>
+      </p:cxnSp>
+      <p:cxnSp>
+        <p:nvCxnSpPr>
+          <p:cNvPr id="13" name="Connector 13"/>
+          <p:cNvCxnSpPr/>
+          <p:nvPr/>
+        </p:nvCxnSpPr>
+        <p:spPr>
+          <a:xfrm>
+            <a:off x="5623560" y="1554480"/>
+            <a:ext cx="320040" cy="0"/>
+          </a:xfrm>
+          <a:prstGeom prst="line">
+            <a:avLst/>
+          </a:prstGeom>
+          <a:ln w="15875">
+            <a:solidFill>
+              <a:srgbClr val="000000"/>
+            </a:solidFill>
+            <a:tailEnd type="triangle" w="med" len="med"/>
+          </a:ln>
+        </p:spPr>
+        <p:style>
+          <a:lnRef idx="2">
+            <a:schemeClr val="accent1"/>
+          </a:lnRef>
+          <a:fillRef idx="0">
+            <a:schemeClr val="accent1"/>
+          </a:fillRef>
+          <a:effectRef idx="1">
+            <a:schemeClr val="accent1"/>
+          </a:effectRef>
+          <a:fontRef idx="minor">
+            <a:schemeClr val="tx1"/>
+          </a:fontRef>
+        </p:style>
+      </p:cxnSp>
+      <p:cxnSp>
+        <p:nvCxnSpPr>
+          <p:cNvPr id="14" name="Connector 14"/>
+          <p:cNvCxnSpPr/>
+          <p:nvPr/>
+        </p:nvCxnSpPr>
+        <p:spPr>
+          <a:xfrm>
+            <a:off x="7635240" y="1554480"/>
+            <a:ext cx="320040" cy="0"/>
+          </a:xfrm>
+          <a:prstGeom prst="line">
+            <a:avLst/>
+          </a:prstGeom>
+          <a:ln w="15875">
+            <a:solidFill>
+              <a:srgbClr val="000000"/>
+            </a:solidFill>
+            <a:tailEnd type="triangle" w="med" len="med"/>
+          </a:ln>
+        </p:spPr>
+        <p:style>
+          <a:lnRef idx="2">
+            <a:schemeClr val="accent1"/>
+          </a:lnRef>
+          <a:fillRef idx="0">
+            <a:schemeClr val="accent1"/>
+          </a:fillRef>
+          <a:effectRef idx="1">
+            <a:schemeClr val="accent1"/>
+          </a:effectRef>
+          <a:fontRef idx="minor">
+            <a:schemeClr val="tx1"/>
+          </a:fontRef>
+        </p:style>
+      </p:cxnSp>
+      <p:cxnSp>
+        <p:nvCxnSpPr>
+          <p:cNvPr id="15" name="Connector 15"/>
+          <p:cNvCxnSpPr/>
+          <p:nvPr/>
+        </p:nvCxnSpPr>
+        <p:spPr>
+          <a:xfrm>
+            <a:off x="9372600" y="1554480"/>
+            <a:ext cx="320040" cy="0"/>
+          </a:xfrm>
+          <a:prstGeom prst="line">
+            <a:avLst/>
+          </a:prstGeom>
+          <a:ln w="15875">
+            <a:solidFill>
+              <a:srgbClr val="000000"/>
+            </a:solidFill>
+            <a:tailEnd type="triangle" w="med" len="med"/>
+          </a:ln>
+        </p:spPr>
+        <p:style>
+          <a:lnRef idx="2">
+            <a:schemeClr val="accent1"/>
+          </a:lnRef>
+          <a:fillRef idx="0">
+            <a:schemeClr val="accent1"/>
+          </a:fillRef>
+          <a:effectRef idx="1">
+            <a:schemeClr val="accent1"/>
+          </a:effectRef>
+          <a:fontRef idx="minor">
+            <a:schemeClr val="tx1"/>
+          </a:fontRef>
+        </p:style>
+      </p:cxnSp>
+      <p:sp>
+        <p:nvSpPr>
+          <p:cNvPr id="16" name="Rectangle 16"/>
           <p:cNvSpPr/>
           <p:nvPr/>
         </p:nvSpPr>
         <p:spPr>
           <a:xfrm>
-            <a:off x="11704320" y="2011680"/>
+            <a:off x="457200" y="2697480"/>
             <a:ext cx="1417320" cy="731520"/>
           </a:xfrm>
           <a:prstGeom prst="rect">
@@ -5658,13 +5871,13 @@
       </p:sp>
       <p:sp>
         <p:nvSpPr>
-          <p:cNvPr id="12" name="Rectangle 11"/>
+          <p:cNvPr id="17" name="Rectangle 17"/>
           <p:cNvSpPr/>
           <p:nvPr/>
         </p:nvSpPr>
         <p:spPr>
           <a:xfrm>
-            <a:off x="13441680" y="2011680"/>
+            <a:off x="2194560" y="2697480"/>
             <a:ext cx="1691640" cy="731520"/>
           </a:xfrm>
           <a:prstGeom prst="rect">
@@ -5706,21 +5919,32 @@
                 </a:solidFill>
                 <a:latin typeface="Arial"/>
               </a:rPr>
-              <a:t>Moore's
-Minimization</a:t>
-            </a:r>
-          </a:p>
-        </p:txBody>
-      </p:sp>
-      <p:sp>
-        <p:nvSpPr>
-          <p:cNvPr id="13" name="Rectangle 12"/>
+              <a:t>Moore's</a:t>
+            </a:r>
+          </a:p>
+          <a:p>
+            <a:pPr algn="ctr"/>
+            <a:r>
+              <a:rPr sz="1300">
+                <a:solidFill>
+                  <a:srgbClr val="000000"/>
+                </a:solidFill>
+                <a:latin typeface="Arial"/>
+              </a:rPr>
+              <a:t>Minimization</a:t>
+            </a:r>
+          </a:p>
+        </p:txBody>
+      </p:sp>
+      <p:sp>
+        <p:nvSpPr>
+          <p:cNvPr id="18" name="Rectangle 18"/>
           <p:cNvSpPr/>
           <p:nvPr/>
         </p:nvSpPr>
         <p:spPr>
           <a:xfrm>
-            <a:off x="15453360" y="2011680"/>
+            <a:off x="4206240" y="2697480"/>
             <a:ext cx="1417320" cy="731520"/>
           </a:xfrm>
           <a:prstGeom prst="rect">
@@ -5769,13 +5993,13 @@
       </p:sp>
       <p:sp>
         <p:nvSpPr>
-          <p:cNvPr id="14" name="Rectangle 13"/>
+          <p:cNvPr id="19" name="Rectangle 19"/>
           <p:cNvSpPr/>
           <p:nvPr/>
         </p:nvSpPr>
         <p:spPr>
           <a:xfrm>
-            <a:off x="17190720" y="2011680"/>
+            <a:off x="5943600" y="2697480"/>
             <a:ext cx="1417320" cy="731520"/>
           </a:xfrm>
           <a:prstGeom prst="rect">
@@ -5824,13 +6048,13 @@
       </p:sp>
       <p:sp>
         <p:nvSpPr>
-          <p:cNvPr id="15" name="Rectangle 14"/>
+          <p:cNvPr id="20" name="Rectangle 20"/>
           <p:cNvSpPr/>
           <p:nvPr/>
         </p:nvSpPr>
         <p:spPr>
           <a:xfrm>
-            <a:off x="18928080" y="2011680"/>
+            <a:off x="7680960" y="2697480"/>
             <a:ext cx="1691640" cy="731520"/>
           </a:xfrm>
           <a:prstGeom prst="rect">
@@ -5872,21 +6096,32 @@
                 </a:solidFill>
                 <a:latin typeface="Arial"/>
               </a:rPr>
-              <a:t>match /
-no-match</a:t>
+              <a:t>match /</a:t>
+            </a:r>
+          </a:p>
+          <a:p>
+            <a:pPr algn="ctr"/>
+            <a:r>
+              <a:rPr sz="1300">
+                <a:solidFill>
+                  <a:srgbClr val="000000"/>
+                </a:solidFill>
+                <a:latin typeface="Arial"/>
+              </a:rPr>
+              <a:t>no-match</a:t>
             </a:r>
           </a:p>
         </p:txBody>
       </p:sp>
       <p:cxnSp>
         <p:nvCxnSpPr>
-          <p:cNvPr id="16" name="Connector 15"/>
+          <p:cNvPr id="21" name="Connector 21"/>
           <p:cNvCxnSpPr/>
           <p:nvPr/>
         </p:nvCxnSpPr>
         <p:spPr>
           <a:xfrm>
-            <a:off x="2148840" y="2377440"/>
+            <a:off x="1874520" y="3063240"/>
             <a:ext cx="320040" cy="0"/>
           </a:xfrm>
           <a:prstGeom prst="line">
@@ -5916,13 +6151,13 @@
       </p:cxnSp>
       <p:cxnSp>
         <p:nvCxnSpPr>
-          <p:cNvPr id="17" name="Connector 16"/>
+          <p:cNvPr id="22" name="Connector 22"/>
           <p:cNvCxnSpPr/>
           <p:nvPr/>
         </p:nvCxnSpPr>
         <p:spPr>
           <a:xfrm>
-            <a:off x="3886200" y="2377440"/>
+            <a:off x="3886200" y="3063240"/>
             <a:ext cx="320040" cy="0"/>
           </a:xfrm>
           <a:prstGeom prst="line">
@@ -5952,14 +6187,14 @@
       </p:cxnSp>
       <p:cxnSp>
         <p:nvCxnSpPr>
-          <p:cNvPr id="18" name="Connector 17"/>
+          <p:cNvPr id="23" name="Connector 23"/>
           <p:cNvCxnSpPr/>
           <p:nvPr/>
         </p:nvCxnSpPr>
         <p:spPr>
           <a:xfrm>
-            <a:off x="5623559" y="2377440"/>
-            <a:ext cx="320041" cy="0"/>
+            <a:off x="5623560" y="3063240"/>
+            <a:ext cx="320040" cy="0"/>
           </a:xfrm>
           <a:prstGeom prst="line">
             <a:avLst/>
@@ -5988,14 +6223,14 @@
       </p:cxnSp>
       <p:cxnSp>
         <p:nvCxnSpPr>
-          <p:cNvPr id="19" name="Connector 18"/>
+          <p:cNvPr id="24" name="Connector 24"/>
           <p:cNvCxnSpPr/>
           <p:nvPr/>
         </p:nvCxnSpPr>
         <p:spPr>
           <a:xfrm>
-            <a:off x="7635240" y="2377440"/>
-            <a:ext cx="320039" cy="0"/>
+            <a:off x="7360920" y="3063240"/>
+            <a:ext cx="320040" cy="0"/>
           </a:xfrm>
           <a:prstGeom prst="line">
             <a:avLst/>
@@ -6024,14 +6259,14 @@
       </p:cxnSp>
       <p:cxnSp>
         <p:nvCxnSpPr>
-          <p:cNvPr id="20" name="Connector 19"/>
+          <p:cNvPr id="25" name="Connector 25"/>
           <p:cNvCxnSpPr/>
           <p:nvPr/>
         </p:nvCxnSpPr>
         <p:spPr>
           <a:xfrm>
-            <a:off x="9372600" y="2377440"/>
-            <a:ext cx="320040" cy="0"/>
+            <a:off x="10538460" y="1920240"/>
+            <a:ext cx="0" cy="388620"/>
           </a:xfrm>
           <a:prstGeom prst="line">
             <a:avLst/>
@@ -6040,7 +6275,6 @@
             <a:solidFill>
               <a:srgbClr val="000000"/>
             </a:solidFill>
-            <a:tailEnd type="triangle" w="med" len="med"/>
           </a:ln>
         </p:spPr>
         <p:style>
@@ -6060,14 +6294,14 @@
       </p:cxnSp>
       <p:cxnSp>
         <p:nvCxnSpPr>
-          <p:cNvPr id="21" name="Connector 20"/>
+          <p:cNvPr id="26" name="Connector 26"/>
           <p:cNvCxnSpPr/>
           <p:nvPr/>
         </p:nvCxnSpPr>
         <p:spPr>
           <a:xfrm>
-            <a:off x="11384280" y="2377440"/>
-            <a:ext cx="320040" cy="0"/>
+            <a:off x="1165860" y="2308860"/>
+            <a:ext cx="9372600" cy="0"/>
           </a:xfrm>
           <a:prstGeom prst="line">
             <a:avLst/>
@@ -6076,7 +6310,6 @@
             <a:solidFill>
               <a:srgbClr val="000000"/>
             </a:solidFill>
-            <a:tailEnd type="triangle" w="med" len="med"/>
           </a:ln>
         </p:spPr>
         <p:style>
@@ -6096,14 +6329,14 @@
       </p:cxnSp>
       <p:cxnSp>
         <p:nvCxnSpPr>
-          <p:cNvPr id="22" name="Connector 21"/>
+          <p:cNvPr id="27" name="Connector 27"/>
           <p:cNvCxnSpPr/>
           <p:nvPr/>
         </p:nvCxnSpPr>
         <p:spPr>
           <a:xfrm>
-            <a:off x="13121640" y="2377440"/>
-            <a:ext cx="320040" cy="0"/>
+            <a:off x="1165860" y="2308860"/>
+            <a:ext cx="0" cy="388620"/>
           </a:xfrm>
           <a:prstGeom prst="line">
             <a:avLst/>
@@ -6130,123 +6363,15 @@
           </a:fontRef>
         </p:style>
       </p:cxnSp>
-      <p:cxnSp>
-        <p:nvCxnSpPr>
-          <p:cNvPr id="23" name="Connector 22"/>
-          <p:cNvCxnSpPr/>
-          <p:nvPr/>
-        </p:nvCxnSpPr>
-        <p:spPr>
-          <a:xfrm>
-            <a:off x="15133320" y="2377440"/>
-            <a:ext cx="320040" cy="0"/>
-          </a:xfrm>
-          <a:prstGeom prst="line">
-            <a:avLst/>
-          </a:prstGeom>
-          <a:ln w="15875">
-            <a:solidFill>
-              <a:srgbClr val="000000"/>
-            </a:solidFill>
-            <a:tailEnd type="triangle" w="med" len="med"/>
-          </a:ln>
-        </p:spPr>
-        <p:style>
-          <a:lnRef idx="2">
-            <a:schemeClr val="accent1"/>
-          </a:lnRef>
-          <a:fillRef idx="0">
-            <a:schemeClr val="accent1"/>
-          </a:fillRef>
-          <a:effectRef idx="1">
-            <a:schemeClr val="accent1"/>
-          </a:effectRef>
-          <a:fontRef idx="minor">
-            <a:schemeClr val="tx1"/>
-          </a:fontRef>
-        </p:style>
-      </p:cxnSp>
-      <p:cxnSp>
-        <p:nvCxnSpPr>
-          <p:cNvPr id="24" name="Connector 23"/>
-          <p:cNvCxnSpPr/>
-          <p:nvPr/>
-        </p:nvCxnSpPr>
-        <p:spPr>
-          <a:xfrm>
-            <a:off x="16870680" y="2377440"/>
-            <a:ext cx="320040" cy="0"/>
-          </a:xfrm>
-          <a:prstGeom prst="line">
-            <a:avLst/>
-          </a:prstGeom>
-          <a:ln w="15875">
-            <a:solidFill>
-              <a:srgbClr val="000000"/>
-            </a:solidFill>
-            <a:tailEnd type="triangle" w="med" len="med"/>
-          </a:ln>
-        </p:spPr>
-        <p:style>
-          <a:lnRef idx="2">
-            <a:schemeClr val="accent1"/>
-          </a:lnRef>
-          <a:fillRef idx="0">
-            <a:schemeClr val="accent1"/>
-          </a:fillRef>
-          <a:effectRef idx="1">
-            <a:schemeClr val="accent1"/>
-          </a:effectRef>
-          <a:fontRef idx="minor">
-            <a:schemeClr val="tx1"/>
-          </a:fontRef>
-        </p:style>
-      </p:cxnSp>
-      <p:cxnSp>
-        <p:nvCxnSpPr>
-          <p:cNvPr id="25" name="Connector 24"/>
-          <p:cNvCxnSpPr/>
-          <p:nvPr/>
-        </p:nvCxnSpPr>
-        <p:spPr>
-          <a:xfrm>
-            <a:off x="18608040" y="2377440"/>
-            <a:ext cx="320040" cy="0"/>
-          </a:xfrm>
-          <a:prstGeom prst="line">
-            <a:avLst/>
-          </a:prstGeom>
-          <a:ln w="15875">
-            <a:solidFill>
-              <a:srgbClr val="000000"/>
-            </a:solidFill>
-            <a:tailEnd type="triangle" w="med" len="med"/>
-          </a:ln>
-        </p:spPr>
-        <p:style>
-          <a:lnRef idx="2">
-            <a:schemeClr val="accent1"/>
-          </a:lnRef>
-          <a:fillRef idx="0">
-            <a:schemeClr val="accent1"/>
-          </a:fillRef>
-          <a:effectRef idx="1">
-            <a:schemeClr val="accent1"/>
-          </a:effectRef>
-          <a:fontRef idx="minor">
-            <a:schemeClr val="tx1"/>
-          </a:fontRef>
-        </p:style>
-      </p:cxnSp>
-      <p:sp>
-        <p:nvSpPr>
-          <p:cNvPr id="26" name="Rectangle 25"/>
+      <p:sp>
+        <p:nvSpPr>
+          <p:cNvPr id="28" name="Rectangle 28"/>
           <p:cNvSpPr/>
           <p:nvPr/>
         </p:nvSpPr>
         <p:spPr>
           <a:xfrm>
-            <a:off x="17213580" y="3474720"/>
+            <a:off x="5966460" y="3931920"/>
             <a:ext cx="1371600" cy="640080"/>
           </a:xfrm>
           <a:prstGeom prst="rect">
@@ -6288,22 +6413,33 @@
                 </a:solidFill>
                 <a:latin typeface="Arial"/>
               </a:rPr>
-              <a:t>Test string
-(text)</a:t>
+              <a:t>Test string</a:t>
+            </a:r>
+          </a:p>
+          <a:p>
+            <a:pPr algn="ctr"/>
+            <a:r>
+              <a:rPr sz="1300">
+                <a:solidFill>
+                  <a:srgbClr val="000000"/>
+                </a:solidFill>
+                <a:latin typeface="Arial"/>
+              </a:rPr>
+              <a:t>(text)</a:t>
             </a:r>
           </a:p>
         </p:txBody>
       </p:sp>
       <p:cxnSp>
         <p:nvCxnSpPr>
-          <p:cNvPr id="27" name="Connector 26"/>
+          <p:cNvPr id="29" name="Connector 29"/>
           <p:cNvCxnSpPr/>
           <p:nvPr/>
         </p:nvCxnSpPr>
         <p:spPr>
           <a:xfrm flipV="1">
-            <a:off x="17899380" y="2743200"/>
-            <a:ext cx="0" cy="731520"/>
+            <a:off x="6652260" y="3429000"/>
+            <a:ext cx="0" cy="502920"/>
           </a:xfrm>
           <a:prstGeom prst="line">
             <a:avLst/>
@@ -6332,14 +6468,14 @@
       </p:cxnSp>
       <p:sp>
         <p:nvSpPr>
-          <p:cNvPr id="28" name="TextBox 27"/>
+          <p:cNvPr id="30" name="TextBox 27"/>
           <p:cNvSpPr txBox="1"/>
           <p:nvPr/>
         </p:nvSpPr>
         <p:spPr>
           <a:xfrm>
-            <a:off x="457200" y="4206240"/>
-            <a:ext cx="11247120" cy="4754880"/>
+            <a:off x="457200" y="4754880"/>
+            <a:ext cx="10789920" cy="1600200"/>
           </a:xfrm>
           <a:prstGeom prst="rect">
             <a:avLst/>

</xml_diff>

<commit_message>
docs: final pass on slides and review prep plan
Fixed slide 10's stale test count (still said 93/7 after the docs
were corrected earlier) and added two short notes explaining in
plain language how the TypeScript and C++ suites actually check
the engine. Audited all 12 slides for overflow, bullet count and
stale facts; nothing else was wrong.

Also rewrote prose throughout the deck and the review prep plan to
read more naturally, mainly by cutting the repeated em-dash habit
in favor of ordinary punctuation. No factual content changed.
</commit_message>
<xml_diff>
--- a/docs/presentation.pptx
+++ b/docs/presentation.pptx
@@ -653,7 +653,7 @@
           <a:lstStyle/>
           <a:p>
             <a:r>
-              <a:t>No demo. These are deliberate scope decisions — say so plainly, don't apologize for them.</a:t>
+              <a:t>No demo. These are deliberate scope decisions, so say that plainly and don't apologize for them.</a:t>
             </a:r>
           </a:p>
           <a:p>
@@ -1148,7 +1148,7 @@
           <a:lstStyle/>
           <a:p>
             <a:r>
-              <a:t>No image here — the min-DFA diagram is on the next slide (matching). Say the fixpoint rule clearly, it's a likely question.</a:t>
+              <a:t>No image here, the min-DFA diagram is on the next slide (matching). Say the fixpoint rule clearly since it's a likely question.</a:t>
             </a:r>
           </a:p>
         </p:txBody>
@@ -4434,7 +4434,7 @@
                 </a:solidFill>
                 <a:latin typeface="Arial"/>
               </a:rPr>
-              <a:t>BCSE307L Compiler Design  —  Vignesh P C, Ujwal</a:t>
+              <a:t>BCSE307L Compiler Design, by Vignesh P C and Ujwal</a:t>
             </a:r>
           </a:p>
         </p:txBody>
@@ -4603,7 +4603,7 @@
               </a:defRPr>
             </a:pPr>
             <a:r>
-              <a:t>•  Differential testing: thousands of random (pattern, input) pairs vs std::regex (C++) and native RegExp (TypeScript) — both independent implementations must agree.</a:t>
+              <a:t>•  Differential testing: thousands of random (pattern, input) pairs checked against std::regex in C++ and native RegExp in TypeScript. Both independent implementations have to agree.</a:t>
             </a:r>
           </a:p>
           <a:p>
@@ -4619,7 +4619,51 @@
               </a:defRPr>
             </a:pPr>
             <a:r>
-              <a:t>•  Measured today: 93 TypeScript tests / 7 files; 4,608 C++ assertions / 41 cases.</a:t>
+              <a:t>•  Measured today: 125 TypeScript tests / 10 files; 4,608 C++ assertions / 41 cases.</a:t>
+            </a:r>
+          </a:p>
+          <a:p>
+            <a:pPr marL="457200">
+              <a:spcAft>
+                <a:spcPts val="800"/>
+              </a:spcAft>
+              <a:defRPr sz="1500" i="1">
+                <a:solidFill>
+                  <a:srgbClr val="606060"/>
+                </a:solidFill>
+                <a:latin typeface="Arial"/>
+              </a:defRPr>
+            </a:pPr>
+            <a:r>
+              <a:rPr sz="1500" i="1">
+                <a:solidFill>
+                  <a:srgbClr val="606060"/>
+                </a:solidFill>
+                <a:latin typeface="Arial"/>
+              </a:rPr>
+              <a:t>–  How: npm test feeds each known pattern through the real pipeline and checks the answer is exactly right.</a:t>
+            </a:r>
+          </a:p>
+          <a:p>
+            <a:pPr marL="457200">
+              <a:spcAft>
+                <a:spcPts val="800"/>
+              </a:spcAft>
+              <a:defRPr sz="1500" i="1">
+                <a:solidFill>
+                  <a:srgbClr val="606060"/>
+                </a:solidFill>
+                <a:latin typeface="Arial"/>
+              </a:defRPr>
+            </a:pPr>
+            <a:r>
+              <a:rPr sz="1500" i="1">
+                <a:solidFill>
+                  <a:srgbClr val="606060"/>
+                </a:solidFill>
+                <a:latin typeface="Arial"/>
+              </a:rPr>
+              <a:t>–  How: ./engine_tests runs the same checks ported to C++, one assertion per fact checked (e.g. an exact state count).</a:t>
             </a:r>
           </a:p>
           <a:p>
@@ -4804,7 +4848,7 @@
               </a:defRPr>
             </a:pPr>
             <a:r>
-              <a:t>•  Direct method (firstpos/followpos) not built — we chose the indirect Thompson + subset-construction route on purpose.</a:t>
+              <a:t>•  Direct method (firstpos/followpos) not built. We chose the indirect Thompson-plus-subset-construction route on purpose.</a:t>
             </a:r>
           </a:p>
           <a:p>
@@ -4820,7 +4864,7 @@
               </a:defRPr>
             </a:pPr>
             <a:r>
-              <a:t>•  Hopcroft's minimization not built — Moore's is simpler to implement and explain fully; Hopcroft's is a planned, gated upgrade.</a:t>
+              <a:t>•  Hopcroft's minimization not built. Moore's is simpler to implement and explain fully, and Hopcroft's stays a planned, gated upgrade.</a:t>
             </a:r>
           </a:p>
           <a:p>
@@ -4836,7 +4880,7 @@
               </a:defRPr>
             </a:pPr>
             <a:r>
-              <a:t>•  No dedicated DFA state-count guard against subset construction's exponential worst case — the 500-char pattern cap bounds it indirectly, not tightly.</a:t>
+              <a:t>•  No dedicated DFA state-count guard against subset construction's exponential worst case. The 500-char pattern cap bounds it indirectly, not tightly.</a:t>
             </a:r>
           </a:p>
         </p:txBody>
@@ -5101,7 +5145,7 @@
               </a:defRPr>
             </a:pPr>
             <a:r>
-              <a:t>•  Given a regular expression and a string, decide whether the string matches — without using a built-in regex engine.</a:t>
+              <a:t>•  Given a regular expression and a string, decide whether the string matches, without reaching for a built-in regex engine.</a:t>
             </a:r>
           </a:p>
           <a:p>
@@ -5117,7 +5161,7 @@
               </a:defRPr>
             </a:pPr>
             <a:r>
-              <a:t>•  Build the actual compiler pipeline that answers this: parser, NFA, DFA, minimization, matcher — not a lookup into an existing library.</a:t>
+              <a:t>•  Build the actual compiler pipeline that answers this: parser, NFA, DFA, minimization and matcher, not a lookup into an existing library.</a:t>
             </a:r>
           </a:p>
           <a:p>
@@ -6516,7 +6560,7 @@
               </a:defRPr>
             </a:pPr>
             <a:r>
-              <a:t>•  Implemented twice: a TypeScript prototype and a C++20 engine compiled to WebAssembly — the browser runs the C++/WASM build.</a:t>
+              <a:t>•  Implemented twice: a TypeScript prototype and a C++20 engine compiled to WebAssembly, and the browser runs the C++/WASM build.</a:t>
             </a:r>
           </a:p>
           <a:p>
@@ -6717,7 +6761,7 @@
               </a:defRPr>
             </a:pPr>
             <a:r>
-              <a:t>•  Precedence by call depth: parseRegex calls parseTerm calls parseFactor calls parseAtom — deepest binds tightest, no table.</a:t>
+              <a:t>•  Precedence by call depth: parseRegex calls parseTerm calls parseFactor calls parseAtom, so the deepest call binds tightest. No precedence table needed.</a:t>
             </a:r>
           </a:p>
           <a:p>
@@ -6733,7 +6777,7 @@
               </a:defRPr>
             </a:pPr>
             <a:r>
-              <a:t>•  No separate lexer — every token is one character.</a:t>
+              <a:t>•  No separate lexer: every token is just one character.</a:t>
             </a:r>
           </a:p>
         </p:txBody>
@@ -7497,7 +7541,7 @@
               </a:defRPr>
             </a:pPr>
             <a:r>
-              <a:t>•  Stop at a fixpoint — a full pass with zero splits.</a:t>
+              <a:t>•  Stop at a fixpoint, meaning a full pass with zero splits.</a:t>
             </a:r>
           </a:p>
           <a:p>
@@ -7757,7 +7801,7 @@
                 </a:solidFill>
                 <a:latin typeface="Arial"/>
               </a:rPr>
-              <a:t>Fig. 4a. babb — ends in abb → Accepted.</a:t>
+              <a:t>Fig. 4a. babb ends in abb: Accepted.</a:t>
             </a:r>
           </a:p>
         </p:txBody>
@@ -7816,7 +7860,7 @@
                 </a:solidFill>
                 <a:latin typeface="Arial"/>
               </a:rPr>
-              <a:t>Fig. 4b. abab — ends in bab, not abb → Rejected.</a:t>
+              <a:t>Fig. 4b. abab ends in bab, not abb: Rejected.</a:t>
             </a:r>
           </a:p>
         </p:txBody>
@@ -7985,7 +8029,7 @@
               </a:defRPr>
             </a:pPr>
             <a:r>
-              <a:t>•  All four tabs have real, stage-specific playback — not just min-DFA scrubbing.</a:t>
+              <a:t>•  All four tabs have real, stage-specific playback, not just min-DFA scrubbing.</a:t>
             </a:r>
           </a:p>
           <a:p>

</xml_diff>

<commit_message>
fix(docs): slide 3 overflow, stale slide 10 count, natural prose (#59)
* fix(docs): fix slide 3 pipeline diagram overflowing off the slide

The 11-box pipeline diagram was laid out in a single row needing
~22.5in on a 13.33in-wide slide. Rebuilt as a two-row flowchart
(same box sizes/fonts, no shrinking) with a connector routing the
flow from the end of row 1 into the start of row 2, and moved the
test-string input box under its new Matcher position.

* docs: final pass on slides and review prep plan

Fixed slide 10's stale test count (still said 93/7 after the docs
were corrected earlier) and added two short notes explaining in
plain language how the TypeScript and C++ suites actually check
the engine. Audited all 12 slides for overflow, bullet count and
stale facts; nothing else was wrong.

Also rewrote prose throughout the deck and the review prep plan to
read more naturally, mainly by cutting the repeated em-dash habit
in favor of ordinary punctuation. No factual content changed.
</commit_message>
<xml_diff>
--- a/docs/presentation.pptx
+++ b/docs/presentation.pptx
@@ -653,7 +653,7 @@
           <a:lstStyle/>
           <a:p>
             <a:r>
-              <a:t>No demo. These are deliberate scope decisions — say so plainly, don't apologize for them.</a:t>
+              <a:t>No demo. These are deliberate scope decisions, so say that plainly and don't apologize for them.</a:t>
             </a:r>
           </a:p>
           <a:p>
@@ -1148,7 +1148,7 @@
           <a:lstStyle/>
           <a:p>
             <a:r>
-              <a:t>No image here — the min-DFA diagram is on the next slide (matching). Say the fixpoint rule clearly, it's a likely question.</a:t>
+              <a:t>No image here, the min-DFA diagram is on the next slide (matching). Say the fixpoint rule clearly since it's a likely question.</a:t>
             </a:r>
           </a:p>
         </p:txBody>
@@ -4434,7 +4434,7 @@
                 </a:solidFill>
                 <a:latin typeface="Arial"/>
               </a:rPr>
-              <a:t>BCSE307L Compiler Design  —  Vignesh P C, Ujwal</a:t>
+              <a:t>BCSE307L Compiler Design, by Vignesh P C and Ujwal</a:t>
             </a:r>
           </a:p>
         </p:txBody>
@@ -4603,7 +4603,7 @@
               </a:defRPr>
             </a:pPr>
             <a:r>
-              <a:t>•  Differential testing: thousands of random (pattern, input) pairs vs std::regex (C++) and native RegExp (TypeScript) — both independent implementations must agree.</a:t>
+              <a:t>•  Differential testing: thousands of random (pattern, input) pairs checked against std::regex in C++ and native RegExp in TypeScript. Both independent implementations have to agree.</a:t>
             </a:r>
           </a:p>
           <a:p>
@@ -4619,7 +4619,51 @@
               </a:defRPr>
             </a:pPr>
             <a:r>
-              <a:t>•  Measured today: 93 TypeScript tests / 7 files; 4,608 C++ assertions / 41 cases.</a:t>
+              <a:t>•  Measured today: 125 TypeScript tests / 10 files; 4,608 C++ assertions / 41 cases.</a:t>
+            </a:r>
+          </a:p>
+          <a:p>
+            <a:pPr marL="457200">
+              <a:spcAft>
+                <a:spcPts val="800"/>
+              </a:spcAft>
+              <a:defRPr sz="1500" i="1">
+                <a:solidFill>
+                  <a:srgbClr val="606060"/>
+                </a:solidFill>
+                <a:latin typeface="Arial"/>
+              </a:defRPr>
+            </a:pPr>
+            <a:r>
+              <a:rPr sz="1500" i="1">
+                <a:solidFill>
+                  <a:srgbClr val="606060"/>
+                </a:solidFill>
+                <a:latin typeface="Arial"/>
+              </a:rPr>
+              <a:t>–  How: npm test feeds each known pattern through the real pipeline and checks the answer is exactly right.</a:t>
+            </a:r>
+          </a:p>
+          <a:p>
+            <a:pPr marL="457200">
+              <a:spcAft>
+                <a:spcPts val="800"/>
+              </a:spcAft>
+              <a:defRPr sz="1500" i="1">
+                <a:solidFill>
+                  <a:srgbClr val="606060"/>
+                </a:solidFill>
+                <a:latin typeface="Arial"/>
+              </a:defRPr>
+            </a:pPr>
+            <a:r>
+              <a:rPr sz="1500" i="1">
+                <a:solidFill>
+                  <a:srgbClr val="606060"/>
+                </a:solidFill>
+                <a:latin typeface="Arial"/>
+              </a:rPr>
+              <a:t>–  How: ./engine_tests runs the same checks ported to C++, one assertion per fact checked (e.g. an exact state count).</a:t>
             </a:r>
           </a:p>
           <a:p>
@@ -4804,7 +4848,7 @@
               </a:defRPr>
             </a:pPr>
             <a:r>
-              <a:t>•  Direct method (firstpos/followpos) not built — we chose the indirect Thompson + subset-construction route on purpose.</a:t>
+              <a:t>•  Direct method (firstpos/followpos) not built. We chose the indirect Thompson-plus-subset-construction route on purpose.</a:t>
             </a:r>
           </a:p>
           <a:p>
@@ -4820,7 +4864,7 @@
               </a:defRPr>
             </a:pPr>
             <a:r>
-              <a:t>•  Hopcroft's minimization not built — Moore's is simpler to implement and explain fully; Hopcroft's is a planned, gated upgrade.</a:t>
+              <a:t>•  Hopcroft's minimization not built. Moore's is simpler to implement and explain fully, and Hopcroft's stays a planned, gated upgrade.</a:t>
             </a:r>
           </a:p>
           <a:p>
@@ -4836,7 +4880,7 @@
               </a:defRPr>
             </a:pPr>
             <a:r>
-              <a:t>•  No dedicated DFA state-count guard against subset construction's exponential worst case — the 500-char pattern cap bounds it indirectly, not tightly.</a:t>
+              <a:t>•  No dedicated DFA state-count guard against subset construction's exponential worst case. The 500-char pattern cap bounds it indirectly, not tightly.</a:t>
             </a:r>
           </a:p>
         </p:txBody>
@@ -5101,7 +5145,7 @@
               </a:defRPr>
             </a:pPr>
             <a:r>
-              <a:t>•  Given a regular expression and a string, decide whether the string matches — without using a built-in regex engine.</a:t>
+              <a:t>•  Given a regular expression and a string, decide whether the string matches, without reaching for a built-in regex engine.</a:t>
             </a:r>
           </a:p>
           <a:p>
@@ -5117,7 +5161,7 @@
               </a:defRPr>
             </a:pPr>
             <a:r>
-              <a:t>•  Build the actual compiler pipeline that answers this: parser, NFA, DFA, minimization, matcher — not a lookup into an existing library.</a:t>
+              <a:t>•  Build the actual compiler pipeline that answers this: parser, NFA, DFA, minimization and matcher, not a lookup into an existing library.</a:t>
             </a:r>
           </a:p>
           <a:p>
@@ -5270,13 +5314,13 @@
       </p:cxnSp>
       <p:sp>
         <p:nvSpPr>
-          <p:cNvPr id="5" name="Rectangle 4"/>
+          <p:cNvPr id="5" name="Rectangle 5"/>
           <p:cNvSpPr/>
           <p:nvPr/>
         </p:nvSpPr>
         <p:spPr>
           <a:xfrm>
-            <a:off x="457200" y="2011680"/>
+            <a:off x="457200" y="1188720"/>
             <a:ext cx="1691640" cy="731520"/>
           </a:xfrm>
           <a:prstGeom prst="rect">
@@ -5318,21 +5362,32 @@
                 </a:solidFill>
                 <a:latin typeface="Arial"/>
               </a:rPr>
-              <a:t>Pattern
-(text)</a:t>
-            </a:r>
-          </a:p>
-        </p:txBody>
-      </p:sp>
-      <p:sp>
-        <p:nvSpPr>
-          <p:cNvPr id="6" name="Rectangle 5"/>
+              <a:t>Pattern</a:t>
+            </a:r>
+          </a:p>
+          <a:p>
+            <a:pPr algn="ctr"/>
+            <a:r>
+              <a:rPr sz="1300">
+                <a:solidFill>
+                  <a:srgbClr val="000000"/>
+                </a:solidFill>
+                <a:latin typeface="Arial"/>
+              </a:rPr>
+              <a:t>(text)</a:t>
+            </a:r>
+          </a:p>
+        </p:txBody>
+      </p:sp>
+      <p:sp>
+        <p:nvSpPr>
+          <p:cNvPr id="6" name="Rectangle 6"/>
           <p:cNvSpPr/>
           <p:nvPr/>
         </p:nvSpPr>
         <p:spPr>
           <a:xfrm>
-            <a:off x="2468880" y="2011680"/>
+            <a:off x="2468880" y="1188720"/>
             <a:ext cx="1417320" cy="731520"/>
           </a:xfrm>
           <a:prstGeom prst="rect">
@@ -5381,13 +5436,13 @@
       </p:sp>
       <p:sp>
         <p:nvSpPr>
-          <p:cNvPr id="7" name="Rectangle 6"/>
+          <p:cNvPr id="7" name="Rectangle 7"/>
           <p:cNvSpPr/>
           <p:nvPr/>
         </p:nvSpPr>
         <p:spPr>
           <a:xfrm>
-            <a:off x="4206240" y="2011680"/>
+            <a:off x="4206240" y="1188720"/>
             <a:ext cx="1417320" cy="731520"/>
           </a:xfrm>
           <a:prstGeom prst="rect">
@@ -5436,13 +5491,13 @@
       </p:sp>
       <p:sp>
         <p:nvSpPr>
-          <p:cNvPr id="8" name="Rectangle 7"/>
+          <p:cNvPr id="8" name="Rectangle 8"/>
           <p:cNvSpPr/>
           <p:nvPr/>
         </p:nvSpPr>
         <p:spPr>
           <a:xfrm>
-            <a:off x="5943600" y="2011680"/>
+            <a:off x="5943600" y="1188720"/>
             <a:ext cx="1691640" cy="731520"/>
           </a:xfrm>
           <a:prstGeom prst="rect">
@@ -5484,21 +5539,32 @@
                 </a:solidFill>
                 <a:latin typeface="Arial"/>
               </a:rPr>
-              <a:t>Thompson's
-Construction</a:t>
-            </a:r>
-          </a:p>
-        </p:txBody>
-      </p:sp>
-      <p:sp>
-        <p:nvSpPr>
-          <p:cNvPr id="9" name="Rectangle 8"/>
+              <a:t>Thompson's</a:t>
+            </a:r>
+          </a:p>
+          <a:p>
+            <a:pPr algn="ctr"/>
+            <a:r>
+              <a:rPr sz="1300">
+                <a:solidFill>
+                  <a:srgbClr val="000000"/>
+                </a:solidFill>
+                <a:latin typeface="Arial"/>
+              </a:rPr>
+              <a:t>Construction</a:t>
+            </a:r>
+          </a:p>
+        </p:txBody>
+      </p:sp>
+      <p:sp>
+        <p:nvSpPr>
+          <p:cNvPr id="9" name="Rectangle 9"/>
           <p:cNvSpPr/>
           <p:nvPr/>
         </p:nvSpPr>
         <p:spPr>
           <a:xfrm>
-            <a:off x="7955279" y="2011680"/>
+            <a:off x="7955280" y="1188720"/>
             <a:ext cx="1417320" cy="731520"/>
           </a:xfrm>
           <a:prstGeom prst="rect">
@@ -5547,13 +5613,13 @@
       </p:sp>
       <p:sp>
         <p:nvSpPr>
-          <p:cNvPr id="10" name="Rectangle 9"/>
+          <p:cNvPr id="10" name="Rectangle 10"/>
           <p:cNvSpPr/>
           <p:nvPr/>
         </p:nvSpPr>
         <p:spPr>
           <a:xfrm>
-            <a:off x="9692640" y="2011680"/>
+            <a:off x="9692640" y="1188720"/>
             <a:ext cx="1691640" cy="731520"/>
           </a:xfrm>
           <a:prstGeom prst="rect">
@@ -5595,21 +5661,212 @@
                 </a:solidFill>
                 <a:latin typeface="Arial"/>
               </a:rPr>
-              <a:t>Subset
-Construction</a:t>
-            </a:r>
-          </a:p>
-        </p:txBody>
-      </p:sp>
-      <p:sp>
-        <p:nvSpPr>
-          <p:cNvPr id="11" name="Rectangle 10"/>
+              <a:t>Subset</a:t>
+            </a:r>
+          </a:p>
+          <a:p>
+            <a:pPr algn="ctr"/>
+            <a:r>
+              <a:rPr sz="1300">
+                <a:solidFill>
+                  <a:srgbClr val="000000"/>
+                </a:solidFill>
+                <a:latin typeface="Arial"/>
+              </a:rPr>
+              <a:t>Construction</a:t>
+            </a:r>
+          </a:p>
+        </p:txBody>
+      </p:sp>
+      <p:cxnSp>
+        <p:nvCxnSpPr>
+          <p:cNvPr id="11" name="Connector 11"/>
+          <p:cNvCxnSpPr/>
+          <p:nvPr/>
+        </p:nvCxnSpPr>
+        <p:spPr>
+          <a:xfrm>
+            <a:off x="2148840" y="1554480"/>
+            <a:ext cx="320040" cy="0"/>
+          </a:xfrm>
+          <a:prstGeom prst="line">
+            <a:avLst/>
+          </a:prstGeom>
+          <a:ln w="15875">
+            <a:solidFill>
+              <a:srgbClr val="000000"/>
+            </a:solidFill>
+            <a:tailEnd type="triangle" w="med" len="med"/>
+          </a:ln>
+        </p:spPr>
+        <p:style>
+          <a:lnRef idx="2">
+            <a:schemeClr val="accent1"/>
+          </a:lnRef>
+          <a:fillRef idx="0">
+            <a:schemeClr val="accent1"/>
+          </a:fillRef>
+          <a:effectRef idx="1">
+            <a:schemeClr val="accent1"/>
+          </a:effectRef>
+          <a:fontRef idx="minor">
+            <a:schemeClr val="tx1"/>
+          </a:fontRef>
+        </p:style>
+      </p:cxnSp>
+      <p:cxnSp>
+        <p:nvCxnSpPr>
+          <p:cNvPr id="12" name="Connector 12"/>
+          <p:cNvCxnSpPr/>
+          <p:nvPr/>
+        </p:nvCxnSpPr>
+        <p:spPr>
+          <a:xfrm>
+            <a:off x="3886200" y="1554480"/>
+            <a:ext cx="320040" cy="0"/>
+          </a:xfrm>
+          <a:prstGeom prst="line">
+            <a:avLst/>
+          </a:prstGeom>
+          <a:ln w="15875">
+            <a:solidFill>
+              <a:srgbClr val="000000"/>
+            </a:solidFill>
+            <a:tailEnd type="triangle" w="med" len="med"/>
+          </a:ln>
+        </p:spPr>
+        <p:style>
+          <a:lnRef idx="2">
+            <a:schemeClr val="accent1"/>
+          </a:lnRef>
+          <a:fillRef idx="0">
+            <a:schemeClr val="accent1"/>
+          </a:fillRef>
+          <a:effectRef idx="1">
+            <a:schemeClr val="accent1"/>
+          </a:effectRef>
+          <a:fontRef idx="minor">
+            <a:schemeClr val="tx1"/>
+          </a:fontRef>
+        </p:style>
+      </p:cxnSp>
+      <p:cxnSp>
+        <p:nvCxnSpPr>
+          <p:cNvPr id="13" name="Connector 13"/>
+          <p:cNvCxnSpPr/>
+          <p:nvPr/>
+        </p:nvCxnSpPr>
+        <p:spPr>
+          <a:xfrm>
+            <a:off x="5623560" y="1554480"/>
+            <a:ext cx="320040" cy="0"/>
+          </a:xfrm>
+          <a:prstGeom prst="line">
+            <a:avLst/>
+          </a:prstGeom>
+          <a:ln w="15875">
+            <a:solidFill>
+              <a:srgbClr val="000000"/>
+            </a:solidFill>
+            <a:tailEnd type="triangle" w="med" len="med"/>
+          </a:ln>
+        </p:spPr>
+        <p:style>
+          <a:lnRef idx="2">
+            <a:schemeClr val="accent1"/>
+          </a:lnRef>
+          <a:fillRef idx="0">
+            <a:schemeClr val="accent1"/>
+          </a:fillRef>
+          <a:effectRef idx="1">
+            <a:schemeClr val="accent1"/>
+          </a:effectRef>
+          <a:fontRef idx="minor">
+            <a:schemeClr val="tx1"/>
+          </a:fontRef>
+        </p:style>
+      </p:cxnSp>
+      <p:cxnSp>
+        <p:nvCxnSpPr>
+          <p:cNvPr id="14" name="Connector 14"/>
+          <p:cNvCxnSpPr/>
+          <p:nvPr/>
+        </p:nvCxnSpPr>
+        <p:spPr>
+          <a:xfrm>
+            <a:off x="7635240" y="1554480"/>
+            <a:ext cx="320040" cy="0"/>
+          </a:xfrm>
+          <a:prstGeom prst="line">
+            <a:avLst/>
+          </a:prstGeom>
+          <a:ln w="15875">
+            <a:solidFill>
+              <a:srgbClr val="000000"/>
+            </a:solidFill>
+            <a:tailEnd type="triangle" w="med" len="med"/>
+          </a:ln>
+        </p:spPr>
+        <p:style>
+          <a:lnRef idx="2">
+            <a:schemeClr val="accent1"/>
+          </a:lnRef>
+          <a:fillRef idx="0">
+            <a:schemeClr val="accent1"/>
+          </a:fillRef>
+          <a:effectRef idx="1">
+            <a:schemeClr val="accent1"/>
+          </a:effectRef>
+          <a:fontRef idx="minor">
+            <a:schemeClr val="tx1"/>
+          </a:fontRef>
+        </p:style>
+      </p:cxnSp>
+      <p:cxnSp>
+        <p:nvCxnSpPr>
+          <p:cNvPr id="15" name="Connector 15"/>
+          <p:cNvCxnSpPr/>
+          <p:nvPr/>
+        </p:nvCxnSpPr>
+        <p:spPr>
+          <a:xfrm>
+            <a:off x="9372600" y="1554480"/>
+            <a:ext cx="320040" cy="0"/>
+          </a:xfrm>
+          <a:prstGeom prst="line">
+            <a:avLst/>
+          </a:prstGeom>
+          <a:ln w="15875">
+            <a:solidFill>
+              <a:srgbClr val="000000"/>
+            </a:solidFill>
+            <a:tailEnd type="triangle" w="med" len="med"/>
+          </a:ln>
+        </p:spPr>
+        <p:style>
+          <a:lnRef idx="2">
+            <a:schemeClr val="accent1"/>
+          </a:lnRef>
+          <a:fillRef idx="0">
+            <a:schemeClr val="accent1"/>
+          </a:fillRef>
+          <a:effectRef idx="1">
+            <a:schemeClr val="accent1"/>
+          </a:effectRef>
+          <a:fontRef idx="minor">
+            <a:schemeClr val="tx1"/>
+          </a:fontRef>
+        </p:style>
+      </p:cxnSp>
+      <p:sp>
+        <p:nvSpPr>
+          <p:cNvPr id="16" name="Rectangle 16"/>
           <p:cNvSpPr/>
           <p:nvPr/>
         </p:nvSpPr>
         <p:spPr>
           <a:xfrm>
-            <a:off x="11704320" y="2011680"/>
+            <a:off x="457200" y="2697480"/>
             <a:ext cx="1417320" cy="731520"/>
           </a:xfrm>
           <a:prstGeom prst="rect">
@@ -5658,13 +5915,13 @@
       </p:sp>
       <p:sp>
         <p:nvSpPr>
-          <p:cNvPr id="12" name="Rectangle 11"/>
+          <p:cNvPr id="17" name="Rectangle 17"/>
           <p:cNvSpPr/>
           <p:nvPr/>
         </p:nvSpPr>
         <p:spPr>
           <a:xfrm>
-            <a:off x="13441680" y="2011680"/>
+            <a:off x="2194560" y="2697480"/>
             <a:ext cx="1691640" cy="731520"/>
           </a:xfrm>
           <a:prstGeom prst="rect">
@@ -5706,21 +5963,32 @@
                 </a:solidFill>
                 <a:latin typeface="Arial"/>
               </a:rPr>
-              <a:t>Moore's
-Minimization</a:t>
-            </a:r>
-          </a:p>
-        </p:txBody>
-      </p:sp>
-      <p:sp>
-        <p:nvSpPr>
-          <p:cNvPr id="13" name="Rectangle 12"/>
+              <a:t>Moore's</a:t>
+            </a:r>
+          </a:p>
+          <a:p>
+            <a:pPr algn="ctr"/>
+            <a:r>
+              <a:rPr sz="1300">
+                <a:solidFill>
+                  <a:srgbClr val="000000"/>
+                </a:solidFill>
+                <a:latin typeface="Arial"/>
+              </a:rPr>
+              <a:t>Minimization</a:t>
+            </a:r>
+          </a:p>
+        </p:txBody>
+      </p:sp>
+      <p:sp>
+        <p:nvSpPr>
+          <p:cNvPr id="18" name="Rectangle 18"/>
           <p:cNvSpPr/>
           <p:nvPr/>
         </p:nvSpPr>
         <p:spPr>
           <a:xfrm>
-            <a:off x="15453360" y="2011680"/>
+            <a:off x="4206240" y="2697480"/>
             <a:ext cx="1417320" cy="731520"/>
           </a:xfrm>
           <a:prstGeom prst="rect">
@@ -5769,13 +6037,13 @@
       </p:sp>
       <p:sp>
         <p:nvSpPr>
-          <p:cNvPr id="14" name="Rectangle 13"/>
+          <p:cNvPr id="19" name="Rectangle 19"/>
           <p:cNvSpPr/>
           <p:nvPr/>
         </p:nvSpPr>
         <p:spPr>
           <a:xfrm>
-            <a:off x="17190720" y="2011680"/>
+            <a:off x="5943600" y="2697480"/>
             <a:ext cx="1417320" cy="731520"/>
           </a:xfrm>
           <a:prstGeom prst="rect">
@@ -5824,13 +6092,13 @@
       </p:sp>
       <p:sp>
         <p:nvSpPr>
-          <p:cNvPr id="15" name="Rectangle 14"/>
+          <p:cNvPr id="20" name="Rectangle 20"/>
           <p:cNvSpPr/>
           <p:nvPr/>
         </p:nvSpPr>
         <p:spPr>
           <a:xfrm>
-            <a:off x="18928080" y="2011680"/>
+            <a:off x="7680960" y="2697480"/>
             <a:ext cx="1691640" cy="731520"/>
           </a:xfrm>
           <a:prstGeom prst="rect">
@@ -5872,21 +6140,32 @@
                 </a:solidFill>
                 <a:latin typeface="Arial"/>
               </a:rPr>
-              <a:t>match /
-no-match</a:t>
+              <a:t>match /</a:t>
+            </a:r>
+          </a:p>
+          <a:p>
+            <a:pPr algn="ctr"/>
+            <a:r>
+              <a:rPr sz="1300">
+                <a:solidFill>
+                  <a:srgbClr val="000000"/>
+                </a:solidFill>
+                <a:latin typeface="Arial"/>
+              </a:rPr>
+              <a:t>no-match</a:t>
             </a:r>
           </a:p>
         </p:txBody>
       </p:sp>
       <p:cxnSp>
         <p:nvCxnSpPr>
-          <p:cNvPr id="16" name="Connector 15"/>
+          <p:cNvPr id="21" name="Connector 21"/>
           <p:cNvCxnSpPr/>
           <p:nvPr/>
         </p:nvCxnSpPr>
         <p:spPr>
           <a:xfrm>
-            <a:off x="2148840" y="2377440"/>
+            <a:off x="1874520" y="3063240"/>
             <a:ext cx="320040" cy="0"/>
           </a:xfrm>
           <a:prstGeom prst="line">
@@ -5916,13 +6195,13 @@
       </p:cxnSp>
       <p:cxnSp>
         <p:nvCxnSpPr>
-          <p:cNvPr id="17" name="Connector 16"/>
+          <p:cNvPr id="22" name="Connector 22"/>
           <p:cNvCxnSpPr/>
           <p:nvPr/>
         </p:nvCxnSpPr>
         <p:spPr>
           <a:xfrm>
-            <a:off x="3886200" y="2377440"/>
+            <a:off x="3886200" y="3063240"/>
             <a:ext cx="320040" cy="0"/>
           </a:xfrm>
           <a:prstGeom prst="line">
@@ -5952,14 +6231,14 @@
       </p:cxnSp>
       <p:cxnSp>
         <p:nvCxnSpPr>
-          <p:cNvPr id="18" name="Connector 17"/>
+          <p:cNvPr id="23" name="Connector 23"/>
           <p:cNvCxnSpPr/>
           <p:nvPr/>
         </p:nvCxnSpPr>
         <p:spPr>
           <a:xfrm>
-            <a:off x="5623559" y="2377440"/>
-            <a:ext cx="320041" cy="0"/>
+            <a:off x="5623560" y="3063240"/>
+            <a:ext cx="320040" cy="0"/>
           </a:xfrm>
           <a:prstGeom prst="line">
             <a:avLst/>
@@ -5988,14 +6267,14 @@
       </p:cxnSp>
       <p:cxnSp>
         <p:nvCxnSpPr>
-          <p:cNvPr id="19" name="Connector 18"/>
+          <p:cNvPr id="24" name="Connector 24"/>
           <p:cNvCxnSpPr/>
           <p:nvPr/>
         </p:nvCxnSpPr>
         <p:spPr>
           <a:xfrm>
-            <a:off x="7635240" y="2377440"/>
-            <a:ext cx="320039" cy="0"/>
+            <a:off x="7360920" y="3063240"/>
+            <a:ext cx="320040" cy="0"/>
           </a:xfrm>
           <a:prstGeom prst="line">
             <a:avLst/>
@@ -6024,14 +6303,14 @@
       </p:cxnSp>
       <p:cxnSp>
         <p:nvCxnSpPr>
-          <p:cNvPr id="20" name="Connector 19"/>
+          <p:cNvPr id="25" name="Connector 25"/>
           <p:cNvCxnSpPr/>
           <p:nvPr/>
         </p:nvCxnSpPr>
         <p:spPr>
           <a:xfrm>
-            <a:off x="9372600" y="2377440"/>
-            <a:ext cx="320040" cy="0"/>
+            <a:off x="10538460" y="1920240"/>
+            <a:ext cx="0" cy="388620"/>
           </a:xfrm>
           <a:prstGeom prst="line">
             <a:avLst/>
@@ -6040,7 +6319,6 @@
             <a:solidFill>
               <a:srgbClr val="000000"/>
             </a:solidFill>
-            <a:tailEnd type="triangle" w="med" len="med"/>
           </a:ln>
         </p:spPr>
         <p:style>
@@ -6060,14 +6338,14 @@
       </p:cxnSp>
       <p:cxnSp>
         <p:nvCxnSpPr>
-          <p:cNvPr id="21" name="Connector 20"/>
+          <p:cNvPr id="26" name="Connector 26"/>
           <p:cNvCxnSpPr/>
           <p:nvPr/>
         </p:nvCxnSpPr>
         <p:spPr>
           <a:xfrm>
-            <a:off x="11384280" y="2377440"/>
-            <a:ext cx="320040" cy="0"/>
+            <a:off x="1165860" y="2308860"/>
+            <a:ext cx="9372600" cy="0"/>
           </a:xfrm>
           <a:prstGeom prst="line">
             <a:avLst/>
@@ -6076,7 +6354,6 @@
             <a:solidFill>
               <a:srgbClr val="000000"/>
             </a:solidFill>
-            <a:tailEnd type="triangle" w="med" len="med"/>
           </a:ln>
         </p:spPr>
         <p:style>
@@ -6096,14 +6373,14 @@
       </p:cxnSp>
       <p:cxnSp>
         <p:nvCxnSpPr>
-          <p:cNvPr id="22" name="Connector 21"/>
+          <p:cNvPr id="27" name="Connector 27"/>
           <p:cNvCxnSpPr/>
           <p:nvPr/>
         </p:nvCxnSpPr>
         <p:spPr>
           <a:xfrm>
-            <a:off x="13121640" y="2377440"/>
-            <a:ext cx="320040" cy="0"/>
+            <a:off x="1165860" y="2308860"/>
+            <a:ext cx="0" cy="388620"/>
           </a:xfrm>
           <a:prstGeom prst="line">
             <a:avLst/>
@@ -6130,123 +6407,15 @@
           </a:fontRef>
         </p:style>
       </p:cxnSp>
-      <p:cxnSp>
-        <p:nvCxnSpPr>
-          <p:cNvPr id="23" name="Connector 22"/>
-          <p:cNvCxnSpPr/>
-          <p:nvPr/>
-        </p:nvCxnSpPr>
-        <p:spPr>
-          <a:xfrm>
-            <a:off x="15133320" y="2377440"/>
-            <a:ext cx="320040" cy="0"/>
-          </a:xfrm>
-          <a:prstGeom prst="line">
-            <a:avLst/>
-          </a:prstGeom>
-          <a:ln w="15875">
-            <a:solidFill>
-              <a:srgbClr val="000000"/>
-            </a:solidFill>
-            <a:tailEnd type="triangle" w="med" len="med"/>
-          </a:ln>
-        </p:spPr>
-        <p:style>
-          <a:lnRef idx="2">
-            <a:schemeClr val="accent1"/>
-          </a:lnRef>
-          <a:fillRef idx="0">
-            <a:schemeClr val="accent1"/>
-          </a:fillRef>
-          <a:effectRef idx="1">
-            <a:schemeClr val="accent1"/>
-          </a:effectRef>
-          <a:fontRef idx="minor">
-            <a:schemeClr val="tx1"/>
-          </a:fontRef>
-        </p:style>
-      </p:cxnSp>
-      <p:cxnSp>
-        <p:nvCxnSpPr>
-          <p:cNvPr id="24" name="Connector 23"/>
-          <p:cNvCxnSpPr/>
-          <p:nvPr/>
-        </p:nvCxnSpPr>
-        <p:spPr>
-          <a:xfrm>
-            <a:off x="16870680" y="2377440"/>
-            <a:ext cx="320040" cy="0"/>
-          </a:xfrm>
-          <a:prstGeom prst="line">
-            <a:avLst/>
-          </a:prstGeom>
-          <a:ln w="15875">
-            <a:solidFill>
-              <a:srgbClr val="000000"/>
-            </a:solidFill>
-            <a:tailEnd type="triangle" w="med" len="med"/>
-          </a:ln>
-        </p:spPr>
-        <p:style>
-          <a:lnRef idx="2">
-            <a:schemeClr val="accent1"/>
-          </a:lnRef>
-          <a:fillRef idx="0">
-            <a:schemeClr val="accent1"/>
-          </a:fillRef>
-          <a:effectRef idx="1">
-            <a:schemeClr val="accent1"/>
-          </a:effectRef>
-          <a:fontRef idx="minor">
-            <a:schemeClr val="tx1"/>
-          </a:fontRef>
-        </p:style>
-      </p:cxnSp>
-      <p:cxnSp>
-        <p:nvCxnSpPr>
-          <p:cNvPr id="25" name="Connector 24"/>
-          <p:cNvCxnSpPr/>
-          <p:nvPr/>
-        </p:nvCxnSpPr>
-        <p:spPr>
-          <a:xfrm>
-            <a:off x="18608040" y="2377440"/>
-            <a:ext cx="320040" cy="0"/>
-          </a:xfrm>
-          <a:prstGeom prst="line">
-            <a:avLst/>
-          </a:prstGeom>
-          <a:ln w="15875">
-            <a:solidFill>
-              <a:srgbClr val="000000"/>
-            </a:solidFill>
-            <a:tailEnd type="triangle" w="med" len="med"/>
-          </a:ln>
-        </p:spPr>
-        <p:style>
-          <a:lnRef idx="2">
-            <a:schemeClr val="accent1"/>
-          </a:lnRef>
-          <a:fillRef idx="0">
-            <a:schemeClr val="accent1"/>
-          </a:fillRef>
-          <a:effectRef idx="1">
-            <a:schemeClr val="accent1"/>
-          </a:effectRef>
-          <a:fontRef idx="minor">
-            <a:schemeClr val="tx1"/>
-          </a:fontRef>
-        </p:style>
-      </p:cxnSp>
-      <p:sp>
-        <p:nvSpPr>
-          <p:cNvPr id="26" name="Rectangle 25"/>
+      <p:sp>
+        <p:nvSpPr>
+          <p:cNvPr id="28" name="Rectangle 28"/>
           <p:cNvSpPr/>
           <p:nvPr/>
         </p:nvSpPr>
         <p:spPr>
           <a:xfrm>
-            <a:off x="17213580" y="3474720"/>
+            <a:off x="5966460" y="3931920"/>
             <a:ext cx="1371600" cy="640080"/>
           </a:xfrm>
           <a:prstGeom prst="rect">
@@ -6288,22 +6457,33 @@
                 </a:solidFill>
                 <a:latin typeface="Arial"/>
               </a:rPr>
-              <a:t>Test string
-(text)</a:t>
+              <a:t>Test string</a:t>
+            </a:r>
+          </a:p>
+          <a:p>
+            <a:pPr algn="ctr"/>
+            <a:r>
+              <a:rPr sz="1300">
+                <a:solidFill>
+                  <a:srgbClr val="000000"/>
+                </a:solidFill>
+                <a:latin typeface="Arial"/>
+              </a:rPr>
+              <a:t>(text)</a:t>
             </a:r>
           </a:p>
         </p:txBody>
       </p:sp>
       <p:cxnSp>
         <p:nvCxnSpPr>
-          <p:cNvPr id="27" name="Connector 26"/>
+          <p:cNvPr id="29" name="Connector 29"/>
           <p:cNvCxnSpPr/>
           <p:nvPr/>
         </p:nvCxnSpPr>
         <p:spPr>
           <a:xfrm flipV="1">
-            <a:off x="17899380" y="2743200"/>
-            <a:ext cx="0" cy="731520"/>
+            <a:off x="6652260" y="3429000"/>
+            <a:ext cx="0" cy="502920"/>
           </a:xfrm>
           <a:prstGeom prst="line">
             <a:avLst/>
@@ -6332,14 +6512,14 @@
       </p:cxnSp>
       <p:sp>
         <p:nvSpPr>
-          <p:cNvPr id="28" name="TextBox 27"/>
+          <p:cNvPr id="30" name="TextBox 27"/>
           <p:cNvSpPr txBox="1"/>
           <p:nvPr/>
         </p:nvSpPr>
         <p:spPr>
           <a:xfrm>
-            <a:off x="457200" y="4206240"/>
-            <a:ext cx="11247120" cy="4754880"/>
+            <a:off x="457200" y="4754880"/>
+            <a:ext cx="10789920" cy="1600200"/>
           </a:xfrm>
           <a:prstGeom prst="rect">
             <a:avLst/>
@@ -6380,7 +6560,7 @@
               </a:defRPr>
             </a:pPr>
             <a:r>
-              <a:t>•  Implemented twice: a TypeScript prototype and a C++20 engine compiled to WebAssembly — the browser runs the C++/WASM build.</a:t>
+              <a:t>•  Implemented twice: a TypeScript prototype and a C++20 engine compiled to WebAssembly, and the browser runs the C++/WASM build.</a:t>
             </a:r>
           </a:p>
           <a:p>
@@ -6581,7 +6761,7 @@
               </a:defRPr>
             </a:pPr>
             <a:r>
-              <a:t>•  Precedence by call depth: parseRegex calls parseTerm calls parseFactor calls parseAtom — deepest binds tightest, no table.</a:t>
+              <a:t>•  Precedence by call depth: parseRegex calls parseTerm calls parseFactor calls parseAtom, so the deepest call binds tightest. No precedence table needed.</a:t>
             </a:r>
           </a:p>
           <a:p>
@@ -6597,7 +6777,7 @@
               </a:defRPr>
             </a:pPr>
             <a:r>
-              <a:t>•  No separate lexer — every token is one character.</a:t>
+              <a:t>•  No separate lexer: every token is just one character.</a:t>
             </a:r>
           </a:p>
         </p:txBody>
@@ -7361,7 +7541,7 @@
               </a:defRPr>
             </a:pPr>
             <a:r>
-              <a:t>•  Stop at a fixpoint — a full pass with zero splits.</a:t>
+              <a:t>•  Stop at a fixpoint, meaning a full pass with zero splits.</a:t>
             </a:r>
           </a:p>
           <a:p>
@@ -7621,7 +7801,7 @@
                 </a:solidFill>
                 <a:latin typeface="Arial"/>
               </a:rPr>
-              <a:t>Fig. 4a. babb — ends in abb → Accepted.</a:t>
+              <a:t>Fig. 4a. babb ends in abb: Accepted.</a:t>
             </a:r>
           </a:p>
         </p:txBody>
@@ -7680,7 +7860,7 @@
                 </a:solidFill>
                 <a:latin typeface="Arial"/>
               </a:rPr>
-              <a:t>Fig. 4b. abab — ends in bab, not abb → Rejected.</a:t>
+              <a:t>Fig. 4b. abab ends in bab, not abb: Rejected.</a:t>
             </a:r>
           </a:p>
         </p:txBody>
@@ -7849,7 +8029,7 @@
               </a:defRPr>
             </a:pPr>
             <a:r>
-              <a:t>•  All four tabs have real, stage-specific playback — not just min-DFA scrubbing.</a:t>
+              <a:t>•  All four tabs have real, stage-specific playback, not just min-DFA scrubbing.</a:t>
             </a:r>
           </a:p>
           <a:p>

</xml_diff>

<commit_message>
feat: complete RegexLab A+B and safety improvements
</commit_message>
<xml_diff>
--- a/docs/presentation.pptx
+++ b/docs/presentation.pptx
@@ -4,21 +4,24 @@
   <p:sldMasterIdLst>
     <p:sldMasterId id="2147483648" r:id="rId1"/>
   </p:sldMasterIdLst>
+  <p:notesMasterIdLst>
+    <p:notesMasterId r:id="rId14"/>
+  </p:notesMasterIdLst>
   <p:sldIdLst>
-    <p:sldId id="256" r:id="rId7"/>
-    <p:sldId id="257" r:id="rId9"/>
-    <p:sldId id="258" r:id="rId10"/>
-    <p:sldId id="259" r:id="rId11"/>
-    <p:sldId id="260" r:id="rId12"/>
-    <p:sldId id="261" r:id="rId13"/>
-    <p:sldId id="262" r:id="rId14"/>
-    <p:sldId id="263" r:id="rId15"/>
-    <p:sldId id="264" r:id="rId16"/>
-    <p:sldId id="265" r:id="rId17"/>
-    <p:sldId id="266" r:id="rId18"/>
-    <p:sldId id="267" r:id="rId19"/>
+    <p:sldId id="256" r:id="rId2"/>
+    <p:sldId id="257" r:id="rId3"/>
+    <p:sldId id="258" r:id="rId4"/>
+    <p:sldId id="259" r:id="rId5"/>
+    <p:sldId id="260" r:id="rId6"/>
+    <p:sldId id="261" r:id="rId7"/>
+    <p:sldId id="262" r:id="rId8"/>
+    <p:sldId id="263" r:id="rId9"/>
+    <p:sldId id="264" r:id="rId10"/>
+    <p:sldId id="265" r:id="rId11"/>
+    <p:sldId id="266" r:id="rId12"/>
+    <p:sldId id="267" r:id="rId13"/>
   </p:sldIdLst>
-  <p:sldSz cx="12191695" cy="6858000" type="screen4x3"/>
+  <p:sldSz cx="12192000" cy="6858000"/>
   <p:notesSz cx="6858000" cy="9144000"/>
   <p:defaultTextStyle>
     <a:defPPr>
@@ -115,11 +118,27 @@
       </a:defRPr>
     </a:lvl9pPr>
   </p:defaultTextStyle>
+  <p:extLst>
+    <p:ext uri="{EFAFB233-063F-42B5-8137-9DF3F51BA10A}">
+      <p15:sldGuideLst xmlns:p15="http://schemas.microsoft.com/office/powerpoint/2012/main">
+        <p15:guide id="1" orient="horz" pos="2160">
+          <p15:clr>
+            <a:srgbClr val="A4A3A4"/>
+          </p15:clr>
+        </p15:guide>
+        <p15:guide id="2" pos="2880">
+          <p15:clr>
+            <a:srgbClr val="A4A3A4"/>
+          </p15:clr>
+        </p15:guide>
+      </p15:sldGuideLst>
+    </p:ext>
+  </p:extLst>
 </p:presentation>
 </file>
 
 <file path=ppt/notesMasters/notesMaster1.xml><?xml version="1.0" encoding="utf-8"?>
-<p:notesMaster xmlns:a="http://schemas.openxmlformats.org/drawingml/2006/main" xmlns:p="http://schemas.openxmlformats.org/presentationml/2006/main" xmlns:r="http://schemas.openxmlformats.org/officeDocument/2006/relationships">
+<p:notesMaster xmlns:a="http://schemas.openxmlformats.org/drawingml/2006/main" xmlns:r="http://schemas.openxmlformats.org/officeDocument/2006/relationships" xmlns:p="http://schemas.openxmlformats.org/presentationml/2006/main">
   <p:cSld>
     <p:bg>
       <p:bgRef idx="1001">
@@ -140,241 +159,16 @@
           <a:chExt cx="0" cy="0"/>
         </a:xfrm>
       </p:grpSpPr>
-      <p:sp>
-        <p:nvSpPr>
-          <p:cNvPr id="2" name="Header Placeholder 1"/>
-          <p:cNvSpPr>
-            <a:spLocks noGrp="1"/>
-          </p:cNvSpPr>
-          <p:nvPr>
-            <p:ph type="hdr" sz="quarter"/>
-          </p:nvPr>
-        </p:nvSpPr>
-        <p:spPr>
-          <a:xfrm>
-            <a:off x="0" y="0"/>
-            <a:ext cx="2971800" cy="457200"/>
-          </a:xfrm>
-          <a:prstGeom prst="rect">
-            <a:avLst/>
-          </a:prstGeom>
-        </p:spPr>
-        <p:txBody>
-          <a:bodyPr vert="horz" lIns="91440" tIns="45720" rIns="91440" bIns="45720" rtlCol="0"/>
-          <a:lstStyle>
-            <a:lvl1pPr algn="l">
-              <a:defRPr sz="1200"/>
-            </a:lvl1pPr>
-          </a:lstStyle>
-          <a:p>
-            <a:endParaRPr lang="en-US"/>
-          </a:p>
-        </p:txBody>
-      </p:sp>
-      <p:sp>
-        <p:nvSpPr>
-          <p:cNvPr id="3" name="Date Placeholder 2"/>
-          <p:cNvSpPr>
-            <a:spLocks noGrp="1"/>
-          </p:cNvSpPr>
-          <p:nvPr>
-            <p:ph type="dt" idx="1"/>
-          </p:nvPr>
-        </p:nvSpPr>
-        <p:spPr>
-          <a:xfrm>
-            <a:off x="3884613" y="0"/>
-            <a:ext cx="2971800" cy="457200"/>
-          </a:xfrm>
-          <a:prstGeom prst="rect">
-            <a:avLst/>
-          </a:prstGeom>
-        </p:spPr>
-        <p:txBody>
-          <a:bodyPr vert="horz" lIns="91440" tIns="45720" rIns="91440" bIns="45720" rtlCol="0"/>
-          <a:lstStyle>
-            <a:lvl1pPr algn="r">
-              <a:defRPr sz="1200"/>
-            </a:lvl1pPr>
-          </a:lstStyle>
-          <a:p>
-            <a:fld id="{0F89C1C7-3DCD-1040-A9CF-14679D8B5DDD}" type="datetimeFigureOut">
-              <a:rPr lang="en-US" smtClean="0"/>
-              <a:t>10/17/16</a:t>
-            </a:fld>
-            <a:endParaRPr lang="en-US"/>
-          </a:p>
-        </p:txBody>
-      </p:sp>
-      <p:sp>
-        <p:nvSpPr>
-          <p:cNvPr id="4" name="Slide Image Placeholder 3"/>
-          <p:cNvSpPr>
-            <a:spLocks noGrp="1" noRot="1" noChangeAspect="1"/>
-          </p:cNvSpPr>
-          <p:nvPr>
-            <p:ph type="sldImg" idx="2"/>
-          </p:nvPr>
-        </p:nvSpPr>
-        <p:spPr>
-          <a:xfrm>
-            <a:off x="1143000" y="685800"/>
-            <a:ext cx="4572000" cy="3429000"/>
-          </a:xfrm>
-          <a:prstGeom prst="rect">
-            <a:avLst/>
-          </a:prstGeom>
-          <a:noFill/>
-          <a:ln w="12700">
-            <a:solidFill>
-              <a:prstClr val="black"/>
-            </a:solidFill>
-          </a:ln>
-        </p:spPr>
-        <p:txBody>
-          <a:bodyPr vert="horz" lIns="91440" tIns="45720" rIns="91440" bIns="45720" rtlCol="0" anchor="ctr"/>
-          <a:lstStyle/>
-          <a:p>
-            <a:endParaRPr lang="en-US"/>
-          </a:p>
-        </p:txBody>
-      </p:sp>
-      <p:sp>
-        <p:nvSpPr>
-          <p:cNvPr id="5" name="Notes Placeholder 4"/>
-          <p:cNvSpPr>
-            <a:spLocks noGrp="1"/>
-          </p:cNvSpPr>
-          <p:nvPr>
-            <p:ph type="body" sz="quarter" idx="3"/>
-          </p:nvPr>
-        </p:nvSpPr>
-        <p:spPr>
-          <a:xfrm>
-            <a:off x="685800" y="4343400"/>
-            <a:ext cx="5486400" cy="4114800"/>
-          </a:xfrm>
-          <a:prstGeom prst="rect">
-            <a:avLst/>
-          </a:prstGeom>
-        </p:spPr>
-        <p:txBody>
-          <a:bodyPr vert="horz" lIns="91440" tIns="45720" rIns="91440" bIns="45720" rtlCol="0"/>
-          <a:lstStyle/>
-          <a:p>
-            <a:pPr lvl="0"/>
-            <a:r>
-              <a:rPr lang="en-US" smtClean="0"/>
-              <a:t>Click to edit Master text styles</a:t>
-            </a:r>
-          </a:p>
-          <a:p>
-            <a:pPr lvl="1"/>
-            <a:r>
-              <a:rPr lang="en-US" smtClean="0"/>
-              <a:t>Second level</a:t>
-            </a:r>
-          </a:p>
-          <a:p>
-            <a:pPr lvl="2"/>
-            <a:r>
-              <a:rPr lang="en-US" smtClean="0"/>
-              <a:t>Third level</a:t>
-            </a:r>
-          </a:p>
-          <a:p>
-            <a:pPr lvl="3"/>
-            <a:r>
-              <a:rPr lang="en-US" smtClean="0"/>
-              <a:t>Fourth level</a:t>
-            </a:r>
-          </a:p>
-          <a:p>
-            <a:pPr lvl="4"/>
-            <a:r>
-              <a:rPr lang="en-US" smtClean="0"/>
-              <a:t>Fifth level</a:t>
-            </a:r>
-            <a:endParaRPr lang="en-US"/>
-          </a:p>
-        </p:txBody>
-      </p:sp>
-      <p:sp>
-        <p:nvSpPr>
-          <p:cNvPr id="6" name="Footer Placeholder 5"/>
-          <p:cNvSpPr>
-            <a:spLocks noGrp="1"/>
-          </p:cNvSpPr>
-          <p:nvPr>
-            <p:ph type="ftr" sz="quarter" idx="4"/>
-          </p:nvPr>
-        </p:nvSpPr>
-        <p:spPr>
-          <a:xfrm>
-            <a:off x="0" y="8685213"/>
-            <a:ext cx="2971800" cy="457200"/>
-          </a:xfrm>
-          <a:prstGeom prst="rect">
-            <a:avLst/>
-          </a:prstGeom>
-        </p:spPr>
-        <p:txBody>
-          <a:bodyPr vert="horz" lIns="91440" tIns="45720" rIns="91440" bIns="45720" rtlCol="0" anchor="b"/>
-          <a:lstStyle>
-            <a:lvl1pPr algn="l">
-              <a:defRPr sz="1200"/>
-            </a:lvl1pPr>
-          </a:lstStyle>
-          <a:p>
-            <a:endParaRPr lang="en-US"/>
-          </a:p>
-        </p:txBody>
-      </p:sp>
-      <p:sp>
-        <p:nvSpPr>
-          <p:cNvPr id="7" name="Slide Number Placeholder 6"/>
-          <p:cNvSpPr>
-            <a:spLocks noGrp="1"/>
-          </p:cNvSpPr>
-          <p:nvPr>
-            <p:ph type="sldNum" sz="quarter" idx="5"/>
-          </p:nvPr>
-        </p:nvSpPr>
-        <p:spPr>
-          <a:xfrm>
-            <a:off x="3884613" y="8685213"/>
-            <a:ext cx="2971800" cy="457200"/>
-          </a:xfrm>
-          <a:prstGeom prst="rect">
-            <a:avLst/>
-          </a:prstGeom>
-        </p:spPr>
-        <p:txBody>
-          <a:bodyPr vert="horz" lIns="91440" tIns="45720" rIns="91440" bIns="45720" rtlCol="0" anchor="b"/>
-          <a:lstStyle>
-            <a:lvl1pPr algn="r">
-              <a:defRPr sz="1200"/>
-            </a:lvl1pPr>
-          </a:lstStyle>
-          <a:p>
-            <a:fld id="{BB5E49A5-4136-284D-997B-48E1D791AD67}" type="slidenum">
-              <a:rPr lang="en-US" smtClean="0"/>
-              <a:t>‹#›</a:t>
-            </a:fld>
-            <a:endParaRPr lang="en-US"/>
-          </a:p>
-        </p:txBody>
-      </p:sp>
     </p:spTree>
     <p:extLst>
       <p:ext uri="{BB962C8B-B14F-4D97-AF65-F5344CB8AC3E}">
-        <p14:creationId xmlns:p14="http://schemas.microsoft.com/office/powerpoint/2010/main" val="2623252185"/>
+        <p14:creationId xmlns:p14="http://schemas.microsoft.com/office/powerpoint/2010/main" val="763076344"/>
       </p:ext>
     </p:extLst>
   </p:cSld>
   <p:clrMap bg1="lt1" tx1="dk1" bg2="lt2" tx2="dk2" accent1="accent1" accent2="accent2" accent3="accent3" accent4="accent4" accent5="accent5" accent6="accent6" hlink="hlink" folHlink="folHlink"/>
   <p:notesStyle>
-    <a:lvl1pPr marL="0" algn="l" defTabSz="457200" rtl="0" eaLnBrk="1" latinLnBrk="0" hangingPunct="1">
+    <a:lvl1pPr marL="0" algn="l" defTabSz="914400" rtl="0" eaLnBrk="1" latinLnBrk="0" hangingPunct="1">
       <a:defRPr sz="1200" kern="1200">
         <a:solidFill>
           <a:schemeClr val="tx1"/>
@@ -384,7 +178,7 @@
         <a:cs typeface="+mn-cs"/>
       </a:defRPr>
     </a:lvl1pPr>
-    <a:lvl2pPr marL="457200" algn="l" defTabSz="457200" rtl="0" eaLnBrk="1" latinLnBrk="0" hangingPunct="1">
+    <a:lvl2pPr marL="457200" algn="l" defTabSz="914400" rtl="0" eaLnBrk="1" latinLnBrk="0" hangingPunct="1">
       <a:defRPr sz="1200" kern="1200">
         <a:solidFill>
           <a:schemeClr val="tx1"/>
@@ -394,7 +188,7 @@
         <a:cs typeface="+mn-cs"/>
       </a:defRPr>
     </a:lvl2pPr>
-    <a:lvl3pPr marL="914400" algn="l" defTabSz="457200" rtl="0" eaLnBrk="1" latinLnBrk="0" hangingPunct="1">
+    <a:lvl3pPr marL="914400" algn="l" defTabSz="914400" rtl="0" eaLnBrk="1" latinLnBrk="0" hangingPunct="1">
       <a:defRPr sz="1200" kern="1200">
         <a:solidFill>
           <a:schemeClr val="tx1"/>
@@ -404,7 +198,7 @@
         <a:cs typeface="+mn-cs"/>
       </a:defRPr>
     </a:lvl3pPr>
-    <a:lvl4pPr marL="1371600" algn="l" defTabSz="457200" rtl="0" eaLnBrk="1" latinLnBrk="0" hangingPunct="1">
+    <a:lvl4pPr marL="1371600" algn="l" defTabSz="914400" rtl="0" eaLnBrk="1" latinLnBrk="0" hangingPunct="1">
       <a:defRPr sz="1200" kern="1200">
         <a:solidFill>
           <a:schemeClr val="tx1"/>
@@ -414,7 +208,7 @@
         <a:cs typeface="+mn-cs"/>
       </a:defRPr>
     </a:lvl4pPr>
-    <a:lvl5pPr marL="1828800" algn="l" defTabSz="457200" rtl="0" eaLnBrk="1" latinLnBrk="0" hangingPunct="1">
+    <a:lvl5pPr marL="1828800" algn="l" defTabSz="914400" rtl="0" eaLnBrk="1" latinLnBrk="0" hangingPunct="1">
       <a:defRPr sz="1200" kern="1200">
         <a:solidFill>
           <a:schemeClr val="tx1"/>
@@ -424,7 +218,7 @@
         <a:cs typeface="+mn-cs"/>
       </a:defRPr>
     </a:lvl5pPr>
-    <a:lvl6pPr marL="2286000" algn="l" defTabSz="457200" rtl="0" eaLnBrk="1" latinLnBrk="0" hangingPunct="1">
+    <a:lvl6pPr marL="2286000" algn="l" defTabSz="914400" rtl="0" eaLnBrk="1" latinLnBrk="0" hangingPunct="1">
       <a:defRPr sz="1200" kern="1200">
         <a:solidFill>
           <a:schemeClr val="tx1"/>
@@ -434,7 +228,7 @@
         <a:cs typeface="+mn-cs"/>
       </a:defRPr>
     </a:lvl6pPr>
-    <a:lvl7pPr marL="2743200" algn="l" defTabSz="457200" rtl="0" eaLnBrk="1" latinLnBrk="0" hangingPunct="1">
+    <a:lvl7pPr marL="2743200" algn="l" defTabSz="914400" rtl="0" eaLnBrk="1" latinLnBrk="0" hangingPunct="1">
       <a:defRPr sz="1200" kern="1200">
         <a:solidFill>
           <a:schemeClr val="tx1"/>
@@ -444,7 +238,7 @@
         <a:cs typeface="+mn-cs"/>
       </a:defRPr>
     </a:lvl7pPr>
-    <a:lvl8pPr marL="3200400" algn="l" defTabSz="457200" rtl="0" eaLnBrk="1" latinLnBrk="0" hangingPunct="1">
+    <a:lvl8pPr marL="3200400" algn="l" defTabSz="914400" rtl="0" eaLnBrk="1" latinLnBrk="0" hangingPunct="1">
       <a:defRPr sz="1200" kern="1200">
         <a:solidFill>
           <a:schemeClr val="tx1"/>
@@ -454,7 +248,7 @@
         <a:cs typeface="+mn-cs"/>
       </a:defRPr>
     </a:lvl8pPr>
-    <a:lvl9pPr marL="3657600" algn="l" defTabSz="457200" rtl="0" eaLnBrk="1" latinLnBrk="0" hangingPunct="1">
+    <a:lvl9pPr marL="3657600" algn="l" defTabSz="914400" rtl="0" eaLnBrk="1" latinLnBrk="0" hangingPunct="1">
       <a:defRPr sz="1200" kern="1200">
         <a:solidFill>
           <a:schemeClr val="tx1"/>
@@ -469,7 +263,7 @@
 </file>
 
 <file path=ppt/notesSlides/notesSlide1.xml><?xml version="1.0" encoding="utf-8"?>
-<p:notes xmlns:a="http://schemas.openxmlformats.org/drawingml/2006/main" xmlns:p="http://schemas.openxmlformats.org/presentationml/2006/main" xmlns:r="http://schemas.openxmlformats.org/officeDocument/2006/relationships">
+<p:notes xmlns:a="http://schemas.openxmlformats.org/drawingml/2006/main" xmlns:r="http://schemas.openxmlformats.org/officeDocument/2006/relationships" xmlns:p="http://schemas.openxmlformats.org/presentationml/2006/main">
   <p:cSld>
     <p:spTree>
       <p:nvGrpSpPr>
@@ -489,43 +283,43 @@
         <p:nvSpPr>
           <p:cNvPr id="2" name="Slide Image Placeholder 1"/>
           <p:cNvSpPr>
+            <a:spLocks noGrp="1" noRot="1" noChangeAspect="1"/>
+          </p:cNvSpPr>
+          <p:nvPr>
+            <p:ph type="sldImg" idx="2"/>
+          </p:nvPr>
+        </p:nvSpPr>
+        <p:spPr/>
+      </p:sp>
+      <p:sp>
+        <p:nvSpPr>
+          <p:cNvPr id="3" name="Notes Placeholder 2"/>
+          <p:cNvSpPr>
             <a:spLocks noGrp="1"/>
           </p:cNvSpPr>
           <p:nvPr>
-            <p:ph type="sldImg" idx="2"/>
+            <p:ph type="body" sz="quarter" idx="3"/>
           </p:nvPr>
         </p:nvSpPr>
         <p:spPr/>
-      </p:sp>
-      <p:sp>
-        <p:nvSpPr>
-          <p:cNvPr id="3" name="Notes Placeholder 2"/>
+        <p:txBody>
+          <a:bodyPr/>
+          <a:lstStyle/>
+          <a:p>
+            <a:r>
+              <a:t>SWITCH TO APP: have the dev server already open in a browser tab, pattern (a|b)*abb, test string babb, AST tab selected, ready before you start talking.</a:t>
+            </a:r>
+          </a:p>
+        </p:txBody>
+      </p:sp>
+      <p:sp>
+        <p:nvSpPr>
+          <p:cNvPr id="4" name="Slide Number Placeholder 3"/>
           <p:cNvSpPr>
             <a:spLocks noGrp="1"/>
           </p:cNvSpPr>
           <p:nvPr>
-            <p:ph type="body" idx="3" sz="quarter"/>
-          </p:nvPr>
-        </p:nvSpPr>
-        <p:spPr/>
-        <p:txBody>
-          <a:bodyPr/>
-          <a:lstStyle/>
-          <a:p>
-            <a:r>
-              <a:t>SWITCH TO APP: have the dev server already open in a browser tab, pattern (a|b)*abb, test string babb, AST tab selected, ready before you start talking.</a:t>
-            </a:r>
-          </a:p>
-        </p:txBody>
-      </p:sp>
-      <p:sp>
-        <p:nvSpPr>
-          <p:cNvPr id="4" name="Slide Number Placeholder 3"/>
-          <p:cNvSpPr>
-            <a:spLocks noGrp="1"/>
-          </p:cNvSpPr>
-          <p:nvPr>
-            <p:ph type="sldNum" idx="5" sz="quarter"/>
+            <p:ph type="sldNum" sz="quarter" idx="5"/>
           </p:nvPr>
         </p:nvSpPr>
         <p:spPr/>
@@ -539,7 +333,7 @@
 </file>
 
 <file path=ppt/notesSlides/notesSlide10.xml><?xml version="1.0" encoding="utf-8"?>
-<p:notes xmlns:a="http://schemas.openxmlformats.org/drawingml/2006/main" xmlns:p="http://schemas.openxmlformats.org/presentationml/2006/main" xmlns:r="http://schemas.openxmlformats.org/officeDocument/2006/relationships">
+<p:notes xmlns:a="http://schemas.openxmlformats.org/drawingml/2006/main" xmlns:r="http://schemas.openxmlformats.org/officeDocument/2006/relationships" xmlns:p="http://schemas.openxmlformats.org/presentationml/2006/main">
   <p:cSld>
     <p:spTree>
       <p:nvGrpSpPr>
@@ -559,43 +353,43 @@
         <p:nvSpPr>
           <p:cNvPr id="2" name="Slide Image Placeholder 1"/>
           <p:cNvSpPr>
+            <a:spLocks noGrp="1" noRot="1" noChangeAspect="1"/>
+          </p:cNvSpPr>
+          <p:nvPr>
+            <p:ph type="sldImg" idx="2"/>
+          </p:nvPr>
+        </p:nvSpPr>
+        <p:spPr/>
+      </p:sp>
+      <p:sp>
+        <p:nvSpPr>
+          <p:cNvPr id="3" name="Notes Placeholder 2"/>
+          <p:cNvSpPr>
             <a:spLocks noGrp="1"/>
           </p:cNvSpPr>
           <p:nvPr>
-            <p:ph type="sldImg" idx="2"/>
+            <p:ph type="body" sz="quarter" idx="3"/>
           </p:nvPr>
         </p:nvSpPr>
         <p:spPr/>
-      </p:sp>
-      <p:sp>
-        <p:nvSpPr>
-          <p:cNvPr id="3" name="Notes Placeholder 2"/>
+        <p:txBody>
+          <a:bodyPr/>
+          <a:lstStyle/>
+          <a:p>
+            <a:r>
+              <a:t>No demo. If asked how counts were obtained: npm ci + vitest run; cmake build + ./engine_tests, run fresh today, not recalled.</a:t>
+            </a:r>
+          </a:p>
+        </p:txBody>
+      </p:sp>
+      <p:sp>
+        <p:nvSpPr>
+          <p:cNvPr id="4" name="Slide Number Placeholder 3"/>
           <p:cNvSpPr>
             <a:spLocks noGrp="1"/>
           </p:cNvSpPr>
           <p:nvPr>
-            <p:ph type="body" idx="3" sz="quarter"/>
-          </p:nvPr>
-        </p:nvSpPr>
-        <p:spPr/>
-        <p:txBody>
-          <a:bodyPr/>
-          <a:lstStyle/>
-          <a:p>
-            <a:r>
-              <a:t>No demo. If asked how counts were obtained: npm ci + vitest run; cmake build + ./engine_tests, run fresh today, not recalled.</a:t>
-            </a:r>
-          </a:p>
-        </p:txBody>
-      </p:sp>
-      <p:sp>
-        <p:nvSpPr>
-          <p:cNvPr id="4" name="Slide Number Placeholder 3"/>
-          <p:cNvSpPr>
-            <a:spLocks noGrp="1"/>
-          </p:cNvSpPr>
-          <p:nvPr>
-            <p:ph type="sldNum" idx="5" sz="quarter"/>
+            <p:ph type="sldNum" sz="quarter" idx="5"/>
           </p:nvPr>
         </p:nvSpPr>
         <p:spPr/>
@@ -609,7 +403,7 @@
 </file>
 
 <file path=ppt/notesSlides/notesSlide11.xml><?xml version="1.0" encoding="utf-8"?>
-<p:notes xmlns:a="http://schemas.openxmlformats.org/drawingml/2006/main" xmlns:p="http://schemas.openxmlformats.org/presentationml/2006/main" xmlns:r="http://schemas.openxmlformats.org/officeDocument/2006/relationships">
+<p:notes xmlns:a="http://schemas.openxmlformats.org/drawingml/2006/main" xmlns:r="http://schemas.openxmlformats.org/officeDocument/2006/relationships" xmlns:p="http://schemas.openxmlformats.org/presentationml/2006/main">
   <p:cSld>
     <p:spTree>
       <p:nvGrpSpPr>
@@ -629,48 +423,48 @@
         <p:nvSpPr>
           <p:cNvPr id="2" name="Slide Image Placeholder 1"/>
           <p:cNvSpPr>
+            <a:spLocks noGrp="1" noRot="1" noChangeAspect="1"/>
+          </p:cNvSpPr>
+          <p:nvPr>
+            <p:ph type="sldImg" idx="2"/>
+          </p:nvPr>
+        </p:nvSpPr>
+        <p:spPr/>
+      </p:sp>
+      <p:sp>
+        <p:nvSpPr>
+          <p:cNvPr id="3" name="Notes Placeholder 2"/>
+          <p:cNvSpPr>
             <a:spLocks noGrp="1"/>
           </p:cNvSpPr>
           <p:nvPr>
-            <p:ph type="sldImg" idx="2"/>
+            <p:ph type="body" sz="quarter" idx="3"/>
           </p:nvPr>
         </p:nvSpPr>
         <p:spPr/>
-      </p:sp>
-      <p:sp>
-        <p:nvSpPr>
-          <p:cNvPr id="3" name="Notes Placeholder 2"/>
+        <p:txBody>
+          <a:bodyPr/>
+          <a:lstStyle/>
+          <a:p>
+            <a:r>
+              <a:t>No demo. These are deliberate scope decisions, so say that plainly and don't apologize for them.</a:t>
+            </a:r>
+          </a:p>
+          <a:p>
+            <a:r>
+              <a:t>Also mention if there's time: character classes, +, and ? are literal characters today, not operators, scoped out on purpose; backreferences and lookahead are permanently out of scope since they are not regular languages.</a:t>
+            </a:r>
+          </a:p>
+        </p:txBody>
+      </p:sp>
+      <p:sp>
+        <p:nvSpPr>
+          <p:cNvPr id="4" name="Slide Number Placeholder 3"/>
           <p:cNvSpPr>
             <a:spLocks noGrp="1"/>
           </p:cNvSpPr>
           <p:nvPr>
-            <p:ph type="body" idx="3" sz="quarter"/>
-          </p:nvPr>
-        </p:nvSpPr>
-        <p:spPr/>
-        <p:txBody>
-          <a:bodyPr/>
-          <a:lstStyle/>
-          <a:p>
-            <a:r>
-              <a:t>No demo. These are deliberate scope decisions, so say that plainly and don't apologize for them.</a:t>
-            </a:r>
-          </a:p>
-          <a:p>
-            <a:r>
-              <a:t>Also mention if there's time: character classes, +, and ? are literal characters today, not operators, scoped out on purpose; backreferences and lookahead are permanently out of scope since they are not regular languages.</a:t>
-            </a:r>
-          </a:p>
-        </p:txBody>
-      </p:sp>
-      <p:sp>
-        <p:nvSpPr>
-          <p:cNvPr id="4" name="Slide Number Placeholder 3"/>
-          <p:cNvSpPr>
-            <a:spLocks noGrp="1"/>
-          </p:cNvSpPr>
-          <p:nvPr>
-            <p:ph type="sldNum" idx="5" sz="quarter"/>
+            <p:ph type="sldNum" sz="quarter" idx="5"/>
           </p:nvPr>
         </p:nvSpPr>
         <p:spPr/>
@@ -684,7 +478,7 @@
 </file>
 
 <file path=ppt/notesSlides/notesSlide12.xml><?xml version="1.0" encoding="utf-8"?>
-<p:notes xmlns:a="http://schemas.openxmlformats.org/drawingml/2006/main" xmlns:p="http://schemas.openxmlformats.org/presentationml/2006/main" xmlns:r="http://schemas.openxmlformats.org/officeDocument/2006/relationships">
+<p:notes xmlns:a="http://schemas.openxmlformats.org/drawingml/2006/main" xmlns:r="http://schemas.openxmlformats.org/officeDocument/2006/relationships" xmlns:p="http://schemas.openxmlformats.org/presentationml/2006/main">
   <p:cSld>
     <p:spTree>
       <p:nvGrpSpPr>
@@ -704,43 +498,43 @@
         <p:nvSpPr>
           <p:cNvPr id="2" name="Slide Image Placeholder 1"/>
           <p:cNvSpPr>
+            <a:spLocks noGrp="1" noRot="1" noChangeAspect="1"/>
+          </p:cNvSpPr>
+          <p:nvPr>
+            <p:ph type="sldImg" idx="2"/>
+          </p:nvPr>
+        </p:nvSpPr>
+        <p:spPr/>
+      </p:sp>
+      <p:sp>
+        <p:nvSpPr>
+          <p:cNvPr id="3" name="Notes Placeholder 2"/>
+          <p:cNvSpPr>
             <a:spLocks noGrp="1"/>
           </p:cNvSpPr>
           <p:nvPr>
-            <p:ph type="sldImg" idx="2"/>
+            <p:ph type="body" sz="quarter" idx="3"/>
           </p:nvPr>
         </p:nvSpPr>
         <p:spPr/>
-      </p:sp>
-      <p:sp>
-        <p:nvSpPr>
-          <p:cNvPr id="3" name="Notes Placeholder 2"/>
+        <p:txBody>
+          <a:bodyPr/>
+          <a:lstStyle/>
+          <a:p>
+            <a:r>
+              <a:t>Have docs/review-prep-plan.md section (d) open off-screen for the 12 prepped questions.</a:t>
+            </a:r>
+          </a:p>
+        </p:txBody>
+      </p:sp>
+      <p:sp>
+        <p:nvSpPr>
+          <p:cNvPr id="4" name="Slide Number Placeholder 3"/>
           <p:cNvSpPr>
             <a:spLocks noGrp="1"/>
           </p:cNvSpPr>
           <p:nvPr>
-            <p:ph type="body" idx="3" sz="quarter"/>
-          </p:nvPr>
-        </p:nvSpPr>
-        <p:spPr/>
-        <p:txBody>
-          <a:bodyPr/>
-          <a:lstStyle/>
-          <a:p>
-            <a:r>
-              <a:t>Have docs/review-prep-plan.md section (d) open off-screen for the 12 prepped questions.</a:t>
-            </a:r>
-          </a:p>
-        </p:txBody>
-      </p:sp>
-      <p:sp>
-        <p:nvSpPr>
-          <p:cNvPr id="4" name="Slide Number Placeholder 3"/>
-          <p:cNvSpPr>
-            <a:spLocks noGrp="1"/>
-          </p:cNvSpPr>
-          <p:nvPr>
-            <p:ph type="sldNum" idx="5" sz="quarter"/>
+            <p:ph type="sldNum" sz="quarter" idx="5"/>
           </p:nvPr>
         </p:nvSpPr>
         <p:spPr/>
@@ -754,7 +548,7 @@
 </file>
 
 <file path=ppt/notesSlides/notesSlide2.xml><?xml version="1.0" encoding="utf-8"?>
-<p:notes xmlns:a="http://schemas.openxmlformats.org/drawingml/2006/main" xmlns:p="http://schemas.openxmlformats.org/presentationml/2006/main" xmlns:r="http://schemas.openxmlformats.org/officeDocument/2006/relationships">
+<p:notes xmlns:a="http://schemas.openxmlformats.org/drawingml/2006/main" xmlns:r="http://schemas.openxmlformats.org/officeDocument/2006/relationships" xmlns:p="http://schemas.openxmlformats.org/presentationml/2006/main">
   <p:cSld>
     <p:spTree>
       <p:nvGrpSpPr>
@@ -774,43 +568,43 @@
         <p:nvSpPr>
           <p:cNvPr id="2" name="Slide Image Placeholder 1"/>
           <p:cNvSpPr>
+            <a:spLocks noGrp="1" noRot="1" noChangeAspect="1"/>
+          </p:cNvSpPr>
+          <p:nvPr>
+            <p:ph type="sldImg" idx="2"/>
+          </p:nvPr>
+        </p:nvSpPr>
+        <p:spPr/>
+      </p:sp>
+      <p:sp>
+        <p:nvSpPr>
+          <p:cNvPr id="3" name="Notes Placeholder 2"/>
+          <p:cNvSpPr>
             <a:spLocks noGrp="1"/>
           </p:cNvSpPr>
           <p:nvPr>
-            <p:ph type="sldImg" idx="2"/>
+            <p:ph type="body" sz="quarter" idx="3"/>
           </p:nvPr>
         </p:nvSpPr>
         <p:spPr/>
-      </p:sp>
-      <p:sp>
-        <p:nvSpPr>
-          <p:cNvPr id="3" name="Notes Placeholder 2"/>
+        <p:txBody>
+          <a:bodyPr/>
+          <a:lstStyle/>
+          <a:p>
+            <a:r>
+              <a:t>No demo on this slide. State the problem plainly, move on quickly.</a:t>
+            </a:r>
+          </a:p>
+        </p:txBody>
+      </p:sp>
+      <p:sp>
+        <p:nvSpPr>
+          <p:cNvPr id="4" name="Slide Number Placeholder 3"/>
           <p:cNvSpPr>
             <a:spLocks noGrp="1"/>
           </p:cNvSpPr>
           <p:nvPr>
-            <p:ph type="body" idx="3" sz="quarter"/>
-          </p:nvPr>
-        </p:nvSpPr>
-        <p:spPr/>
-        <p:txBody>
-          <a:bodyPr/>
-          <a:lstStyle/>
-          <a:p>
-            <a:r>
-              <a:t>No demo on this slide. State the problem plainly, move on quickly.</a:t>
-            </a:r>
-          </a:p>
-        </p:txBody>
-      </p:sp>
-      <p:sp>
-        <p:nvSpPr>
-          <p:cNvPr id="4" name="Slide Number Placeholder 3"/>
-          <p:cNvSpPr>
-            <a:spLocks noGrp="1"/>
-          </p:cNvSpPr>
-          <p:nvPr>
-            <p:ph type="sldNum" idx="5" sz="quarter"/>
+            <p:ph type="sldNum" sz="quarter" idx="5"/>
           </p:nvPr>
         </p:nvSpPr>
         <p:spPr/>
@@ -824,7 +618,7 @@
 </file>
 
 <file path=ppt/notesSlides/notesSlide3.xml><?xml version="1.0" encoding="utf-8"?>
-<p:notes xmlns:a="http://schemas.openxmlformats.org/drawingml/2006/main" xmlns:p="http://schemas.openxmlformats.org/presentationml/2006/main" xmlns:r="http://schemas.openxmlformats.org/officeDocument/2006/relationships">
+<p:notes xmlns:a="http://schemas.openxmlformats.org/drawingml/2006/main" xmlns:r="http://schemas.openxmlformats.org/officeDocument/2006/relationships" xmlns:p="http://schemas.openxmlformats.org/presentationml/2006/main">
   <p:cSld>
     <p:spTree>
       <p:nvGrpSpPr>
@@ -844,43 +638,43 @@
         <p:nvSpPr>
           <p:cNvPr id="2" name="Slide Image Placeholder 1"/>
           <p:cNvSpPr>
+            <a:spLocks noGrp="1" noRot="1" noChangeAspect="1"/>
+          </p:cNvSpPr>
+          <p:nvPr>
+            <p:ph type="sldImg" idx="2"/>
+          </p:nvPr>
+        </p:nvSpPr>
+        <p:spPr/>
+      </p:sp>
+      <p:sp>
+        <p:nvSpPr>
+          <p:cNvPr id="3" name="Notes Placeholder 2"/>
+          <p:cNvSpPr>
             <a:spLocks noGrp="1"/>
           </p:cNvSpPr>
           <p:nvPr>
-            <p:ph type="sldImg" idx="2"/>
+            <p:ph type="body" sz="quarter" idx="3"/>
           </p:nvPr>
         </p:nvSpPr>
         <p:spPr/>
-      </p:sp>
-      <p:sp>
-        <p:nvSpPr>
-          <p:cNvPr id="3" name="Notes Placeholder 2"/>
+        <p:txBody>
+          <a:bodyPr/>
+          <a:lstStyle/>
+          <a:p>
+            <a:r>
+              <a:t>No demo yet. Point at the boxes left to right while saying the pipeline sentence.</a:t>
+            </a:r>
+          </a:p>
+        </p:txBody>
+      </p:sp>
+      <p:sp>
+        <p:nvSpPr>
+          <p:cNvPr id="4" name="Slide Number Placeholder 3"/>
           <p:cNvSpPr>
             <a:spLocks noGrp="1"/>
           </p:cNvSpPr>
           <p:nvPr>
-            <p:ph type="body" idx="3" sz="quarter"/>
-          </p:nvPr>
-        </p:nvSpPr>
-        <p:spPr/>
-        <p:txBody>
-          <a:bodyPr/>
-          <a:lstStyle/>
-          <a:p>
-            <a:r>
-              <a:t>No demo yet. Point at the boxes left to right while saying the pipeline sentence.</a:t>
-            </a:r>
-          </a:p>
-        </p:txBody>
-      </p:sp>
-      <p:sp>
-        <p:nvSpPr>
-          <p:cNvPr id="4" name="Slide Number Placeholder 3"/>
-          <p:cNvSpPr>
-            <a:spLocks noGrp="1"/>
-          </p:cNvSpPr>
-          <p:nvPr>
-            <p:ph type="sldNum" idx="5" sz="quarter"/>
+            <p:ph type="sldNum" sz="quarter" idx="5"/>
           </p:nvPr>
         </p:nvSpPr>
         <p:spPr/>
@@ -894,7 +688,7 @@
 </file>
 
 <file path=ppt/notesSlides/notesSlide4.xml><?xml version="1.0" encoding="utf-8"?>
-<p:notes xmlns:a="http://schemas.openxmlformats.org/drawingml/2006/main" xmlns:p="http://schemas.openxmlformats.org/presentationml/2006/main" xmlns:r="http://schemas.openxmlformats.org/officeDocument/2006/relationships">
+<p:notes xmlns:a="http://schemas.openxmlformats.org/drawingml/2006/main" xmlns:r="http://schemas.openxmlformats.org/officeDocument/2006/relationships" xmlns:p="http://schemas.openxmlformats.org/presentationml/2006/main">
   <p:cSld>
     <p:spTree>
       <p:nvGrpSpPr>
@@ -914,43 +708,43 @@
         <p:nvSpPr>
           <p:cNvPr id="2" name="Slide Image Placeholder 1"/>
           <p:cNvSpPr>
+            <a:spLocks noGrp="1" noRot="1" noChangeAspect="1"/>
+          </p:cNvSpPr>
+          <p:nvPr>
+            <p:ph type="sldImg" idx="2"/>
+          </p:nvPr>
+        </p:nvSpPr>
+        <p:spPr/>
+      </p:sp>
+      <p:sp>
+        <p:nvSpPr>
+          <p:cNvPr id="3" name="Notes Placeholder 2"/>
+          <p:cNvSpPr>
             <a:spLocks noGrp="1"/>
           </p:cNvSpPr>
           <p:nvPr>
-            <p:ph type="sldImg" idx="2"/>
+            <p:ph type="body" sz="quarter" idx="3"/>
           </p:nvPr>
         </p:nvSpPr>
         <p:spPr/>
-      </p:sp>
-      <p:sp>
-        <p:nvSpPr>
-          <p:cNvPr id="3" name="Notes Placeholder 2"/>
+        <p:txBody>
+          <a:bodyPr/>
+          <a:lstStyle/>
+          <a:p>
+            <a:r>
+              <a:t>SWITCH TO APP: type (a|b)*abb in Pattern, point at the AST tab. Then type (ab and show the UnmatchedParen error and its position.</a:t>
+            </a:r>
+          </a:p>
+        </p:txBody>
+      </p:sp>
+      <p:sp>
+        <p:nvSpPr>
+          <p:cNvPr id="4" name="Slide Number Placeholder 3"/>
           <p:cNvSpPr>
             <a:spLocks noGrp="1"/>
           </p:cNvSpPr>
           <p:nvPr>
-            <p:ph type="body" idx="3" sz="quarter"/>
-          </p:nvPr>
-        </p:nvSpPr>
-        <p:spPr/>
-        <p:txBody>
-          <a:bodyPr/>
-          <a:lstStyle/>
-          <a:p>
-            <a:r>
-              <a:t>SWITCH TO APP: type (a|b)*abb in Pattern, point at the AST tab. Then type (ab and show the UnmatchedParen error and its position.</a:t>
-            </a:r>
-          </a:p>
-        </p:txBody>
-      </p:sp>
-      <p:sp>
-        <p:nvSpPr>
-          <p:cNvPr id="4" name="Slide Number Placeholder 3"/>
-          <p:cNvSpPr>
-            <a:spLocks noGrp="1"/>
-          </p:cNvSpPr>
-          <p:nvPr>
-            <p:ph type="sldNum" idx="5" sz="quarter"/>
+            <p:ph type="sldNum" sz="quarter" idx="5"/>
           </p:nvPr>
         </p:nvSpPr>
         <p:spPr/>
@@ -964,7 +758,7 @@
 </file>
 
 <file path=ppt/notesSlides/notesSlide5.xml><?xml version="1.0" encoding="utf-8"?>
-<p:notes xmlns:a="http://schemas.openxmlformats.org/drawingml/2006/main" xmlns:p="http://schemas.openxmlformats.org/presentationml/2006/main" xmlns:r="http://schemas.openxmlformats.org/officeDocument/2006/relationships">
+<p:notes xmlns:a="http://schemas.openxmlformats.org/drawingml/2006/main" xmlns:r="http://schemas.openxmlformats.org/officeDocument/2006/relationships" xmlns:p="http://schemas.openxmlformats.org/presentationml/2006/main">
   <p:cSld>
     <p:spTree>
       <p:nvGrpSpPr>
@@ -984,43 +778,44 @@
         <p:nvSpPr>
           <p:cNvPr id="2" name="Slide Image Placeholder 1"/>
           <p:cNvSpPr>
+            <a:spLocks noGrp="1" noRot="1" noChangeAspect="1"/>
+          </p:cNvSpPr>
+          <p:nvPr>
+            <p:ph type="sldImg" idx="2"/>
+          </p:nvPr>
+        </p:nvSpPr>
+        <p:spPr/>
+      </p:sp>
+      <p:sp>
+        <p:nvSpPr>
+          <p:cNvPr id="3" name="Notes Placeholder 2"/>
+          <p:cNvSpPr>
             <a:spLocks noGrp="1"/>
           </p:cNvSpPr>
           <p:nvPr>
-            <p:ph type="sldImg" idx="2"/>
+            <p:ph type="body" sz="quarter" idx="3"/>
           </p:nvPr>
         </p:nvSpPr>
         <p:spPr/>
-      </p:sp>
-      <p:sp>
-        <p:nvSpPr>
-          <p:cNvPr id="3" name="Notes Placeholder 2"/>
+        <p:txBody>
+          <a:bodyPr/>
+          <a:lstStyle/>
+          <a:p>
+            <a:r>
+              <a:rPr dirty="0"/>
+              <a:t>SWITCH TO APP: NFA tab. Point at an epsilon edge and the active-state highlight.</a:t>
+            </a:r>
+          </a:p>
+        </p:txBody>
+      </p:sp>
+      <p:sp>
+        <p:nvSpPr>
+          <p:cNvPr id="4" name="Slide Number Placeholder 3"/>
           <p:cNvSpPr>
             <a:spLocks noGrp="1"/>
           </p:cNvSpPr>
           <p:nvPr>
-            <p:ph type="body" idx="3" sz="quarter"/>
-          </p:nvPr>
-        </p:nvSpPr>
-        <p:spPr/>
-        <p:txBody>
-          <a:bodyPr/>
-          <a:lstStyle/>
-          <a:p>
-            <a:r>
-              <a:t>SWITCH TO APP: NFA tab. Point at an epsilon edge and the active-state highlight.</a:t>
-            </a:r>
-          </a:p>
-        </p:txBody>
-      </p:sp>
-      <p:sp>
-        <p:nvSpPr>
-          <p:cNvPr id="4" name="Slide Number Placeholder 3"/>
-          <p:cNvSpPr>
-            <a:spLocks noGrp="1"/>
-          </p:cNvSpPr>
-          <p:nvPr>
-            <p:ph type="sldNum" idx="5" sz="quarter"/>
+            <p:ph type="sldNum" sz="quarter" idx="5"/>
           </p:nvPr>
         </p:nvSpPr>
         <p:spPr/>
@@ -1034,7 +829,7 @@
 </file>
 
 <file path=ppt/notesSlides/notesSlide6.xml><?xml version="1.0" encoding="utf-8"?>
-<p:notes xmlns:a="http://schemas.openxmlformats.org/drawingml/2006/main" xmlns:p="http://schemas.openxmlformats.org/presentationml/2006/main" xmlns:r="http://schemas.openxmlformats.org/officeDocument/2006/relationships">
+<p:notes xmlns:a="http://schemas.openxmlformats.org/drawingml/2006/main" xmlns:r="http://schemas.openxmlformats.org/officeDocument/2006/relationships" xmlns:p="http://schemas.openxmlformats.org/presentationml/2006/main">
   <p:cSld>
     <p:spTree>
       <p:nvGrpSpPr>
@@ -1054,43 +849,43 @@
         <p:nvSpPr>
           <p:cNvPr id="2" name="Slide Image Placeholder 1"/>
           <p:cNvSpPr>
+            <a:spLocks noGrp="1" noRot="1" noChangeAspect="1"/>
+          </p:cNvSpPr>
+          <p:nvPr>
+            <p:ph type="sldImg" idx="2"/>
+          </p:nvPr>
+        </p:nvSpPr>
+        <p:spPr/>
+      </p:sp>
+      <p:sp>
+        <p:nvSpPr>
+          <p:cNvPr id="3" name="Notes Placeholder 2"/>
+          <p:cNvSpPr>
             <a:spLocks noGrp="1"/>
           </p:cNvSpPr>
           <p:nvPr>
-            <p:ph type="sldImg" idx="2"/>
+            <p:ph type="body" sz="quarter" idx="3"/>
           </p:nvPr>
         </p:nvSpPr>
         <p:spPr/>
-      </p:sp>
-      <p:sp>
-        <p:nvSpPr>
-          <p:cNvPr id="3" name="Notes Placeholder 2"/>
+        <p:txBody>
+          <a:bodyPr/>
+          <a:lstStyle/>
+          <a:p>
+            <a:r>
+              <a:t>SWITCH TO APP: DFA tab. Point at the caption showing the NFA-set-for-this-prefix annotation.</a:t>
+            </a:r>
+          </a:p>
+        </p:txBody>
+      </p:sp>
+      <p:sp>
+        <p:nvSpPr>
+          <p:cNvPr id="4" name="Slide Number Placeholder 3"/>
           <p:cNvSpPr>
             <a:spLocks noGrp="1"/>
           </p:cNvSpPr>
           <p:nvPr>
-            <p:ph type="body" idx="3" sz="quarter"/>
-          </p:nvPr>
-        </p:nvSpPr>
-        <p:spPr/>
-        <p:txBody>
-          <a:bodyPr/>
-          <a:lstStyle/>
-          <a:p>
-            <a:r>
-              <a:t>SWITCH TO APP: DFA tab. Point at the caption showing the NFA-set-for-this-prefix annotation.</a:t>
-            </a:r>
-          </a:p>
-        </p:txBody>
-      </p:sp>
-      <p:sp>
-        <p:nvSpPr>
-          <p:cNvPr id="4" name="Slide Number Placeholder 3"/>
-          <p:cNvSpPr>
-            <a:spLocks noGrp="1"/>
-          </p:cNvSpPr>
-          <p:nvPr>
-            <p:ph type="sldNum" idx="5" sz="quarter"/>
+            <p:ph type="sldNum" sz="quarter" idx="5"/>
           </p:nvPr>
         </p:nvSpPr>
         <p:spPr/>
@@ -1104,7 +899,7 @@
 </file>
 
 <file path=ppt/notesSlides/notesSlide7.xml><?xml version="1.0" encoding="utf-8"?>
-<p:notes xmlns:a="http://schemas.openxmlformats.org/drawingml/2006/main" xmlns:p="http://schemas.openxmlformats.org/presentationml/2006/main" xmlns:r="http://schemas.openxmlformats.org/officeDocument/2006/relationships">
+<p:notes xmlns:a="http://schemas.openxmlformats.org/drawingml/2006/main" xmlns:r="http://schemas.openxmlformats.org/officeDocument/2006/relationships" xmlns:p="http://schemas.openxmlformats.org/presentationml/2006/main">
   <p:cSld>
     <p:spTree>
       <p:nvGrpSpPr>
@@ -1124,43 +919,43 @@
         <p:nvSpPr>
           <p:cNvPr id="2" name="Slide Image Placeholder 1"/>
           <p:cNvSpPr>
+            <a:spLocks noGrp="1" noRot="1" noChangeAspect="1"/>
+          </p:cNvSpPr>
+          <p:nvPr>
+            <p:ph type="sldImg" idx="2"/>
+          </p:nvPr>
+        </p:nvSpPr>
+        <p:spPr/>
+      </p:sp>
+      <p:sp>
+        <p:nvSpPr>
+          <p:cNvPr id="3" name="Notes Placeholder 2"/>
+          <p:cNvSpPr>
             <a:spLocks noGrp="1"/>
           </p:cNvSpPr>
           <p:nvPr>
-            <p:ph type="sldImg" idx="2"/>
+            <p:ph type="body" sz="quarter" idx="3"/>
           </p:nvPr>
         </p:nvSpPr>
         <p:spPr/>
-      </p:sp>
-      <p:sp>
-        <p:nvSpPr>
-          <p:cNvPr id="3" name="Notes Placeholder 2"/>
+        <p:txBody>
+          <a:bodyPr/>
+          <a:lstStyle/>
+          <a:p>
+            <a:r>
+              <a:t>No image here, the min-DFA diagram is on the next slide (matching). Say the fixpoint rule clearly since it's a likely question.</a:t>
+            </a:r>
+          </a:p>
+        </p:txBody>
+      </p:sp>
+      <p:sp>
+        <p:nvSpPr>
+          <p:cNvPr id="4" name="Slide Number Placeholder 3"/>
           <p:cNvSpPr>
             <a:spLocks noGrp="1"/>
           </p:cNvSpPr>
           <p:nvPr>
-            <p:ph type="body" idx="3" sz="quarter"/>
-          </p:nvPr>
-        </p:nvSpPr>
-        <p:spPr/>
-        <p:txBody>
-          <a:bodyPr/>
-          <a:lstStyle/>
-          <a:p>
-            <a:r>
-              <a:t>No image here, the min-DFA diagram is on the next slide (matching). Say the fixpoint rule clearly since it's a likely question.</a:t>
-            </a:r>
-          </a:p>
-        </p:txBody>
-      </p:sp>
-      <p:sp>
-        <p:nvSpPr>
-          <p:cNvPr id="4" name="Slide Number Placeholder 3"/>
-          <p:cNvSpPr>
-            <a:spLocks noGrp="1"/>
-          </p:cNvSpPr>
-          <p:nvPr>
-            <p:ph type="sldNum" idx="5" sz="quarter"/>
+            <p:ph type="sldNum" sz="quarter" idx="5"/>
           </p:nvPr>
         </p:nvSpPr>
         <p:spPr/>
@@ -1174,7 +969,7 @@
 </file>
 
 <file path=ppt/notesSlides/notesSlide8.xml><?xml version="1.0" encoding="utf-8"?>
-<p:notes xmlns:a="http://schemas.openxmlformats.org/drawingml/2006/main" xmlns:p="http://schemas.openxmlformats.org/presentationml/2006/main" xmlns:r="http://schemas.openxmlformats.org/officeDocument/2006/relationships">
+<p:notes xmlns:a="http://schemas.openxmlformats.org/drawingml/2006/main" xmlns:r="http://schemas.openxmlformats.org/officeDocument/2006/relationships" xmlns:p="http://schemas.openxmlformats.org/presentationml/2006/main">
   <p:cSld>
     <p:spTree>
       <p:nvGrpSpPr>
@@ -1194,43 +989,43 @@
         <p:nvSpPr>
           <p:cNvPr id="2" name="Slide Image Placeholder 1"/>
           <p:cNvSpPr>
+            <a:spLocks noGrp="1" noRot="1" noChangeAspect="1"/>
+          </p:cNvSpPr>
+          <p:nvPr>
+            <p:ph type="sldImg" idx="2"/>
+          </p:nvPr>
+        </p:nvSpPr>
+        <p:spPr/>
+      </p:sp>
+      <p:sp>
+        <p:nvSpPr>
+          <p:cNvPr id="3" name="Notes Placeholder 2"/>
+          <p:cNvSpPr>
             <a:spLocks noGrp="1"/>
           </p:cNvSpPr>
           <p:nvPr>
-            <p:ph type="sldImg" idx="2"/>
+            <p:ph type="body" sz="quarter" idx="3"/>
           </p:nvPr>
         </p:nvSpPr>
         <p:spPr/>
-      </p:sp>
-      <p:sp>
-        <p:nvSpPr>
-          <p:cNvPr id="3" name="Notes Placeholder 2"/>
+        <p:txBody>
+          <a:bodyPr/>
+          <a:lstStyle/>
+          <a:p>
+            <a:r>
+              <a:t>SWITCH TO APP: min-DFA tab, test string babb, point at Accepted. Then change to abab, point at Rejected.</a:t>
+            </a:r>
+          </a:p>
+        </p:txBody>
+      </p:sp>
+      <p:sp>
+        <p:nvSpPr>
+          <p:cNvPr id="4" name="Slide Number Placeholder 3"/>
           <p:cNvSpPr>
             <a:spLocks noGrp="1"/>
           </p:cNvSpPr>
           <p:nvPr>
-            <p:ph type="body" idx="3" sz="quarter"/>
-          </p:nvPr>
-        </p:nvSpPr>
-        <p:spPr/>
-        <p:txBody>
-          <a:bodyPr/>
-          <a:lstStyle/>
-          <a:p>
-            <a:r>
-              <a:t>SWITCH TO APP: min-DFA tab, test string babb, point at Accepted. Then change to abab, point at Rejected.</a:t>
-            </a:r>
-          </a:p>
-        </p:txBody>
-      </p:sp>
-      <p:sp>
-        <p:nvSpPr>
-          <p:cNvPr id="4" name="Slide Number Placeholder 3"/>
-          <p:cNvSpPr>
-            <a:spLocks noGrp="1"/>
-          </p:cNvSpPr>
-          <p:nvPr>
-            <p:ph type="sldNum" idx="5" sz="quarter"/>
+            <p:ph type="sldNum" sz="quarter" idx="5"/>
           </p:nvPr>
         </p:nvSpPr>
         <p:spPr/>
@@ -1244,7 +1039,7 @@
 </file>
 
 <file path=ppt/notesSlides/notesSlide9.xml><?xml version="1.0" encoding="utf-8"?>
-<p:notes xmlns:a="http://schemas.openxmlformats.org/drawingml/2006/main" xmlns:p="http://schemas.openxmlformats.org/presentationml/2006/main" xmlns:r="http://schemas.openxmlformats.org/officeDocument/2006/relationships">
+<p:notes xmlns:a="http://schemas.openxmlformats.org/drawingml/2006/main" xmlns:r="http://schemas.openxmlformats.org/officeDocument/2006/relationships" xmlns:p="http://schemas.openxmlformats.org/presentationml/2006/main">
   <p:cSld>
     <p:spTree>
       <p:nvGrpSpPr>
@@ -1264,43 +1059,43 @@
         <p:nvSpPr>
           <p:cNvPr id="2" name="Slide Image Placeholder 1"/>
           <p:cNvSpPr>
+            <a:spLocks noGrp="1" noRot="1" noChangeAspect="1"/>
+          </p:cNvSpPr>
+          <p:nvPr>
+            <p:ph type="sldImg" idx="2"/>
+          </p:nvPr>
+        </p:nvSpPr>
+        <p:spPr/>
+      </p:sp>
+      <p:sp>
+        <p:nvSpPr>
+          <p:cNvPr id="3" name="Notes Placeholder 2"/>
+          <p:cNvSpPr>
             <a:spLocks noGrp="1"/>
           </p:cNvSpPr>
           <p:nvPr>
-            <p:ph type="sldImg" idx="2"/>
+            <p:ph type="body" sz="quarter" idx="3"/>
           </p:nvPr>
         </p:nvSpPr>
         <p:spPr/>
-      </p:sp>
-      <p:sp>
-        <p:nvSpPr>
-          <p:cNvPr id="3" name="Notes Placeholder 2"/>
+        <p:txBody>
+          <a:bodyPr/>
+          <a:lstStyle/>
+          <a:p>
+            <a:r>
+              <a:t>SWITCH TO APP: NFA tab, click the step-forward arrow a couple of times, point at the multiple highlighted states and the purple traversed edges.</a:t>
+            </a:r>
+          </a:p>
+        </p:txBody>
+      </p:sp>
+      <p:sp>
+        <p:nvSpPr>
+          <p:cNvPr id="4" name="Slide Number Placeholder 3"/>
           <p:cNvSpPr>
             <a:spLocks noGrp="1"/>
           </p:cNvSpPr>
           <p:nvPr>
-            <p:ph type="body" idx="3" sz="quarter"/>
-          </p:nvPr>
-        </p:nvSpPr>
-        <p:spPr/>
-        <p:txBody>
-          <a:bodyPr/>
-          <a:lstStyle/>
-          <a:p>
-            <a:r>
-              <a:t>SWITCH TO APP: NFA tab, click the step-forward arrow a couple of times, point at the multiple highlighted states and the purple traversed edges.</a:t>
-            </a:r>
-          </a:p>
-        </p:txBody>
-      </p:sp>
-      <p:sp>
-        <p:nvSpPr>
-          <p:cNvPr id="4" name="Slide Number Placeholder 3"/>
-          <p:cNvSpPr>
-            <a:spLocks noGrp="1"/>
-          </p:cNvSpPr>
-          <p:nvPr>
-            <p:ph type="sldNum" idx="5" sz="quarter"/>
+            <p:ph type="sldNum" sz="quarter" idx="5"/>
           </p:nvPr>
         </p:nvSpPr>
         <p:spPr/>
@@ -1351,10 +1146,9 @@
           <a:lstStyle/>
           <a:p>
             <a:r>
-              <a:rPr lang="en-US" smtClean="0"/>
+              <a:rPr lang="en-US"/>
               <a:t>Click to edit Master title style</a:t>
             </a:r>
-            <a:endParaRPr lang="en-US"/>
           </a:p>
         </p:txBody>
       </p:sp>
@@ -1470,10 +1264,9 @@
           </a:lstStyle>
           <a:p>
             <a:r>
-              <a:rPr lang="en-US" smtClean="0"/>
+              <a:rPr lang="en-US"/>
               <a:t>Click to edit Master subtitle style</a:t>
             </a:r>
-            <a:endParaRPr lang="en-US"/>
           </a:p>
         </p:txBody>
       </p:sp>
@@ -1494,7 +1287,7 @@
           <a:p>
             <a:fld id="{5BCAD085-E8A6-8845-BD4E-CB4CCA059FC4}" type="datetimeFigureOut">
               <a:rPr lang="en-US" smtClean="0"/>
-              <a:t>1/27/13</a:t>
+              <a:t>10/20/2026</a:t>
             </a:fld>
             <a:endParaRPr lang="en-US"/>
           </a:p>
@@ -1588,10 +1381,9 @@
           <a:lstStyle/>
           <a:p>
             <a:r>
-              <a:rPr lang="en-US" smtClean="0"/>
+              <a:rPr lang="en-US"/>
               <a:t>Click to edit Master title style</a:t>
             </a:r>
-            <a:endParaRPr lang="en-US"/>
           </a:p>
         </p:txBody>
       </p:sp>
@@ -1612,38 +1404,37 @@
           <a:p>
             <a:pPr lvl="0"/>
             <a:r>
-              <a:rPr lang="en-US" smtClean="0"/>
+              <a:rPr lang="en-US"/>
               <a:t>Click to edit Master text styles</a:t>
             </a:r>
           </a:p>
           <a:p>
             <a:pPr lvl="1"/>
             <a:r>
-              <a:rPr lang="en-US" smtClean="0"/>
+              <a:rPr lang="en-US"/>
               <a:t>Second level</a:t>
             </a:r>
           </a:p>
           <a:p>
             <a:pPr lvl="2"/>
             <a:r>
-              <a:rPr lang="en-US" smtClean="0"/>
+              <a:rPr lang="en-US"/>
               <a:t>Third level</a:t>
             </a:r>
           </a:p>
           <a:p>
             <a:pPr lvl="3"/>
             <a:r>
-              <a:rPr lang="en-US" smtClean="0"/>
+              <a:rPr lang="en-US"/>
               <a:t>Fourth level</a:t>
             </a:r>
           </a:p>
           <a:p>
             <a:pPr lvl="4"/>
             <a:r>
-              <a:rPr lang="en-US" smtClean="0"/>
+              <a:rPr lang="en-US"/>
               <a:t>Fifth level</a:t>
             </a:r>
-            <a:endParaRPr lang="en-US"/>
           </a:p>
         </p:txBody>
       </p:sp>
@@ -1664,7 +1455,7 @@
           <a:p>
             <a:fld id="{5BCAD085-E8A6-8845-BD4E-CB4CCA059FC4}" type="datetimeFigureOut">
               <a:rPr lang="en-US" smtClean="0"/>
-              <a:t>1/27/13</a:t>
+              <a:t>10/20/2026</a:t>
             </a:fld>
             <a:endParaRPr lang="en-US"/>
           </a:p>
@@ -1763,10 +1554,9 @@
           <a:lstStyle/>
           <a:p>
             <a:r>
-              <a:rPr lang="en-US" smtClean="0"/>
+              <a:rPr lang="en-US"/>
               <a:t>Click to edit Master title style</a:t>
             </a:r>
-            <a:endParaRPr lang="en-US"/>
           </a:p>
         </p:txBody>
       </p:sp>
@@ -1792,38 +1582,37 @@
           <a:p>
             <a:pPr lvl="0"/>
             <a:r>
-              <a:rPr lang="en-US" smtClean="0"/>
+              <a:rPr lang="en-US"/>
               <a:t>Click to edit Master text styles</a:t>
             </a:r>
           </a:p>
           <a:p>
             <a:pPr lvl="1"/>
             <a:r>
-              <a:rPr lang="en-US" smtClean="0"/>
+              <a:rPr lang="en-US"/>
               <a:t>Second level</a:t>
             </a:r>
           </a:p>
           <a:p>
             <a:pPr lvl="2"/>
             <a:r>
-              <a:rPr lang="en-US" smtClean="0"/>
+              <a:rPr lang="en-US"/>
               <a:t>Third level</a:t>
             </a:r>
           </a:p>
           <a:p>
             <a:pPr lvl="3"/>
             <a:r>
-              <a:rPr lang="en-US" smtClean="0"/>
+              <a:rPr lang="en-US"/>
               <a:t>Fourth level</a:t>
             </a:r>
           </a:p>
           <a:p>
             <a:pPr lvl="4"/>
             <a:r>
-              <a:rPr lang="en-US" smtClean="0"/>
+              <a:rPr lang="en-US"/>
               <a:t>Fifth level</a:t>
             </a:r>
-            <a:endParaRPr lang="en-US"/>
           </a:p>
         </p:txBody>
       </p:sp>
@@ -1844,7 +1633,7 @@
           <a:p>
             <a:fld id="{5BCAD085-E8A6-8845-BD4E-CB4CCA059FC4}" type="datetimeFigureOut">
               <a:rPr lang="en-US" smtClean="0"/>
-              <a:t>1/27/13</a:t>
+              <a:t>10/20/2026</a:t>
             </a:fld>
             <a:endParaRPr lang="en-US"/>
           </a:p>
@@ -1938,10 +1727,9 @@
           <a:lstStyle/>
           <a:p>
             <a:r>
-              <a:rPr lang="en-US" smtClean="0"/>
+              <a:rPr lang="en-US"/>
               <a:t>Click to edit Master title style</a:t>
             </a:r>
-            <a:endParaRPr lang="en-US"/>
           </a:p>
         </p:txBody>
       </p:sp>
@@ -1962,38 +1750,37 @@
           <a:p>
             <a:pPr lvl="0"/>
             <a:r>
-              <a:rPr lang="en-US" smtClean="0"/>
+              <a:rPr lang="en-US"/>
               <a:t>Click to edit Master text styles</a:t>
             </a:r>
           </a:p>
           <a:p>
             <a:pPr lvl="1"/>
             <a:r>
-              <a:rPr lang="en-US" smtClean="0"/>
+              <a:rPr lang="en-US"/>
               <a:t>Second level</a:t>
             </a:r>
           </a:p>
           <a:p>
             <a:pPr lvl="2"/>
             <a:r>
-              <a:rPr lang="en-US" smtClean="0"/>
+              <a:rPr lang="en-US"/>
               <a:t>Third level</a:t>
             </a:r>
           </a:p>
           <a:p>
             <a:pPr lvl="3"/>
             <a:r>
-              <a:rPr lang="en-US" smtClean="0"/>
+              <a:rPr lang="en-US"/>
               <a:t>Fourth level</a:t>
             </a:r>
           </a:p>
           <a:p>
             <a:pPr lvl="4"/>
             <a:r>
-              <a:rPr lang="en-US" smtClean="0"/>
+              <a:rPr lang="en-US"/>
               <a:t>Fifth level</a:t>
             </a:r>
-            <a:endParaRPr lang="en-US"/>
           </a:p>
         </p:txBody>
       </p:sp>
@@ -2014,7 +1801,7 @@
           <a:p>
             <a:fld id="{5BCAD085-E8A6-8845-BD4E-CB4CCA059FC4}" type="datetimeFigureOut">
               <a:rPr lang="en-US" smtClean="0"/>
-              <a:t>1/27/13</a:t>
+              <a:t>10/20/2026</a:t>
             </a:fld>
             <a:endParaRPr lang="en-US"/>
           </a:p>
@@ -2117,10 +1904,9 @@
           </a:lstStyle>
           <a:p>
             <a:r>
-              <a:rPr lang="en-US" smtClean="0"/>
+              <a:rPr lang="en-US"/>
               <a:t>Click to edit Master title style</a:t>
             </a:r>
-            <a:endParaRPr lang="en-US"/>
           </a:p>
         </p:txBody>
       </p:sp>
@@ -2237,7 +2023,7 @@
           <a:p>
             <a:pPr lvl="0"/>
             <a:r>
-              <a:rPr lang="en-US" smtClean="0"/>
+              <a:rPr lang="en-US"/>
               <a:t>Click to edit Master text styles</a:t>
             </a:r>
           </a:p>
@@ -2260,7 +2046,7 @@
           <a:p>
             <a:fld id="{5BCAD085-E8A6-8845-BD4E-CB4CCA059FC4}" type="datetimeFigureOut">
               <a:rPr lang="en-US" smtClean="0"/>
-              <a:t>1/27/13</a:t>
+              <a:t>10/20/2026</a:t>
             </a:fld>
             <a:endParaRPr lang="en-US"/>
           </a:p>
@@ -2354,10 +2140,9 @@
           <a:lstStyle/>
           <a:p>
             <a:r>
-              <a:rPr lang="en-US" smtClean="0"/>
+              <a:rPr lang="en-US"/>
               <a:t>Click to edit Master title style</a:t>
             </a:r>
-            <a:endParaRPr lang="en-US"/>
           </a:p>
         </p:txBody>
       </p:sp>
@@ -2411,38 +2196,37 @@
           <a:p>
             <a:pPr lvl="0"/>
             <a:r>
-              <a:rPr lang="en-US" smtClean="0"/>
+              <a:rPr lang="en-US"/>
               <a:t>Click to edit Master text styles</a:t>
             </a:r>
           </a:p>
           <a:p>
             <a:pPr lvl="1"/>
             <a:r>
-              <a:rPr lang="en-US" smtClean="0"/>
+              <a:rPr lang="en-US"/>
               <a:t>Second level</a:t>
             </a:r>
           </a:p>
           <a:p>
             <a:pPr lvl="2"/>
             <a:r>
-              <a:rPr lang="en-US" smtClean="0"/>
+              <a:rPr lang="en-US"/>
               <a:t>Third level</a:t>
             </a:r>
           </a:p>
           <a:p>
             <a:pPr lvl="3"/>
             <a:r>
-              <a:rPr lang="en-US" smtClean="0"/>
+              <a:rPr lang="en-US"/>
               <a:t>Fourth level</a:t>
             </a:r>
           </a:p>
           <a:p>
             <a:pPr lvl="4"/>
             <a:r>
-              <a:rPr lang="en-US" smtClean="0"/>
+              <a:rPr lang="en-US"/>
               <a:t>Fifth level</a:t>
             </a:r>
-            <a:endParaRPr lang="en-US"/>
           </a:p>
         </p:txBody>
       </p:sp>
@@ -2496,38 +2280,37 @@
           <a:p>
             <a:pPr lvl="0"/>
             <a:r>
-              <a:rPr lang="en-US" smtClean="0"/>
+              <a:rPr lang="en-US"/>
               <a:t>Click to edit Master text styles</a:t>
             </a:r>
           </a:p>
           <a:p>
             <a:pPr lvl="1"/>
             <a:r>
-              <a:rPr lang="en-US" smtClean="0"/>
+              <a:rPr lang="en-US"/>
               <a:t>Second level</a:t>
             </a:r>
           </a:p>
           <a:p>
             <a:pPr lvl="2"/>
             <a:r>
-              <a:rPr lang="en-US" smtClean="0"/>
+              <a:rPr lang="en-US"/>
               <a:t>Third level</a:t>
             </a:r>
           </a:p>
           <a:p>
             <a:pPr lvl="3"/>
             <a:r>
-              <a:rPr lang="en-US" smtClean="0"/>
+              <a:rPr lang="en-US"/>
               <a:t>Fourth level</a:t>
             </a:r>
           </a:p>
           <a:p>
             <a:pPr lvl="4"/>
             <a:r>
-              <a:rPr lang="en-US" smtClean="0"/>
+              <a:rPr lang="en-US"/>
               <a:t>Fifth level</a:t>
             </a:r>
-            <a:endParaRPr lang="en-US"/>
           </a:p>
         </p:txBody>
       </p:sp>
@@ -2548,7 +2331,7 @@
           <a:p>
             <a:fld id="{5BCAD085-E8A6-8845-BD4E-CB4CCA059FC4}" type="datetimeFigureOut">
               <a:rPr lang="en-US" smtClean="0"/>
-              <a:t>1/27/13</a:t>
+              <a:t>10/20/2026</a:t>
             </a:fld>
             <a:endParaRPr lang="en-US"/>
           </a:p>
@@ -2646,10 +2429,9 @@
           </a:lstStyle>
           <a:p>
             <a:r>
-              <a:rPr lang="en-US" smtClean="0"/>
+              <a:rPr lang="en-US"/>
               <a:t>Click to edit Master title style</a:t>
             </a:r>
-            <a:endParaRPr lang="en-US"/>
           </a:p>
         </p:txBody>
       </p:sp>
@@ -2712,7 +2494,7 @@
           <a:p>
             <a:pPr lvl="0"/>
             <a:r>
-              <a:rPr lang="en-US" smtClean="0"/>
+              <a:rPr lang="en-US"/>
               <a:t>Click to edit Master text styles</a:t>
             </a:r>
           </a:p>
@@ -2768,38 +2550,37 @@
           <a:p>
             <a:pPr lvl="0"/>
             <a:r>
-              <a:rPr lang="en-US" smtClean="0"/>
+              <a:rPr lang="en-US"/>
               <a:t>Click to edit Master text styles</a:t>
             </a:r>
           </a:p>
           <a:p>
             <a:pPr lvl="1"/>
             <a:r>
-              <a:rPr lang="en-US" smtClean="0"/>
+              <a:rPr lang="en-US"/>
               <a:t>Second level</a:t>
             </a:r>
           </a:p>
           <a:p>
             <a:pPr lvl="2"/>
             <a:r>
-              <a:rPr lang="en-US" smtClean="0"/>
+              <a:rPr lang="en-US"/>
               <a:t>Third level</a:t>
             </a:r>
           </a:p>
           <a:p>
             <a:pPr lvl="3"/>
             <a:r>
-              <a:rPr lang="en-US" smtClean="0"/>
+              <a:rPr lang="en-US"/>
               <a:t>Fourth level</a:t>
             </a:r>
           </a:p>
           <a:p>
             <a:pPr lvl="4"/>
             <a:r>
-              <a:rPr lang="en-US" smtClean="0"/>
+              <a:rPr lang="en-US"/>
               <a:t>Fifth level</a:t>
             </a:r>
-            <a:endParaRPr lang="en-US"/>
           </a:p>
         </p:txBody>
       </p:sp>
@@ -2862,7 +2643,7 @@
           <a:p>
             <a:pPr lvl="0"/>
             <a:r>
-              <a:rPr lang="en-US" smtClean="0"/>
+              <a:rPr lang="en-US"/>
               <a:t>Click to edit Master text styles</a:t>
             </a:r>
           </a:p>
@@ -2918,38 +2699,37 @@
           <a:p>
             <a:pPr lvl="0"/>
             <a:r>
-              <a:rPr lang="en-US" smtClean="0"/>
+              <a:rPr lang="en-US"/>
               <a:t>Click to edit Master text styles</a:t>
             </a:r>
           </a:p>
           <a:p>
             <a:pPr lvl="1"/>
             <a:r>
-              <a:rPr lang="en-US" smtClean="0"/>
+              <a:rPr lang="en-US"/>
               <a:t>Second level</a:t>
             </a:r>
           </a:p>
           <a:p>
             <a:pPr lvl="2"/>
             <a:r>
-              <a:rPr lang="en-US" smtClean="0"/>
+              <a:rPr lang="en-US"/>
               <a:t>Third level</a:t>
             </a:r>
           </a:p>
           <a:p>
             <a:pPr lvl="3"/>
             <a:r>
-              <a:rPr lang="en-US" smtClean="0"/>
+              <a:rPr lang="en-US"/>
               <a:t>Fourth level</a:t>
             </a:r>
           </a:p>
           <a:p>
             <a:pPr lvl="4"/>
             <a:r>
-              <a:rPr lang="en-US" smtClean="0"/>
+              <a:rPr lang="en-US"/>
               <a:t>Fifth level</a:t>
             </a:r>
-            <a:endParaRPr lang="en-US"/>
           </a:p>
         </p:txBody>
       </p:sp>
@@ -2970,7 +2750,7 @@
           <a:p>
             <a:fld id="{5BCAD085-E8A6-8845-BD4E-CB4CCA059FC4}" type="datetimeFigureOut">
               <a:rPr lang="en-US" smtClean="0"/>
-              <a:t>1/27/13</a:t>
+              <a:t>10/20/2026</a:t>
             </a:fld>
             <a:endParaRPr lang="en-US"/>
           </a:p>
@@ -3064,10 +2844,9 @@
           <a:lstStyle/>
           <a:p>
             <a:r>
-              <a:rPr lang="en-US" smtClean="0"/>
+              <a:rPr lang="en-US"/>
               <a:t>Click to edit Master title style</a:t>
             </a:r>
-            <a:endParaRPr lang="en-US"/>
           </a:p>
         </p:txBody>
       </p:sp>
@@ -3088,7 +2867,7 @@
           <a:p>
             <a:fld id="{5BCAD085-E8A6-8845-BD4E-CB4CCA059FC4}" type="datetimeFigureOut">
               <a:rPr lang="en-US" smtClean="0"/>
-              <a:t>1/27/13</a:t>
+              <a:t>10/20/2026</a:t>
             </a:fld>
             <a:endParaRPr lang="en-US"/>
           </a:p>
@@ -3183,7 +2962,7 @@
           <a:p>
             <a:fld id="{5BCAD085-E8A6-8845-BD4E-CB4CCA059FC4}" type="datetimeFigureOut">
               <a:rPr lang="en-US" smtClean="0"/>
-              <a:t>1/27/13</a:t>
+              <a:t>10/20/2026</a:t>
             </a:fld>
             <a:endParaRPr lang="en-US"/>
           </a:p>
@@ -3286,10 +3065,9 @@
           </a:lstStyle>
           <a:p>
             <a:r>
-              <a:rPr lang="en-US" smtClean="0"/>
+              <a:rPr lang="en-US"/>
               <a:t>Click to edit Master title style</a:t>
             </a:r>
-            <a:endParaRPr lang="en-US"/>
           </a:p>
         </p:txBody>
       </p:sp>
@@ -3343,38 +3121,37 @@
           <a:p>
             <a:pPr lvl="0"/>
             <a:r>
-              <a:rPr lang="en-US" smtClean="0"/>
+              <a:rPr lang="en-US"/>
               <a:t>Click to edit Master text styles</a:t>
             </a:r>
           </a:p>
           <a:p>
             <a:pPr lvl="1"/>
             <a:r>
-              <a:rPr lang="en-US" smtClean="0"/>
+              <a:rPr lang="en-US"/>
               <a:t>Second level</a:t>
             </a:r>
           </a:p>
           <a:p>
             <a:pPr lvl="2"/>
             <a:r>
-              <a:rPr lang="en-US" smtClean="0"/>
+              <a:rPr lang="en-US"/>
               <a:t>Third level</a:t>
             </a:r>
           </a:p>
           <a:p>
             <a:pPr lvl="3"/>
             <a:r>
-              <a:rPr lang="en-US" smtClean="0"/>
+              <a:rPr lang="en-US"/>
               <a:t>Fourth level</a:t>
             </a:r>
           </a:p>
           <a:p>
             <a:pPr lvl="4"/>
             <a:r>
-              <a:rPr lang="en-US" smtClean="0"/>
+              <a:rPr lang="en-US"/>
               <a:t>Fifth level</a:t>
             </a:r>
-            <a:endParaRPr lang="en-US"/>
           </a:p>
         </p:txBody>
       </p:sp>
@@ -3437,7 +3214,7 @@
           <a:p>
             <a:pPr lvl="0"/>
             <a:r>
-              <a:rPr lang="en-US" smtClean="0"/>
+              <a:rPr lang="en-US"/>
               <a:t>Click to edit Master text styles</a:t>
             </a:r>
           </a:p>
@@ -3460,7 +3237,7 @@
           <a:p>
             <a:fld id="{5BCAD085-E8A6-8845-BD4E-CB4CCA059FC4}" type="datetimeFigureOut">
               <a:rPr lang="en-US" smtClean="0"/>
-              <a:t>1/27/13</a:t>
+              <a:t>10/20/2026</a:t>
             </a:fld>
             <a:endParaRPr lang="en-US"/>
           </a:p>
@@ -3563,10 +3340,9 @@
           </a:lstStyle>
           <a:p>
             <a:r>
-              <a:rPr lang="en-US" smtClean="0"/>
+              <a:rPr lang="en-US"/>
               <a:t>Click to edit Master title style</a:t>
             </a:r>
-            <a:endParaRPr lang="en-US"/>
           </a:p>
         </p:txBody>
       </p:sp>
@@ -3690,7 +3466,7 @@
           <a:p>
             <a:pPr lvl="0"/>
             <a:r>
-              <a:rPr lang="en-US" smtClean="0"/>
+              <a:rPr lang="en-US"/>
               <a:t>Click to edit Master text styles</a:t>
             </a:r>
           </a:p>
@@ -3713,7 +3489,7 @@
           <a:p>
             <a:fld id="{5BCAD085-E8A6-8845-BD4E-CB4CCA059FC4}" type="datetimeFigureOut">
               <a:rPr lang="en-US" smtClean="0"/>
-              <a:t>1/27/13</a:t>
+              <a:t>10/20/2026</a:t>
             </a:fld>
             <a:endParaRPr lang="en-US"/>
           </a:p>
@@ -3822,10 +3598,9 @@
           <a:lstStyle/>
           <a:p>
             <a:r>
-              <a:rPr lang="en-US" smtClean="0"/>
+              <a:rPr lang="en-US"/>
               <a:t>Click to edit Master title style</a:t>
             </a:r>
-            <a:endParaRPr lang="en-US"/>
           </a:p>
         </p:txBody>
       </p:sp>
@@ -3856,38 +3631,37 @@
           <a:p>
             <a:pPr lvl="0"/>
             <a:r>
-              <a:rPr lang="en-US" smtClean="0"/>
+              <a:rPr lang="en-US"/>
               <a:t>Click to edit Master text styles</a:t>
             </a:r>
           </a:p>
           <a:p>
             <a:pPr lvl="1"/>
             <a:r>
-              <a:rPr lang="en-US" smtClean="0"/>
+              <a:rPr lang="en-US"/>
               <a:t>Second level</a:t>
             </a:r>
           </a:p>
           <a:p>
             <a:pPr lvl="2"/>
             <a:r>
-              <a:rPr lang="en-US" smtClean="0"/>
+              <a:rPr lang="en-US"/>
               <a:t>Third level</a:t>
             </a:r>
           </a:p>
           <a:p>
             <a:pPr lvl="3"/>
             <a:r>
-              <a:rPr lang="en-US" smtClean="0"/>
+              <a:rPr lang="en-US"/>
               <a:t>Fourth level</a:t>
             </a:r>
           </a:p>
           <a:p>
             <a:pPr lvl="4"/>
             <a:r>
-              <a:rPr lang="en-US" smtClean="0"/>
+              <a:rPr lang="en-US"/>
               <a:t>Fifth level</a:t>
             </a:r>
-            <a:endParaRPr lang="en-US"/>
           </a:p>
         </p:txBody>
       </p:sp>
@@ -3926,7 +3700,7 @@
           <a:p>
             <a:fld id="{5BCAD085-E8A6-8845-BD4E-CB4CCA059FC4}" type="datetimeFigureOut">
               <a:rPr lang="en-US" smtClean="0"/>
-              <a:t>1/27/13</a:t>
+              <a:t>10/20/2026</a:t>
             </a:fld>
             <a:endParaRPr lang="en-US"/>
           </a:p>
@@ -4285,7 +4059,7 @@
 </file>
 
 <file path=ppt/slides/slide1.xml><?xml version="1.0" encoding="utf-8"?>
-<p:sld xmlns:a="http://schemas.openxmlformats.org/drawingml/2006/main" xmlns:p="http://schemas.openxmlformats.org/presentationml/2006/main" xmlns:r="http://schemas.openxmlformats.org/officeDocument/2006/relationships">
+<p:sld xmlns:a="http://schemas.openxmlformats.org/drawingml/2006/main" xmlns:r="http://schemas.openxmlformats.org/officeDocument/2006/relationships" xmlns:p="http://schemas.openxmlformats.org/presentationml/2006/main">
   <p:cSld>
     <p:bg>
       <p:bgPr>
@@ -4301,7 +4075,14 @@
         <p:cNvGrpSpPr/>
         <p:nvPr/>
       </p:nvGrpSpPr>
-      <p:grpSpPr/>
+      <p:grpSpPr>
+        <a:xfrm>
+          <a:off x="0" y="0"/>
+          <a:ext cx="0" cy="0"/>
+          <a:chOff x="0" y="0"/>
+          <a:chExt cx="0" cy="0"/>
+        </a:xfrm>
+      </p:grpSpPr>
       <p:sp>
         <p:nvSpPr>
           <p:cNvPr id="2" name="TextBox 1"/>
@@ -4319,7 +4100,7 @@
           <a:noFill/>
         </p:spPr>
         <p:txBody>
-          <a:bodyPr wrap="none" lIns="0" rIns="0" tIns="0" bIns="0">
+          <a:bodyPr wrap="none" lIns="0" tIns="0" rIns="0" bIns="0">
             <a:spAutoFit/>
           </a:bodyPr>
           <a:lstStyle/>
@@ -4346,7 +4127,7 @@
         <p:spPr>
           <a:xfrm>
             <a:off x="914400" y="2377440"/>
-            <a:ext cx="10332720" cy="1097280"/>
+            <a:ext cx="10220811" cy="830997"/>
           </a:xfrm>
           <a:prstGeom prst="rect">
             <a:avLst/>
@@ -4360,7 +4141,7 @@
           <a:lstStyle/>
           <a:p>
             <a:r>
-              <a:rPr sz="4800" b="1">
+              <a:rPr sz="4800" b="1" dirty="0" err="1">
                 <a:solidFill>
                   <a:srgbClr val="000000"/>
                 </a:solidFill>
@@ -4368,6 +4149,21 @@
               </a:rPr>
               <a:t>RegexLab</a:t>
             </a:r>
+            <a:r>
+              <a:rPr lang="en-US" sz="4800" b="1" dirty="0">
+                <a:solidFill>
+                  <a:srgbClr val="000000"/>
+                </a:solidFill>
+                <a:latin typeface="Arial"/>
+              </a:rPr>
+              <a:t>: Automata Made Visible</a:t>
+            </a:r>
+            <a:endParaRPr sz="4800" b="1" dirty="0">
+              <a:solidFill>
+                <a:srgbClr val="000000"/>
+              </a:solidFill>
+              <a:latin typeface="Arial"/>
+            </a:endParaRPr>
           </a:p>
         </p:txBody>
       </p:sp>
@@ -4414,7 +4210,7 @@
         <p:spPr>
           <a:xfrm>
             <a:off x="914400" y="4206240"/>
-            <a:ext cx="10332720" cy="548640"/>
+            <a:ext cx="9825960" cy="338554"/>
           </a:xfrm>
           <a:prstGeom prst="rect">
             <a:avLst/>
@@ -4428,14 +4224,74 @@
           <a:lstStyle/>
           <a:p>
             <a:r>
-              <a:rPr sz="1600">
+              <a:rPr sz="1600" dirty="0">
                 <a:solidFill>
                   <a:srgbClr val="606060"/>
                 </a:solidFill>
                 <a:latin typeface="Arial"/>
               </a:rPr>
-              <a:t>BCSE307L Compiler Design, by Vignesh P C and Ujwal</a:t>
-            </a:r>
+              <a:t>BCSE307L Compiler Design, by Vignesh P C</a:t>
+            </a:r>
+            <a:r>
+              <a:rPr lang="en-US" sz="1600" dirty="0">
+                <a:solidFill>
+                  <a:srgbClr val="606060"/>
+                </a:solidFill>
+                <a:latin typeface="Arial"/>
+              </a:rPr>
+              <a:t> (24BCE0695)</a:t>
+            </a:r>
+            <a:r>
+              <a:rPr sz="1600" dirty="0">
+                <a:solidFill>
+                  <a:srgbClr val="606060"/>
+                </a:solidFill>
+                <a:latin typeface="Arial"/>
+              </a:rPr>
+              <a:t> and </a:t>
+            </a:r>
+            <a:r>
+              <a:rPr lang="en-US" sz="1600" dirty="0" err="1">
+                <a:solidFill>
+                  <a:srgbClr val="606060"/>
+                </a:solidFill>
+                <a:latin typeface="Arial"/>
+              </a:rPr>
+              <a:t>Coppisetty</a:t>
+            </a:r>
+            <a:r>
+              <a:rPr lang="en-US" sz="1600" dirty="0">
+                <a:solidFill>
+                  <a:srgbClr val="606060"/>
+                </a:solidFill>
+                <a:latin typeface="Arial"/>
+              </a:rPr>
+              <a:t> Venkat Sai </a:t>
+            </a:r>
+            <a:r>
+              <a:rPr sz="1600" dirty="0">
+                <a:solidFill>
+                  <a:srgbClr val="606060"/>
+                </a:solidFill>
+                <a:latin typeface="Arial"/>
+              </a:rPr>
+              <a:t>Ujwal</a:t>
+            </a:r>
+            <a:r>
+              <a:rPr lang="en-US" sz="1600" dirty="0">
+                <a:solidFill>
+                  <a:srgbClr val="606060"/>
+                </a:solidFill>
+                <a:latin typeface="Arial"/>
+              </a:rPr>
+              <a:t> (24BCE0667)</a:t>
+            </a:r>
+            <a:endParaRPr sz="1600" dirty="0">
+              <a:solidFill>
+                <a:srgbClr val="606060"/>
+              </a:solidFill>
+              <a:latin typeface="Arial"/>
+            </a:endParaRPr>
           </a:p>
         </p:txBody>
       </p:sp>
@@ -4448,7 +4304,7 @@
 </file>
 
 <file path=ppt/slides/slide10.xml><?xml version="1.0" encoding="utf-8"?>
-<p:sld xmlns:a="http://schemas.openxmlformats.org/drawingml/2006/main" xmlns:p="http://schemas.openxmlformats.org/presentationml/2006/main" xmlns:r="http://schemas.openxmlformats.org/officeDocument/2006/relationships">
+<p:sld xmlns:a="http://schemas.openxmlformats.org/drawingml/2006/main" xmlns:r="http://schemas.openxmlformats.org/officeDocument/2006/relationships" xmlns:p="http://schemas.openxmlformats.org/presentationml/2006/main">
   <p:cSld>
     <p:bg>
       <p:bgPr>
@@ -4464,7 +4320,14 @@
         <p:cNvGrpSpPr/>
         <p:nvPr/>
       </p:nvGrpSpPr>
-      <p:grpSpPr/>
+      <p:grpSpPr>
+        <a:xfrm>
+          <a:off x="0" y="0"/>
+          <a:ext cx="0" cy="0"/>
+          <a:chOff x="0" y="0"/>
+          <a:chExt cx="0" cy="0"/>
+        </a:xfrm>
+      </p:grpSpPr>
       <p:sp>
         <p:nvSpPr>
           <p:cNvPr id="2" name="TextBox 1"/>
@@ -4482,7 +4345,7 @@
           <a:noFill/>
         </p:spPr>
         <p:txBody>
-          <a:bodyPr wrap="none" lIns="0" rIns="0" tIns="0" bIns="0">
+          <a:bodyPr wrap="none" lIns="0" tIns="0" rIns="0" bIns="0">
             <a:spAutoFit/>
           </a:bodyPr>
           <a:lstStyle/>
@@ -4578,7 +4441,7 @@
         <p:spPr>
           <a:xfrm>
             <a:off x="457200" y="1463040"/>
-            <a:ext cx="10515600" cy="4754880"/>
+            <a:ext cx="10515600" cy="3221395"/>
           </a:xfrm>
           <a:prstGeom prst="rect">
             <a:avLst/>
@@ -4603,7 +4466,16 @@
               </a:defRPr>
             </a:pPr>
             <a:r>
-              <a:t>•  Differential testing: thousands of random (pattern, input) pairs checked against std::regex in C++ and native RegExp in TypeScript. Both independent implementations have to agree.</a:t>
+              <a:rPr dirty="0"/>
+              <a:t>•  Differential testing: thousands of random (pattern, input) pairs checked against std::regex in C++ and native </a:t>
+            </a:r>
+            <a:r>
+              <a:rPr dirty="0" err="1"/>
+              <a:t>RegExp</a:t>
+            </a:r>
+            <a:r>
+              <a:rPr dirty="0"/>
+              <a:t> in TypeScript. Both independent implementations have to agree.</a:t>
             </a:r>
           </a:p>
           <a:p>
@@ -4619,6 +4491,7 @@
               </a:defRPr>
             </a:pPr>
             <a:r>
+              <a:rPr dirty="0"/>
               <a:t>•  Measured today: 125 TypeScript tests / 10 files; 4,608 C++ assertions / 41 cases.</a:t>
             </a:r>
           </a:p>
@@ -4635,13 +4508,31 @@
               </a:defRPr>
             </a:pPr>
             <a:r>
-              <a:rPr sz="1500" i="1">
+              <a:rPr sz="1500" i="1" dirty="0">
                 <a:solidFill>
                   <a:srgbClr val="606060"/>
                 </a:solidFill>
                 <a:latin typeface="Arial"/>
               </a:rPr>
-              <a:t>–  How: npm test feeds each known pattern through the real pipeline and checks the answer is exactly right.</a:t>
+              <a:t>–  How: </a:t>
+            </a:r>
+            <a:r>
+              <a:rPr sz="1500" i="1" dirty="0" err="1">
+                <a:solidFill>
+                  <a:srgbClr val="606060"/>
+                </a:solidFill>
+                <a:latin typeface="Arial"/>
+              </a:rPr>
+              <a:t>npm</a:t>
+            </a:r>
+            <a:r>
+              <a:rPr sz="1500" i="1" dirty="0">
+                <a:solidFill>
+                  <a:srgbClr val="606060"/>
+                </a:solidFill>
+                <a:latin typeface="Arial"/>
+              </a:rPr>
+              <a:t> test feeds each known pattern through the real pipeline and checks the answer is exactly right.</a:t>
             </a:r>
           </a:p>
           <a:p>
@@ -4657,14 +4548,57 @@
               </a:defRPr>
             </a:pPr>
             <a:r>
-              <a:rPr sz="1500" i="1">
+              <a:rPr sz="1500" i="1" dirty="0">
                 <a:solidFill>
                   <a:srgbClr val="606060"/>
                 </a:solidFill>
                 <a:latin typeface="Arial"/>
               </a:rPr>
-              <a:t>–  How: ./engine_tests runs the same checks ported to C++, one assertion per fact checked (e.g. an exact state count).</a:t>
-            </a:r>
+              <a:t>–  How: ./</a:t>
+            </a:r>
+            <a:r>
+              <a:rPr sz="1500" i="1" dirty="0" err="1">
+                <a:solidFill>
+                  <a:srgbClr val="606060"/>
+                </a:solidFill>
+                <a:latin typeface="Arial"/>
+              </a:rPr>
+              <a:t>engine_tests</a:t>
+            </a:r>
+            <a:r>
+              <a:rPr sz="1500" i="1" dirty="0">
+                <a:solidFill>
+                  <a:srgbClr val="606060"/>
+                </a:solidFill>
+                <a:latin typeface="Arial"/>
+              </a:rPr>
+              <a:t> runs the same checks ported to C++, one assertion per fact checked (e.g. an exact state count).</a:t>
+            </a:r>
+            <a:endParaRPr lang="en-US" sz="1500" i="1" dirty="0">
+              <a:solidFill>
+                <a:srgbClr val="606060"/>
+              </a:solidFill>
+              <a:latin typeface="Arial"/>
+            </a:endParaRPr>
+          </a:p>
+          <a:p>
+            <a:pPr marL="457200">
+              <a:spcAft>
+                <a:spcPts val="800"/>
+              </a:spcAft>
+              <a:defRPr sz="1500" i="1">
+                <a:solidFill>
+                  <a:srgbClr val="606060"/>
+                </a:solidFill>
+                <a:latin typeface="Arial"/>
+              </a:defRPr>
+            </a:pPr>
+            <a:endParaRPr sz="1500" i="1" dirty="0">
+              <a:solidFill>
+                <a:srgbClr val="606060"/>
+              </a:solidFill>
+              <a:latin typeface="Arial"/>
+            </a:endParaRPr>
           </a:p>
           <a:p>
             <a:pPr>
@@ -4679,6 +4613,7 @@
               </a:defRPr>
             </a:pPr>
             <a:r>
+              <a:rPr dirty="0"/>
               <a:t>•  WASM build verified: 25/25 guard probes passed (length cap, nesting cap, non-ASCII handling) against the real compiled module.</a:t>
             </a:r>
           </a:p>
@@ -4693,7 +4628,7 @@
 </file>
 
 <file path=ppt/slides/slide11.xml><?xml version="1.0" encoding="utf-8"?>
-<p:sld xmlns:a="http://schemas.openxmlformats.org/drawingml/2006/main" xmlns:p="http://schemas.openxmlformats.org/presentationml/2006/main" xmlns:r="http://schemas.openxmlformats.org/officeDocument/2006/relationships">
+<p:sld xmlns:a="http://schemas.openxmlformats.org/drawingml/2006/main" xmlns:r="http://schemas.openxmlformats.org/officeDocument/2006/relationships" xmlns:p="http://schemas.openxmlformats.org/presentationml/2006/main">
   <p:cSld>
     <p:bg>
       <p:bgPr>
@@ -4709,7 +4644,14 @@
         <p:cNvGrpSpPr/>
         <p:nvPr/>
       </p:nvGrpSpPr>
-      <p:grpSpPr/>
+      <p:grpSpPr>
+        <a:xfrm>
+          <a:off x="0" y="0"/>
+          <a:ext cx="0" cy="0"/>
+          <a:chOff x="0" y="0"/>
+          <a:chExt cx="0" cy="0"/>
+        </a:xfrm>
+      </p:grpSpPr>
       <p:sp>
         <p:nvSpPr>
           <p:cNvPr id="2" name="TextBox 1"/>
@@ -4727,7 +4669,7 @@
           <a:noFill/>
         </p:spPr>
         <p:txBody>
-          <a:bodyPr wrap="none" lIns="0" rIns="0" tIns="0" bIns="0">
+          <a:bodyPr wrap="none" lIns="0" tIns="0" rIns="0" bIns="0">
             <a:spAutoFit/>
           </a:bodyPr>
           <a:lstStyle/>
@@ -4848,7 +4790,24 @@
               </a:defRPr>
             </a:pPr>
             <a:r>
-              <a:t>•  Direct method (firstpos/followpos) not built. We chose the indirect Thompson-plus-subset-construction route on purpose.</a:t>
+              <a:rPr dirty="0"/>
+              <a:t>•  Direct method (</a:t>
+            </a:r>
+            <a:r>
+              <a:rPr dirty="0" err="1"/>
+              <a:t>firstpos</a:t>
+            </a:r>
+            <a:r>
+              <a:rPr dirty="0"/>
+              <a:t>/</a:t>
+            </a:r>
+            <a:r>
+              <a:rPr dirty="0" err="1"/>
+              <a:t>followpos</a:t>
+            </a:r>
+            <a:r>
+              <a:rPr dirty="0"/>
+              <a:t>) not built. We chose the indirect Thompson-plus-subset-construction route on purpose.</a:t>
             </a:r>
           </a:p>
           <a:p>
@@ -4864,6 +4823,7 @@
               </a:defRPr>
             </a:pPr>
             <a:r>
+              <a:rPr dirty="0"/>
               <a:t>•  Hopcroft's minimization not built. Moore's is simpler to implement and explain fully, and Hopcroft's stays a planned, gated upgrade.</a:t>
             </a:r>
           </a:p>
@@ -4880,6 +4840,7 @@
               </a:defRPr>
             </a:pPr>
             <a:r>
+              <a:rPr dirty="0"/>
               <a:t>•  No dedicated DFA state-count guard against subset construction's exponential worst case. The 500-char pattern cap bounds it indirectly, not tightly.</a:t>
             </a:r>
           </a:p>
@@ -4894,7 +4855,7 @@
 </file>
 
 <file path=ppt/slides/slide12.xml><?xml version="1.0" encoding="utf-8"?>
-<p:sld xmlns:a="http://schemas.openxmlformats.org/drawingml/2006/main" xmlns:p="http://schemas.openxmlformats.org/presentationml/2006/main" xmlns:r="http://schemas.openxmlformats.org/officeDocument/2006/relationships">
+<p:sld xmlns:a="http://schemas.openxmlformats.org/drawingml/2006/main" xmlns:r="http://schemas.openxmlformats.org/officeDocument/2006/relationships" xmlns:p="http://schemas.openxmlformats.org/presentationml/2006/main">
   <p:cSld>
     <p:bg>
       <p:bgPr>
@@ -4910,7 +4871,14 @@
         <p:cNvGrpSpPr/>
         <p:nvPr/>
       </p:nvGrpSpPr>
-      <p:grpSpPr/>
+      <p:grpSpPr>
+        <a:xfrm>
+          <a:off x="0" y="0"/>
+          <a:ext cx="0" cy="0"/>
+          <a:chOff x="0" y="0"/>
+          <a:chExt cx="0" cy="0"/>
+        </a:xfrm>
+      </p:grpSpPr>
       <p:sp>
         <p:nvSpPr>
           <p:cNvPr id="2" name="TextBox 1"/>
@@ -4928,7 +4896,7 @@
           <a:noFill/>
         </p:spPr>
         <p:txBody>
-          <a:bodyPr wrap="none" lIns="0" rIns="0" tIns="0" bIns="0">
+          <a:bodyPr wrap="none" lIns="0" tIns="0" rIns="0" bIns="0">
             <a:spAutoFit/>
           </a:bodyPr>
           <a:lstStyle/>
@@ -4990,7 +4958,7 @@
 </file>
 
 <file path=ppt/slides/slide2.xml><?xml version="1.0" encoding="utf-8"?>
-<p:sld xmlns:a="http://schemas.openxmlformats.org/drawingml/2006/main" xmlns:p="http://schemas.openxmlformats.org/presentationml/2006/main" xmlns:r="http://schemas.openxmlformats.org/officeDocument/2006/relationships">
+<p:sld xmlns:a="http://schemas.openxmlformats.org/drawingml/2006/main" xmlns:r="http://schemas.openxmlformats.org/officeDocument/2006/relationships" xmlns:p="http://schemas.openxmlformats.org/presentationml/2006/main">
   <p:cSld>
     <p:bg>
       <p:bgPr>
@@ -5006,7 +4974,14 @@
         <p:cNvGrpSpPr/>
         <p:nvPr/>
       </p:nvGrpSpPr>
-      <p:grpSpPr/>
+      <p:grpSpPr>
+        <a:xfrm>
+          <a:off x="0" y="0"/>
+          <a:ext cx="0" cy="0"/>
+          <a:chOff x="0" y="0"/>
+          <a:chExt cx="0" cy="0"/>
+        </a:xfrm>
+      </p:grpSpPr>
       <p:sp>
         <p:nvSpPr>
           <p:cNvPr id="2" name="TextBox 1"/>
@@ -5024,7 +4999,7 @@
           <a:noFill/>
         </p:spPr>
         <p:txBody>
-          <a:bodyPr wrap="none" lIns="0" rIns="0" tIns="0" bIns="0">
+          <a:bodyPr wrap="none" lIns="0" tIns="0" rIns="0" bIns="0">
             <a:spAutoFit/>
           </a:bodyPr>
           <a:lstStyle/>
@@ -5145,6 +5120,7 @@
               </a:defRPr>
             </a:pPr>
             <a:r>
+              <a:rPr dirty="0"/>
               <a:t>•  Given a regular expression and a string, decide whether the string matches, without reaching for a built-in regex engine.</a:t>
             </a:r>
           </a:p>
@@ -5161,6 +5137,7 @@
               </a:defRPr>
             </a:pPr>
             <a:r>
+              <a:rPr dirty="0"/>
               <a:t>•  Build the actual compiler pipeline that answers this: parser, NFA, DFA, minimization and matcher, not a lookup into an existing library.</a:t>
             </a:r>
           </a:p>
@@ -5177,6 +5154,7 @@
               </a:defRPr>
             </a:pPr>
             <a:r>
+              <a:rPr dirty="0"/>
               <a:t>•  Show every intermediate structure, so the automata-theory constructions are visible, not hidden inside a black box.</a:t>
             </a:r>
           </a:p>
@@ -5191,7 +5169,7 @@
 </file>
 
 <file path=ppt/slides/slide3.xml><?xml version="1.0" encoding="utf-8"?>
-<p:sld xmlns:a="http://schemas.openxmlformats.org/drawingml/2006/main" xmlns:p="http://schemas.openxmlformats.org/presentationml/2006/main" xmlns:r="http://schemas.openxmlformats.org/officeDocument/2006/relationships">
+<p:sld xmlns:a="http://schemas.openxmlformats.org/drawingml/2006/main" xmlns:r="http://schemas.openxmlformats.org/officeDocument/2006/relationships" xmlns:p="http://schemas.openxmlformats.org/presentationml/2006/main">
   <p:cSld>
     <p:bg>
       <p:bgPr>
@@ -5207,7 +5185,14 @@
         <p:cNvGrpSpPr/>
         <p:nvPr/>
       </p:nvGrpSpPr>
-      <p:grpSpPr/>
+      <p:grpSpPr>
+        <a:xfrm>
+          <a:off x="0" y="0"/>
+          <a:ext cx="0" cy="0"/>
+          <a:chOff x="0" y="0"/>
+          <a:chExt cx="0" cy="0"/>
+        </a:xfrm>
+      </p:grpSpPr>
       <p:sp>
         <p:nvSpPr>
           <p:cNvPr id="2" name="TextBox 1"/>
@@ -5225,7 +5210,7 @@
           <a:noFill/>
         </p:spPr>
         <p:txBody>
-          <a:bodyPr wrap="none" lIns="0" rIns="0" tIns="0" bIns="0">
+          <a:bodyPr wrap="none" lIns="0" tIns="0" rIns="0" bIns="0">
             <a:spAutoFit/>
           </a:bodyPr>
           <a:lstStyle/>
@@ -5351,7 +5336,7 @@
           </a:fontRef>
         </p:style>
         <p:txBody>
-          <a:bodyPr rtlCol="0" anchor="ctr" wrap="square" lIns="50800" rIns="50800" tIns="25400" bIns="25400"/>
+          <a:bodyPr wrap="square" lIns="50800" tIns="25400" rIns="50800" bIns="25400" rtlCol="0" anchor="ctr"/>
           <a:lstStyle/>
           <a:p>
             <a:pPr algn="ctr"/>
@@ -5418,7 +5403,7 @@
           </a:fontRef>
         </p:style>
         <p:txBody>
-          <a:bodyPr rtlCol="0" anchor="ctr" wrap="square" lIns="50800" rIns="50800" tIns="25400" bIns="25400"/>
+          <a:bodyPr wrap="square" lIns="50800" tIns="25400" rIns="50800" bIns="25400" rtlCol="0" anchor="ctr"/>
           <a:lstStyle/>
           <a:p>
             <a:pPr algn="ctr"/>
@@ -5473,7 +5458,7 @@
           </a:fontRef>
         </p:style>
         <p:txBody>
-          <a:bodyPr rtlCol="0" anchor="ctr" wrap="square" lIns="50800" rIns="50800" tIns="25400" bIns="25400"/>
+          <a:bodyPr wrap="square" lIns="50800" tIns="25400" rIns="50800" bIns="25400" rtlCol="0" anchor="ctr"/>
           <a:lstStyle/>
           <a:p>
             <a:pPr algn="ctr"/>
@@ -5528,7 +5513,7 @@
           </a:fontRef>
         </p:style>
         <p:txBody>
-          <a:bodyPr rtlCol="0" anchor="ctr" wrap="square" lIns="50800" rIns="50800" tIns="25400" bIns="25400"/>
+          <a:bodyPr wrap="square" lIns="50800" tIns="25400" rIns="50800" bIns="25400" rtlCol="0" anchor="ctr"/>
           <a:lstStyle/>
           <a:p>
             <a:pPr algn="ctr"/>
@@ -5595,7 +5580,7 @@
           </a:fontRef>
         </p:style>
         <p:txBody>
-          <a:bodyPr rtlCol="0" anchor="ctr" wrap="square" lIns="50800" rIns="50800" tIns="25400" bIns="25400"/>
+          <a:bodyPr wrap="square" lIns="50800" tIns="25400" rIns="50800" bIns="25400" rtlCol="0" anchor="ctr"/>
           <a:lstStyle/>
           <a:p>
             <a:pPr algn="ctr"/>
@@ -5650,7 +5635,7 @@
           </a:fontRef>
         </p:style>
         <p:txBody>
-          <a:bodyPr rtlCol="0" anchor="ctr" wrap="square" lIns="50800" rIns="50800" tIns="25400" bIns="25400"/>
+          <a:bodyPr wrap="square" lIns="50800" tIns="25400" rIns="50800" bIns="25400" rtlCol="0" anchor="ctr"/>
           <a:lstStyle/>
           <a:p>
             <a:pPr algn="ctr"/>
@@ -5897,7 +5882,7 @@
           </a:fontRef>
         </p:style>
         <p:txBody>
-          <a:bodyPr rtlCol="0" anchor="ctr" wrap="square" lIns="50800" rIns="50800" tIns="25400" bIns="25400"/>
+          <a:bodyPr wrap="square" lIns="50800" tIns="25400" rIns="50800" bIns="25400" rtlCol="0" anchor="ctr"/>
           <a:lstStyle/>
           <a:p>
             <a:pPr algn="ctr"/>
@@ -5952,7 +5937,7 @@
           </a:fontRef>
         </p:style>
         <p:txBody>
-          <a:bodyPr rtlCol="0" anchor="ctr" wrap="square" lIns="50800" rIns="50800" tIns="25400" bIns="25400"/>
+          <a:bodyPr wrap="square" lIns="50800" tIns="25400" rIns="50800" bIns="25400" rtlCol="0" anchor="ctr"/>
           <a:lstStyle/>
           <a:p>
             <a:pPr algn="ctr"/>
@@ -6019,7 +6004,7 @@
           </a:fontRef>
         </p:style>
         <p:txBody>
-          <a:bodyPr rtlCol="0" anchor="ctr" wrap="square" lIns="50800" rIns="50800" tIns="25400" bIns="25400"/>
+          <a:bodyPr wrap="square" lIns="50800" tIns="25400" rIns="50800" bIns="25400" rtlCol="0" anchor="ctr"/>
           <a:lstStyle/>
           <a:p>
             <a:pPr algn="ctr"/>
@@ -6074,7 +6059,7 @@
           </a:fontRef>
         </p:style>
         <p:txBody>
-          <a:bodyPr rtlCol="0" anchor="ctr" wrap="square" lIns="50800" rIns="50800" tIns="25400" bIns="25400"/>
+          <a:bodyPr wrap="square" lIns="50800" tIns="25400" rIns="50800" bIns="25400" rtlCol="0" anchor="ctr"/>
           <a:lstStyle/>
           <a:p>
             <a:pPr algn="ctr"/>
@@ -6129,7 +6114,7 @@
           </a:fontRef>
         </p:style>
         <p:txBody>
-          <a:bodyPr rtlCol="0" anchor="ctr" wrap="square" lIns="50800" rIns="50800" tIns="25400" bIns="25400"/>
+          <a:bodyPr wrap="square" lIns="50800" tIns="25400" rIns="50800" bIns="25400" rtlCol="0" anchor="ctr"/>
           <a:lstStyle/>
           <a:p>
             <a:pPr algn="ctr"/>
@@ -6446,7 +6431,7 @@
           </a:fontRef>
         </p:style>
         <p:txBody>
-          <a:bodyPr rtlCol="0" anchor="ctr" wrap="square" lIns="50800" rIns="50800" tIns="25400" bIns="25400"/>
+          <a:bodyPr wrap="square" lIns="50800" tIns="25400" rIns="50800" bIns="25400" rtlCol="0" anchor="ctr"/>
           <a:lstStyle/>
           <a:p>
             <a:pPr algn="ctr"/>
@@ -6590,7 +6575,7 @@
 </file>
 
 <file path=ppt/slides/slide4.xml><?xml version="1.0" encoding="utf-8"?>
-<p:sld xmlns:a="http://schemas.openxmlformats.org/drawingml/2006/main" xmlns:p="http://schemas.openxmlformats.org/presentationml/2006/main" xmlns:r="http://schemas.openxmlformats.org/officeDocument/2006/relationships">
+<p:sld xmlns:a="http://schemas.openxmlformats.org/drawingml/2006/main" xmlns:r="http://schemas.openxmlformats.org/officeDocument/2006/relationships" xmlns:p="http://schemas.openxmlformats.org/presentationml/2006/main">
   <p:cSld>
     <p:bg>
       <p:bgPr>
@@ -6606,7 +6591,14 @@
         <p:cNvGrpSpPr/>
         <p:nvPr/>
       </p:nvGrpSpPr>
-      <p:grpSpPr/>
+      <p:grpSpPr>
+        <a:xfrm>
+          <a:off x="0" y="0"/>
+          <a:ext cx="0" cy="0"/>
+          <a:chOff x="0" y="0"/>
+          <a:chExt cx="0" cy="0"/>
+        </a:xfrm>
+      </p:grpSpPr>
       <p:sp>
         <p:nvSpPr>
           <p:cNvPr id="2" name="TextBox 1"/>
@@ -6624,7 +6616,7 @@
           <a:noFill/>
         </p:spPr>
         <p:txBody>
-          <a:bodyPr wrap="none" lIns="0" rIns="0" tIns="0" bIns="0">
+          <a:bodyPr wrap="none" lIns="0" tIns="0" rIns="0" bIns="0">
             <a:spAutoFit/>
           </a:bodyPr>
           <a:lstStyle/>
@@ -6791,7 +6783,7 @@
           <p:nvPr/>
         </p:nvPicPr>
         <p:blipFill>
-          <a:blip r:embed="rId2"/>
+          <a:blip r:embed="rId3"/>
           <a:stretch>
             <a:fillRect/>
           </a:stretch>
@@ -6850,7 +6842,7 @@
 </file>
 
 <file path=ppt/slides/slide5.xml><?xml version="1.0" encoding="utf-8"?>
-<p:sld xmlns:a="http://schemas.openxmlformats.org/drawingml/2006/main" xmlns:p="http://schemas.openxmlformats.org/presentationml/2006/main" xmlns:r="http://schemas.openxmlformats.org/officeDocument/2006/relationships">
+<p:sld xmlns:a="http://schemas.openxmlformats.org/drawingml/2006/main" xmlns:r="http://schemas.openxmlformats.org/officeDocument/2006/relationships" xmlns:p="http://schemas.openxmlformats.org/presentationml/2006/main">
   <p:cSld>
     <p:bg>
       <p:bgPr>
@@ -6866,7 +6858,14 @@
         <p:cNvGrpSpPr/>
         <p:nvPr/>
       </p:nvGrpSpPr>
-      <p:grpSpPr/>
+      <p:grpSpPr>
+        <a:xfrm>
+          <a:off x="0" y="0"/>
+          <a:ext cx="0" cy="0"/>
+          <a:chOff x="0" y="0"/>
+          <a:chExt cx="0" cy="0"/>
+        </a:xfrm>
+      </p:grpSpPr>
       <p:sp>
         <p:nvSpPr>
           <p:cNvPr id="2" name="TextBox 1"/>
@@ -6884,7 +6883,7 @@
           <a:noFill/>
         </p:spPr>
         <p:txBody>
-          <a:bodyPr wrap="none" lIns="0" rIns="0" tIns="0" bIns="0">
+          <a:bodyPr wrap="none" lIns="0" tIns="0" rIns="0" bIns="0">
             <a:spAutoFit/>
           </a:bodyPr>
           <a:lstStyle/>
@@ -7051,7 +7050,7 @@
           <p:nvPr/>
         </p:nvPicPr>
         <p:blipFill>
-          <a:blip r:embed="rId2"/>
+          <a:blip r:embed="rId3"/>
           <a:stretch>
             <a:fillRect/>
           </a:stretch>
@@ -7110,7 +7109,7 @@
 </file>
 
 <file path=ppt/slides/slide6.xml><?xml version="1.0" encoding="utf-8"?>
-<p:sld xmlns:a="http://schemas.openxmlformats.org/drawingml/2006/main" xmlns:p="http://schemas.openxmlformats.org/presentationml/2006/main" xmlns:r="http://schemas.openxmlformats.org/officeDocument/2006/relationships">
+<p:sld xmlns:a="http://schemas.openxmlformats.org/drawingml/2006/main" xmlns:r="http://schemas.openxmlformats.org/officeDocument/2006/relationships" xmlns:p="http://schemas.openxmlformats.org/presentationml/2006/main">
   <p:cSld>
     <p:bg>
       <p:bgPr>
@@ -7126,7 +7125,14 @@
         <p:cNvGrpSpPr/>
         <p:nvPr/>
       </p:nvGrpSpPr>
-      <p:grpSpPr/>
+      <p:grpSpPr>
+        <a:xfrm>
+          <a:off x="0" y="0"/>
+          <a:ext cx="0" cy="0"/>
+          <a:chOff x="0" y="0"/>
+          <a:chExt cx="0" cy="0"/>
+        </a:xfrm>
+      </p:grpSpPr>
       <p:sp>
         <p:nvSpPr>
           <p:cNvPr id="2" name="TextBox 1"/>
@@ -7144,7 +7150,7 @@
           <a:noFill/>
         </p:spPr>
         <p:txBody>
-          <a:bodyPr wrap="none" lIns="0" rIns="0" tIns="0" bIns="0">
+          <a:bodyPr wrap="none" lIns="0" tIns="0" rIns="0" bIns="0">
             <a:spAutoFit/>
           </a:bodyPr>
           <a:lstStyle/>
@@ -7311,7 +7317,7 @@
           <p:nvPr/>
         </p:nvPicPr>
         <p:blipFill>
-          <a:blip r:embed="rId2"/>
+          <a:blip r:embed="rId3"/>
           <a:stretch>
             <a:fillRect/>
           </a:stretch>
@@ -7370,7 +7376,7 @@
 </file>
 
 <file path=ppt/slides/slide7.xml><?xml version="1.0" encoding="utf-8"?>
-<p:sld xmlns:a="http://schemas.openxmlformats.org/drawingml/2006/main" xmlns:p="http://schemas.openxmlformats.org/presentationml/2006/main" xmlns:r="http://schemas.openxmlformats.org/officeDocument/2006/relationships">
+<p:sld xmlns:a="http://schemas.openxmlformats.org/drawingml/2006/main" xmlns:r="http://schemas.openxmlformats.org/officeDocument/2006/relationships" xmlns:p="http://schemas.openxmlformats.org/presentationml/2006/main">
   <p:cSld>
     <p:bg>
       <p:bgPr>
@@ -7386,7 +7392,14 @@
         <p:cNvGrpSpPr/>
         <p:nvPr/>
       </p:nvGrpSpPr>
-      <p:grpSpPr/>
+      <p:grpSpPr>
+        <a:xfrm>
+          <a:off x="0" y="0"/>
+          <a:ext cx="0" cy="0"/>
+          <a:chOff x="0" y="0"/>
+          <a:chExt cx="0" cy="0"/>
+        </a:xfrm>
+      </p:grpSpPr>
       <p:sp>
         <p:nvSpPr>
           <p:cNvPr id="2" name="TextBox 1"/>
@@ -7404,7 +7417,7 @@
           <a:noFill/>
         </p:spPr>
         <p:txBody>
-          <a:bodyPr wrap="none" lIns="0" rIns="0" tIns="0" bIns="0">
+          <a:bodyPr wrap="none" lIns="0" tIns="0" rIns="0" bIns="0">
             <a:spAutoFit/>
           </a:bodyPr>
           <a:lstStyle/>
@@ -7571,7 +7584,7 @@
 </file>
 
 <file path=ppt/slides/slide8.xml><?xml version="1.0" encoding="utf-8"?>
-<p:sld xmlns:a="http://schemas.openxmlformats.org/drawingml/2006/main" xmlns:p="http://schemas.openxmlformats.org/presentationml/2006/main" xmlns:r="http://schemas.openxmlformats.org/officeDocument/2006/relationships">
+<p:sld xmlns:a="http://schemas.openxmlformats.org/drawingml/2006/main" xmlns:r="http://schemas.openxmlformats.org/officeDocument/2006/relationships" xmlns:p="http://schemas.openxmlformats.org/presentationml/2006/main">
   <p:cSld>
     <p:bg>
       <p:bgPr>
@@ -7587,7 +7600,14 @@
         <p:cNvGrpSpPr/>
         <p:nvPr/>
       </p:nvGrpSpPr>
-      <p:grpSpPr/>
+      <p:grpSpPr>
+        <a:xfrm>
+          <a:off x="0" y="0"/>
+          <a:ext cx="0" cy="0"/>
+          <a:chOff x="0" y="0"/>
+          <a:chExt cx="0" cy="0"/>
+        </a:xfrm>
+      </p:grpSpPr>
       <p:sp>
         <p:nvSpPr>
           <p:cNvPr id="2" name="TextBox 1"/>
@@ -7605,7 +7625,7 @@
           <a:noFill/>
         </p:spPr>
         <p:txBody>
-          <a:bodyPr wrap="none" lIns="0" rIns="0" tIns="0" bIns="0">
+          <a:bodyPr wrap="none" lIns="0" tIns="0" rIns="0" bIns="0">
             <a:spAutoFit/>
           </a:bodyPr>
           <a:lstStyle/>
@@ -7750,65 +7770,6 @@
       <p:pic>
         <p:nvPicPr>
           <p:cNvPr id="6" name="Picture 5" descr="04-mindfa-accepted.png"/>
-          <p:cNvPicPr>
-            <a:picLocks noChangeAspect="1"/>
-          </p:cNvPicPr>
-          <p:nvPr/>
-        </p:nvPicPr>
-        <p:blipFill>
-          <a:blip r:embed="rId2"/>
-          <a:stretch>
-            <a:fillRect/>
-          </a:stretch>
-        </p:blipFill>
-        <p:spPr>
-          <a:xfrm>
-            <a:off x="457200" y="2103120"/>
-            <a:ext cx="3685597" cy="4206240"/>
-          </a:xfrm>
-          <a:prstGeom prst="rect">
-            <a:avLst/>
-          </a:prstGeom>
-        </p:spPr>
-      </p:pic>
-      <p:sp>
-        <p:nvSpPr>
-          <p:cNvPr id="7" name="TextBox 6"/>
-          <p:cNvSpPr txBox="1"/>
-          <p:nvPr/>
-        </p:nvSpPr>
-        <p:spPr>
-          <a:xfrm>
-            <a:off x="457200" y="6355079"/>
-            <a:ext cx="5394960" cy="320040"/>
-          </a:xfrm>
-          <a:prstGeom prst="rect">
-            <a:avLst/>
-          </a:prstGeom>
-          <a:noFill/>
-        </p:spPr>
-        <p:txBody>
-          <a:bodyPr wrap="none">
-            <a:spAutoFit/>
-          </a:bodyPr>
-          <a:lstStyle/>
-          <a:p>
-            <a:pPr algn="ctr"/>
-            <a:r>
-              <a:rPr sz="1200" i="1">
-                <a:solidFill>
-                  <a:srgbClr val="606060"/>
-                </a:solidFill>
-                <a:latin typeface="Arial"/>
-              </a:rPr>
-              <a:t>Fig. 4a. babb ends in abb: Accepted.</a:t>
-            </a:r>
-          </a:p>
-        </p:txBody>
-      </p:sp>
-      <p:pic>
-        <p:nvPicPr>
-          <p:cNvPr id="8" name="Picture 7" descr="05-mindfa-rejected.png"/>
           <p:cNvPicPr>
             <a:picLocks noChangeAspect="1"/>
           </p:cNvPicPr>
@@ -7822,6 +7783,65 @@
         </p:blipFill>
         <p:spPr>
           <a:xfrm>
+            <a:off x="457200" y="2103120"/>
+            <a:ext cx="3685597" cy="4206240"/>
+          </a:xfrm>
+          <a:prstGeom prst="rect">
+            <a:avLst/>
+          </a:prstGeom>
+        </p:spPr>
+      </p:pic>
+      <p:sp>
+        <p:nvSpPr>
+          <p:cNvPr id="7" name="TextBox 6"/>
+          <p:cNvSpPr txBox="1"/>
+          <p:nvPr/>
+        </p:nvSpPr>
+        <p:spPr>
+          <a:xfrm>
+            <a:off x="457200" y="6355079"/>
+            <a:ext cx="5394960" cy="320040"/>
+          </a:xfrm>
+          <a:prstGeom prst="rect">
+            <a:avLst/>
+          </a:prstGeom>
+          <a:noFill/>
+        </p:spPr>
+        <p:txBody>
+          <a:bodyPr wrap="none">
+            <a:spAutoFit/>
+          </a:bodyPr>
+          <a:lstStyle/>
+          <a:p>
+            <a:pPr algn="ctr"/>
+            <a:r>
+              <a:rPr sz="1200" i="1">
+                <a:solidFill>
+                  <a:srgbClr val="606060"/>
+                </a:solidFill>
+                <a:latin typeface="Arial"/>
+              </a:rPr>
+              <a:t>Fig. 4a. babb ends in abb: Accepted.</a:t>
+            </a:r>
+          </a:p>
+        </p:txBody>
+      </p:sp>
+      <p:pic>
+        <p:nvPicPr>
+          <p:cNvPr id="8" name="Picture 7" descr="05-mindfa-rejected.png"/>
+          <p:cNvPicPr>
+            <a:picLocks noChangeAspect="1"/>
+          </p:cNvPicPr>
+          <p:nvPr/>
+        </p:nvPicPr>
+        <p:blipFill>
+          <a:blip r:embed="rId4"/>
+          <a:stretch>
+            <a:fillRect/>
+          </a:stretch>
+        </p:blipFill>
+        <p:spPr>
+          <a:xfrm>
             <a:off x="6217920" y="2103120"/>
             <a:ext cx="3685597" cy="4206240"/>
           </a:xfrm>
@@ -7874,7 +7894,7 @@
 </file>
 
 <file path=ppt/slides/slide9.xml><?xml version="1.0" encoding="utf-8"?>
-<p:sld xmlns:a="http://schemas.openxmlformats.org/drawingml/2006/main" xmlns:p="http://schemas.openxmlformats.org/presentationml/2006/main" xmlns:r="http://schemas.openxmlformats.org/officeDocument/2006/relationships">
+<p:sld xmlns:a="http://schemas.openxmlformats.org/drawingml/2006/main" xmlns:r="http://schemas.openxmlformats.org/officeDocument/2006/relationships" xmlns:p="http://schemas.openxmlformats.org/presentationml/2006/main">
   <p:cSld>
     <p:bg>
       <p:bgPr>
@@ -7890,7 +7910,14 @@
         <p:cNvGrpSpPr/>
         <p:nvPr/>
       </p:nvGrpSpPr>
-      <p:grpSpPr/>
+      <p:grpSpPr>
+        <a:xfrm>
+          <a:off x="0" y="0"/>
+          <a:ext cx="0" cy="0"/>
+          <a:chOff x="0" y="0"/>
+          <a:chExt cx="0" cy="0"/>
+        </a:xfrm>
+      </p:grpSpPr>
       <p:sp>
         <p:nvSpPr>
           <p:cNvPr id="2" name="TextBox 1"/>
@@ -7908,7 +7935,7 @@
           <a:noFill/>
         </p:spPr>
         <p:txBody>
-          <a:bodyPr wrap="none" lIns="0" rIns="0" tIns="0" bIns="0">
+          <a:bodyPr wrap="none" lIns="0" tIns="0" rIns="0" bIns="0">
             <a:spAutoFit/>
           </a:bodyPr>
           <a:lstStyle/>
@@ -7935,7 +7962,7 @@
         <p:spPr>
           <a:xfrm>
             <a:off x="457200" y="274320"/>
-            <a:ext cx="9601200" cy="640080"/>
+            <a:ext cx="5069658" cy="477054"/>
           </a:xfrm>
           <a:prstGeom prst="rect">
             <a:avLst/>
@@ -7949,13 +7976,22 @@
           <a:lstStyle/>
           <a:p>
             <a:r>
-              <a:rPr sz="2800" b="1">
+              <a:rPr sz="2800" b="1" dirty="0">
                 <a:solidFill>
                   <a:srgbClr val="000000"/>
                 </a:solidFill>
                 <a:latin typeface="Arial"/>
               </a:rPr>
-              <a:t>Step Playback (issue #52)</a:t>
+              <a:t>Step Playback </a:t>
+            </a:r>
+            <a:r>
+              <a:rPr lang="en-US" sz="2800" b="1" dirty="0">
+                <a:solidFill>
+                  <a:srgbClr val="000000"/>
+                </a:solidFill>
+                <a:latin typeface="Arial"/>
+              </a:rPr>
+              <a:t>for each stage</a:t>
             </a:r>
           </a:p>
         </p:txBody>
@@ -8029,6 +8065,7 @@
               </a:defRPr>
             </a:pPr>
             <a:r>
+              <a:rPr dirty="0"/>
               <a:t>•  All four tabs have real, stage-specific playback, not just min-DFA scrubbing.</a:t>
             </a:r>
           </a:p>
@@ -8045,6 +8082,7 @@
               </a:defRPr>
             </a:pPr>
             <a:r>
+              <a:rPr dirty="0"/>
               <a:t>•  NFA shows the FULL active-state set and highlights every traversed edge, epsilon included.</a:t>
             </a:r>
           </a:p>
@@ -8061,6 +8099,7 @@
               </a:defRPr>
             </a:pPr>
             <a:r>
+              <a:rPr dirty="0"/>
               <a:t>•  AST steps through the tree in Thompson's-construction order, with a caption naming the rule.</a:t>
             </a:r>
           </a:p>
@@ -8075,7 +8114,7 @@
           <p:nvPr/>
         </p:nvPicPr>
         <p:blipFill>
-          <a:blip r:embed="rId2"/>
+          <a:blip r:embed="rId3"/>
           <a:stretch>
             <a:fillRect/>
           </a:stretch>
@@ -8464,44 +8503,44 @@
         <a:sysClr val="window" lastClr="FFFFFF"/>
       </a:lt1>
       <a:dk2>
-        <a:srgbClr val="1F497D"/>
+        <a:srgbClr val="44546A"/>
       </a:dk2>
       <a:lt2>
-        <a:srgbClr val="EEECE1"/>
+        <a:srgbClr val="E7E6E6"/>
       </a:lt2>
       <a:accent1>
-        <a:srgbClr val="4F81BD"/>
+        <a:srgbClr val="4472C4"/>
       </a:accent1>
       <a:accent2>
-        <a:srgbClr val="C0504D"/>
+        <a:srgbClr val="ED7D31"/>
       </a:accent2>
       <a:accent3>
-        <a:srgbClr val="9BBB59"/>
+        <a:srgbClr val="A5A5A5"/>
       </a:accent3>
       <a:accent4>
-        <a:srgbClr val="8064A2"/>
+        <a:srgbClr val="FFC000"/>
       </a:accent4>
       <a:accent5>
-        <a:srgbClr val="4BACC6"/>
+        <a:srgbClr val="5B9BD5"/>
       </a:accent5>
       <a:accent6>
-        <a:srgbClr val="F79646"/>
+        <a:srgbClr val="70AD47"/>
       </a:accent6>
       <a:hlink>
-        <a:srgbClr val="0000FF"/>
+        <a:srgbClr val="0563C1"/>
       </a:hlink>
       <a:folHlink>
-        <a:srgbClr val="800080"/>
+        <a:srgbClr val="954F72"/>
       </a:folHlink>
     </a:clrScheme>
     <a:fontScheme name="Office">
       <a:majorFont>
-        <a:latin typeface="Calibri"/>
+        <a:latin typeface="Calibri Light" panose="020F0302020204030204"/>
         <a:ea typeface=""/>
         <a:cs typeface=""/>
-        <a:font script="Jpan" typeface="ＭＳ Ｐゴシック"/>
+        <a:font script="Jpan" typeface="游ゴシック Light"/>
         <a:font script="Hang" typeface="맑은 고딕"/>
-        <a:font script="Hans" typeface="宋体"/>
+        <a:font script="Hans" typeface="等线 Light"/>
         <a:font script="Hant" typeface="新細明體"/>
         <a:font script="Arab" typeface="Times New Roman"/>
         <a:font script="Hebr" typeface="Times New Roman"/>
@@ -8529,14 +8568,31 @@
         <a:font script="Viet" typeface="Times New Roman"/>
         <a:font script="Uigh" typeface="Microsoft Uighur"/>
         <a:font script="Geor" typeface="Sylfaen"/>
+        <a:font script="Armn" typeface="Arial"/>
+        <a:font script="Bugi" typeface="Leelawadee UI"/>
+        <a:font script="Bopo" typeface="Microsoft JhengHei"/>
+        <a:font script="Java" typeface="Javanese Text"/>
+        <a:font script="Lisu" typeface="Segoe UI"/>
+        <a:font script="Mymr" typeface="Myanmar Text"/>
+        <a:font script="Nkoo" typeface="Ebrima"/>
+        <a:font script="Olck" typeface="Nirmala UI"/>
+        <a:font script="Osma" typeface="Ebrima"/>
+        <a:font script="Phag" typeface="Phagspa"/>
+        <a:font script="Syrn" typeface="Estrangelo Edessa"/>
+        <a:font script="Syrj" typeface="Estrangelo Edessa"/>
+        <a:font script="Syre" typeface="Estrangelo Edessa"/>
+        <a:font script="Sora" typeface="Nirmala UI"/>
+        <a:font script="Tale" typeface="Microsoft Tai Le"/>
+        <a:font script="Talu" typeface="Microsoft New Tai Lue"/>
+        <a:font script="Tfng" typeface="Ebrima"/>
       </a:majorFont>
       <a:minorFont>
-        <a:latin typeface="Calibri"/>
+        <a:latin typeface="Calibri" panose="020F0502020204030204"/>
         <a:ea typeface=""/>
         <a:cs typeface=""/>
-        <a:font script="Jpan" typeface="ＭＳ Ｐゴシック"/>
+        <a:font script="Jpan" typeface="游ゴシック"/>
         <a:font script="Hang" typeface="맑은 고딕"/>
-        <a:font script="Hans" typeface="宋体"/>
+        <a:font script="Hans" typeface="等线"/>
         <a:font script="Hant" typeface="新細明體"/>
         <a:font script="Arab" typeface="Arial"/>
         <a:font script="Hebr" typeface="Arial"/>
@@ -8564,6 +8620,23 @@
         <a:font script="Viet" typeface="Arial"/>
         <a:font script="Uigh" typeface="Microsoft Uighur"/>
         <a:font script="Geor" typeface="Sylfaen"/>
+        <a:font script="Armn" typeface="Arial"/>
+        <a:font script="Bugi" typeface="Leelawadee UI"/>
+        <a:font script="Bopo" typeface="Microsoft JhengHei"/>
+        <a:font script="Java" typeface="Javanese Text"/>
+        <a:font script="Lisu" typeface="Segoe UI"/>
+        <a:font script="Mymr" typeface="Myanmar Text"/>
+        <a:font script="Nkoo" typeface="Ebrima"/>
+        <a:font script="Olck" typeface="Nirmala UI"/>
+        <a:font script="Osma" typeface="Ebrima"/>
+        <a:font script="Phag" typeface="Phagspa"/>
+        <a:font script="Syrn" typeface="Estrangelo Edessa"/>
+        <a:font script="Syrj" typeface="Estrangelo Edessa"/>
+        <a:font script="Syre" typeface="Estrangelo Edessa"/>
+        <a:font script="Sora" typeface="Nirmala UI"/>
+        <a:font script="Tale" typeface="Microsoft Tai Le"/>
+        <a:font script="Talu" typeface="Microsoft New Tai Lue"/>
+        <a:font script="Tfng" typeface="Ebrima"/>
       </a:minorFont>
     </a:fontScheme>
     <a:fmtScheme name="Office">
@@ -8575,200 +8648,141 @@
           <a:gsLst>
             <a:gs pos="0">
               <a:schemeClr val="phClr">
-                <a:tint val="50000"/>
-                <a:satMod val="300000"/>
+                <a:lumMod val="110000"/>
+                <a:satMod val="105000"/>
+                <a:tint val="67000"/>
               </a:schemeClr>
             </a:gs>
-            <a:gs pos="35000">
+            <a:gs pos="50000">
               <a:schemeClr val="phClr">
-                <a:tint val="37000"/>
-                <a:satMod val="300000"/>
+                <a:lumMod val="105000"/>
+                <a:satMod val="103000"/>
+                <a:tint val="73000"/>
               </a:schemeClr>
             </a:gs>
             <a:gs pos="100000">
               <a:schemeClr val="phClr">
-                <a:tint val="15000"/>
-                <a:satMod val="350000"/>
+                <a:lumMod val="105000"/>
+                <a:satMod val="109000"/>
+                <a:tint val="81000"/>
               </a:schemeClr>
             </a:gs>
           </a:gsLst>
-          <a:lin ang="16200000" scaled="1"/>
+          <a:lin ang="5400000" scaled="0"/>
         </a:gradFill>
         <a:gradFill rotWithShape="1">
           <a:gsLst>
             <a:gs pos="0">
               <a:schemeClr val="phClr">
-                <a:tint val="100000"/>
+                <a:satMod val="103000"/>
+                <a:lumMod val="102000"/>
+                <a:tint val="94000"/>
+              </a:schemeClr>
+            </a:gs>
+            <a:gs pos="50000">
+              <a:schemeClr val="phClr">
+                <a:satMod val="110000"/>
+                <a:lumMod val="100000"/>
                 <a:shade val="100000"/>
-                <a:satMod val="130000"/>
               </a:schemeClr>
             </a:gs>
             <a:gs pos="100000">
               <a:schemeClr val="phClr">
-                <a:tint val="50000"/>
-                <a:shade val="100000"/>
-                <a:satMod val="350000"/>
+                <a:lumMod val="99000"/>
+                <a:satMod val="120000"/>
+                <a:shade val="78000"/>
               </a:schemeClr>
             </a:gs>
           </a:gsLst>
-          <a:lin ang="16200000" scaled="0"/>
+          <a:lin ang="5400000" scaled="0"/>
         </a:gradFill>
       </a:fillStyleLst>
       <a:lnStyleLst>
-        <a:ln w="9525" cap="flat" cmpd="sng" algn="ctr">
-          <a:solidFill>
-            <a:schemeClr val="phClr">
-              <a:shade val="95000"/>
-              <a:satMod val="105000"/>
-            </a:schemeClr>
-          </a:solidFill>
-          <a:prstDash val="solid"/>
-        </a:ln>
-        <a:ln w="25400" cap="flat" cmpd="sng" algn="ctr">
+        <a:ln w="6350" cap="flat" cmpd="sng" algn="ctr">
           <a:solidFill>
             <a:schemeClr val="phClr"/>
           </a:solidFill>
           <a:prstDash val="solid"/>
+          <a:miter lim="800000"/>
         </a:ln>
-        <a:ln w="38100" cap="flat" cmpd="sng" algn="ctr">
+        <a:ln w="12700" cap="flat" cmpd="sng" algn="ctr">
           <a:solidFill>
             <a:schemeClr val="phClr"/>
           </a:solidFill>
           <a:prstDash val="solid"/>
+          <a:miter lim="800000"/>
+        </a:ln>
+        <a:ln w="19050" cap="flat" cmpd="sng" algn="ctr">
+          <a:solidFill>
+            <a:schemeClr val="phClr"/>
+          </a:solidFill>
+          <a:prstDash val="solid"/>
+          <a:miter lim="800000"/>
         </a:ln>
       </a:lnStyleLst>
       <a:effectStyleLst>
         <a:effectStyle>
+          <a:effectLst/>
+        </a:effectStyle>
+        <a:effectStyle>
+          <a:effectLst/>
+        </a:effectStyle>
+        <a:effectStyle>
           <a:effectLst>
-            <a:outerShdw blurRad="40000" dist="20000" dir="5400000" rotWithShape="0">
+            <a:outerShdw blurRad="57150" dist="19050" dir="5400000" algn="ctr" rotWithShape="0">
               <a:srgbClr val="000000">
-                <a:alpha val="38000"/>
+                <a:alpha val="63000"/>
               </a:srgbClr>
             </a:outerShdw>
           </a:effectLst>
-        </a:effectStyle>
-        <a:effectStyle>
-          <a:effectLst>
-            <a:outerShdw blurRad="40000" dist="23000" dir="5400000" rotWithShape="0">
-              <a:srgbClr val="000000">
-                <a:alpha val="35000"/>
-              </a:srgbClr>
-            </a:outerShdw>
-          </a:effectLst>
-        </a:effectStyle>
-        <a:effectStyle>
-          <a:effectLst>
-            <a:outerShdw blurRad="40000" dist="23000" dir="5400000" rotWithShape="0">
-              <a:srgbClr val="000000">
-                <a:alpha val="35000"/>
-              </a:srgbClr>
-            </a:outerShdw>
-          </a:effectLst>
-          <a:scene3d>
-            <a:camera prst="orthographicFront">
-              <a:rot lat="0" lon="0" rev="0"/>
-            </a:camera>
-            <a:lightRig rig="threePt" dir="t">
-              <a:rot lat="0" lon="0" rev="1200000"/>
-            </a:lightRig>
-          </a:scene3d>
-          <a:sp3d>
-            <a:bevelT w="63500" h="25400"/>
-          </a:sp3d>
         </a:effectStyle>
       </a:effectStyleLst>
       <a:bgFillStyleLst>
         <a:solidFill>
           <a:schemeClr val="phClr"/>
         </a:solidFill>
+        <a:solidFill>
+          <a:schemeClr val="phClr">
+            <a:tint val="95000"/>
+            <a:satMod val="170000"/>
+          </a:schemeClr>
+        </a:solidFill>
         <a:gradFill rotWithShape="1">
           <a:gsLst>
             <a:gs pos="0">
               <a:schemeClr val="phClr">
-                <a:tint val="40000"/>
-                <a:satMod val="350000"/>
+                <a:tint val="93000"/>
+                <a:satMod val="150000"/>
+                <a:shade val="98000"/>
+                <a:lumMod val="102000"/>
               </a:schemeClr>
             </a:gs>
-            <a:gs pos="40000">
+            <a:gs pos="50000">
               <a:schemeClr val="phClr">
-                <a:tint val="45000"/>
-                <a:shade val="99000"/>
-                <a:satMod val="350000"/>
+                <a:tint val="98000"/>
+                <a:satMod val="130000"/>
+                <a:shade val="90000"/>
+                <a:lumMod val="103000"/>
               </a:schemeClr>
             </a:gs>
             <a:gs pos="100000">
               <a:schemeClr val="phClr">
-                <a:shade val="20000"/>
-                <a:satMod val="255000"/>
+                <a:shade val="63000"/>
+                <a:satMod val="120000"/>
               </a:schemeClr>
             </a:gs>
           </a:gsLst>
-          <a:path path="circle">
-            <a:fillToRect l="50000" t="-80000" r="50000" b="180000"/>
-          </a:path>
-        </a:gradFill>
-        <a:gradFill rotWithShape="1">
-          <a:gsLst>
-            <a:gs pos="0">
-              <a:schemeClr val="phClr">
-                <a:tint val="80000"/>
-                <a:satMod val="300000"/>
-              </a:schemeClr>
-            </a:gs>
-            <a:gs pos="100000">
-              <a:schemeClr val="phClr">
-                <a:shade val="30000"/>
-                <a:satMod val="200000"/>
-              </a:schemeClr>
-            </a:gs>
-          </a:gsLst>
-          <a:path path="circle">
-            <a:fillToRect l="50000" t="50000" r="50000" b="50000"/>
-          </a:path>
+          <a:lin ang="5400000" scaled="0"/>
         </a:gradFill>
       </a:bgFillStyleLst>
     </a:fmtScheme>
   </a:themeElements>
-  <a:objectDefaults>
-    <a:spDef>
-      <a:spPr/>
-      <a:bodyPr/>
-      <a:lstStyle/>
-      <a:style>
-        <a:lnRef idx="1">
-          <a:schemeClr val="accent1"/>
-        </a:lnRef>
-        <a:fillRef idx="3">
-          <a:schemeClr val="accent1"/>
-        </a:fillRef>
-        <a:effectRef idx="2">
-          <a:schemeClr val="accent1"/>
-        </a:effectRef>
-        <a:fontRef idx="minor">
-          <a:schemeClr val="lt1"/>
-        </a:fontRef>
-      </a:style>
-    </a:spDef>
-    <a:lnDef>
-      <a:spPr/>
-      <a:bodyPr/>
-      <a:lstStyle/>
-      <a:style>
-        <a:lnRef idx="2">
-          <a:schemeClr val="accent1"/>
-        </a:lnRef>
-        <a:fillRef idx="0">
-          <a:schemeClr val="accent1"/>
-        </a:fillRef>
-        <a:effectRef idx="1">
-          <a:schemeClr val="accent1"/>
-        </a:effectRef>
-        <a:fontRef idx="minor">
-          <a:schemeClr val="tx1"/>
-        </a:fontRef>
-      </a:style>
-    </a:lnDef>
-  </a:objectDefaults>
+  <a:objectDefaults/>
   <a:extraClrSchemeLst/>
+  <a:extLst>
+    <a:ext uri="{05A4C25C-085E-4340-85A3-A5531E510DB2}">
+      <thm15:themeFamily xmlns:thm15="http://schemas.microsoft.com/office/thememl/2012/main" name="Office Theme" id="{62F939B6-93AF-4DB8-9C6B-D6C7DFDC589F}" vid="{4A3C46E8-61CC-4603-A589-7422A47A8E4A}"/>
+    </a:ext>
+  </a:extLst>
 </a:theme>
 </file>
</xml_diff>